<commit_message>
sync(workvault): 2026-10-23 08:50 差分 9 件
</commit_message>
<xml_diff>
--- a/workvault-sync/10_業務全般/業務報告/9月業務報告(篠原).pptx
+++ b/workvault-sync/10_業務全般/業務報告/9月業務報告(篠原).pptx
@@ -117,998 +117,46 @@
 </p:presentation>
 </file>
 
-<file path=ppt/revisionInfo.xml><?xml version="1.0" encoding="utf-8"?>
-<p1510:revInfo xmlns:a="http://schemas.openxmlformats.org/drawingml/2006/main" xmlns:r="http://schemas.openxmlformats.org/officeDocument/2006/relationships" xmlns:p1510="http://schemas.microsoft.com/office/powerpoint/2015/10/main">
-  <p1510:revLst>
-    <p1510:client id="{A13B977E-83BD-4364-9C7A-8EA8A549CE76}" v="67" dt="2026-09-18T06:10:57.359"/>
-  </p1510:revLst>
-</p1510:revInfo>
-</file>
-
 <file path=ppt/changesInfos/changesInfo1.xml><?xml version="1.0" encoding="utf-8"?>
 <pc:chgInfo xmlns:a="http://schemas.openxmlformats.org/drawingml/2006/main" xmlns:r="http://schemas.openxmlformats.org/officeDocument/2006/relationships" xmlns:ac="http://schemas.microsoft.com/office/drawing/2013/main/command" xmlns:pc="http://schemas.microsoft.com/office/powerpoint/2013/main/command">
   <pc:docChgLst>
     <pc:chgData name="SHINOHARA Soshi (篠原 想詩)" userId="309c0b21-8b61-4cd5-9d32-07652c56306e" providerId="ADAL" clId="{60D42A6B-AE32-4A06-B461-AA9486421C3B}"/>
     <pc:docChg chg="undo custSel addSld delSld modSld sldOrd delMainMaster">
-      <pc:chgData name="SHINOHARA Soshi (篠原 想詩)" userId="309c0b21-8b61-4cd5-9d32-07652c56306e" providerId="ADAL" clId="{60D42A6B-AE32-4A06-B461-AA9486421C3B}" dt="2026-09-18T07:27:41.343" v="2583" actId="20577"/>
+      <pc:chgData name="SHINOHARA Soshi (篠原 想詩)" userId="309c0b21-8b61-4cd5-9d32-07652c56306e" providerId="ADAL" clId="{60D42A6B-AE32-4A06-B461-AA9486421C3B}" dt="2026-10-22T09:43:08.253" v="2636" actId="1076"/>
       <pc:docMkLst>
         <pc:docMk/>
       </pc:docMkLst>
-      <pc:sldChg chg="del">
-        <pc:chgData name="SHINOHARA Soshi (篠原 想詩)" userId="309c0b21-8b61-4cd5-9d32-07652c56306e" providerId="ADAL" clId="{60D42A6B-AE32-4A06-B461-AA9486421C3B}" dt="2026-09-18T06:09:00.715" v="2395" actId="47"/>
-        <pc:sldMkLst>
-          <pc:docMk/>
-          <pc:sldMk cId="2775494873" sldId="256"/>
-        </pc:sldMkLst>
-      </pc:sldChg>
-      <pc:sldChg chg="addSp delSp modSp new del mod">
-        <pc:chgData name="SHINOHARA Soshi (篠原 想詩)" userId="309c0b21-8b61-4cd5-9d32-07652c56306e" providerId="ADAL" clId="{60D42A6B-AE32-4A06-B461-AA9486421C3B}" dt="2026-09-18T06:09:01.320" v="2396" actId="47"/>
-        <pc:sldMkLst>
-          <pc:docMk/>
-          <pc:sldMk cId="2238980019" sldId="257"/>
-        </pc:sldMkLst>
-        <pc:spChg chg="del">
-          <ac:chgData name="SHINOHARA Soshi (篠原 想詩)" userId="309c0b21-8b61-4cd5-9d32-07652c56306e" providerId="ADAL" clId="{60D42A6B-AE32-4A06-B461-AA9486421C3B}" dt="2026-09-18T05:11:48.559" v="2" actId="478"/>
-          <ac:spMkLst>
-            <pc:docMk/>
-            <pc:sldMk cId="2238980019" sldId="257"/>
-            <ac:spMk id="2" creationId="{394D9B7B-7D5B-7DBA-ABDB-D47E65809127}"/>
-          </ac:spMkLst>
-        </pc:spChg>
-        <pc:spChg chg="del">
-          <ac:chgData name="SHINOHARA Soshi (篠原 想詩)" userId="309c0b21-8b61-4cd5-9d32-07652c56306e" providerId="ADAL" clId="{60D42A6B-AE32-4A06-B461-AA9486421C3B}" dt="2026-09-18T05:11:47.940" v="1" actId="478"/>
-          <ac:spMkLst>
-            <pc:docMk/>
-            <pc:sldMk cId="2238980019" sldId="257"/>
-            <ac:spMk id="3" creationId="{26DF8E07-B2DA-7105-C165-EE27C7BA2409}"/>
-          </ac:spMkLst>
-        </pc:spChg>
-        <pc:graphicFrameChg chg="add del mod">
-          <ac:chgData name="SHINOHARA Soshi (篠原 想詩)" userId="309c0b21-8b61-4cd5-9d32-07652c56306e" providerId="ADAL" clId="{60D42A6B-AE32-4A06-B461-AA9486421C3B}" dt="2026-09-18T05:12:05.751" v="5" actId="478"/>
-          <ac:graphicFrameMkLst>
-            <pc:docMk/>
-            <pc:sldMk cId="2238980019" sldId="257"/>
-            <ac:graphicFrameMk id="4" creationId="{492B0FED-8F60-8C69-B5F2-5450775EA0FF}"/>
-          </ac:graphicFrameMkLst>
-        </pc:graphicFrameChg>
-      </pc:sldChg>
-      <pc:sldChg chg="addSp delSp modSp add del mod">
-        <pc:chgData name="SHINOHARA Soshi (篠原 想詩)" userId="309c0b21-8b61-4cd5-9d32-07652c56306e" providerId="ADAL" clId="{60D42A6B-AE32-4A06-B461-AA9486421C3B}" dt="2026-09-18T05:52:20.736" v="1612" actId="20577"/>
-        <pc:sldMkLst>
-          <pc:docMk/>
-          <pc:sldMk cId="0" sldId="258"/>
-        </pc:sldMkLst>
-        <pc:spChg chg="add del mod">
-          <ac:chgData name="SHINOHARA Soshi (篠原 想詩)" userId="309c0b21-8b61-4cd5-9d32-07652c56306e" providerId="ADAL" clId="{60D42A6B-AE32-4A06-B461-AA9486421C3B}" dt="2026-09-18T05:15:21.052" v="58" actId="21"/>
-          <ac:spMkLst>
-            <pc:docMk/>
-            <pc:sldMk cId="0" sldId="258"/>
-            <ac:spMk id="2" creationId="{94DD132E-067B-7378-CD64-23C9EC5B506B}"/>
-          </ac:spMkLst>
-        </pc:spChg>
-        <pc:spChg chg="add mod">
-          <ac:chgData name="SHINOHARA Soshi (篠原 想詩)" userId="309c0b21-8b61-4cd5-9d32-07652c56306e" providerId="ADAL" clId="{60D42A6B-AE32-4A06-B461-AA9486421C3B}" dt="2026-09-18T05:52:20.736" v="1612" actId="20577"/>
-          <ac:spMkLst>
-            <pc:docMk/>
-            <pc:sldMk cId="0" sldId="258"/>
-            <ac:spMk id="3" creationId="{D8611FDF-9B1D-9612-327D-9456F6143916}"/>
-          </ac:spMkLst>
-        </pc:spChg>
-        <pc:spChg chg="add del mod">
-          <ac:chgData name="SHINOHARA Soshi (篠原 想詩)" userId="309c0b21-8b61-4cd5-9d32-07652c56306e" providerId="ADAL" clId="{60D42A6B-AE32-4A06-B461-AA9486421C3B}" dt="2026-09-18T05:15:29.082" v="64" actId="478"/>
-          <ac:spMkLst>
-            <pc:docMk/>
-            <pc:sldMk cId="0" sldId="258"/>
-            <ac:spMk id="4" creationId="{EB812D85-C2CF-8FAD-F086-3119E0647715}"/>
-          </ac:spMkLst>
-        </pc:spChg>
-        <pc:spChg chg="add del mod">
-          <ac:chgData name="SHINOHARA Soshi (篠原 想詩)" userId="309c0b21-8b61-4cd5-9d32-07652c56306e" providerId="ADAL" clId="{60D42A6B-AE32-4A06-B461-AA9486421C3B}" dt="2026-09-18T05:15:27.457" v="63" actId="21"/>
-          <ac:spMkLst>
-            <pc:docMk/>
-            <pc:sldMk cId="0" sldId="258"/>
-            <ac:spMk id="6" creationId="{31E1ED1F-4204-68E6-245A-F1A17FB2943C}"/>
-          </ac:spMkLst>
-        </pc:spChg>
-        <pc:spChg chg="add mod">
-          <ac:chgData name="SHINOHARA Soshi (篠原 想詩)" userId="309c0b21-8b61-4cd5-9d32-07652c56306e" providerId="ADAL" clId="{60D42A6B-AE32-4A06-B461-AA9486421C3B}" dt="2026-09-18T05:21:48.287" v="207" actId="1076"/>
-          <ac:spMkLst>
-            <pc:docMk/>
-            <pc:sldMk cId="0" sldId="258"/>
-            <ac:spMk id="8" creationId="{D2FA8936-D68E-6874-8EB3-C9A079275CE7}"/>
-          </ac:spMkLst>
-        </pc:spChg>
-        <pc:spChg chg="del mod">
-          <ac:chgData name="SHINOHARA Soshi (篠原 想詩)" userId="309c0b21-8b61-4cd5-9d32-07652c56306e" providerId="ADAL" clId="{60D42A6B-AE32-4A06-B461-AA9486421C3B}" dt="2026-09-18T05:15:22.292" v="59" actId="478"/>
-          <ac:spMkLst>
-            <pc:docMk/>
-            <pc:sldMk cId="0" sldId="258"/>
-            <ac:spMk id="5125" creationId="{ED21CF95-DAEB-0ED1-2F64-90E9C5261A33}"/>
-          </ac:spMkLst>
-        </pc:spChg>
-        <pc:spChg chg="del">
-          <ac:chgData name="SHINOHARA Soshi (篠原 想詩)" userId="309c0b21-8b61-4cd5-9d32-07652c56306e" providerId="ADAL" clId="{60D42A6B-AE32-4A06-B461-AA9486421C3B}" dt="2026-09-18T05:15:34.042" v="66" actId="478"/>
-          <ac:spMkLst>
-            <pc:docMk/>
-            <pc:sldMk cId="0" sldId="258"/>
-            <ac:spMk id="5126" creationId="{7F2BCA0B-F299-74C5-96D3-C3D6EF19918A}"/>
-          </ac:spMkLst>
-        </pc:spChg>
-      </pc:sldChg>
-      <pc:sldChg chg="addSp delSp modSp add del mod">
-        <pc:chgData name="SHINOHARA Soshi (篠原 想詩)" userId="309c0b21-8b61-4cd5-9d32-07652c56306e" providerId="ADAL" clId="{60D42A6B-AE32-4A06-B461-AA9486421C3B}" dt="2026-09-18T06:10:48.715" v="2475" actId="47"/>
-        <pc:sldMkLst>
-          <pc:docMk/>
-          <pc:sldMk cId="0" sldId="259"/>
-        </pc:sldMkLst>
-        <pc:spChg chg="add del">
-          <ac:chgData name="SHINOHARA Soshi (篠原 想詩)" userId="309c0b21-8b61-4cd5-9d32-07652c56306e" providerId="ADAL" clId="{60D42A6B-AE32-4A06-B461-AA9486421C3B}" dt="2026-09-18T05:24:57.783" v="258" actId="21"/>
-          <ac:spMkLst>
-            <pc:docMk/>
-            <pc:sldMk cId="0" sldId="259"/>
-            <ac:spMk id="5" creationId="{16BEEDCE-E230-E6CC-9D69-9CE4C12B6E65}"/>
-          </ac:spMkLst>
-        </pc:spChg>
-        <pc:spChg chg="add del">
-          <ac:chgData name="SHINOHARA Soshi (篠原 想詩)" userId="309c0b21-8b61-4cd5-9d32-07652c56306e" providerId="ADAL" clId="{60D42A6B-AE32-4A06-B461-AA9486421C3B}" dt="2026-09-18T05:24:57.783" v="258" actId="21"/>
-          <ac:spMkLst>
-            <pc:docMk/>
-            <pc:sldMk cId="0" sldId="259"/>
-            <ac:spMk id="7" creationId="{794BAA89-82D5-064F-1037-F3EDA1FF681E}"/>
-          </ac:spMkLst>
-        </pc:spChg>
-        <pc:spChg chg="add del">
-          <ac:chgData name="SHINOHARA Soshi (篠原 想詩)" userId="309c0b21-8b61-4cd5-9d32-07652c56306e" providerId="ADAL" clId="{60D42A6B-AE32-4A06-B461-AA9486421C3B}" dt="2026-09-18T05:24:57.783" v="258" actId="21"/>
-          <ac:spMkLst>
-            <pc:docMk/>
-            <pc:sldMk cId="0" sldId="259"/>
-            <ac:spMk id="13" creationId="{DB6929EC-8CFE-8684-4905-C662CE9BE12D}"/>
-          </ac:spMkLst>
-        </pc:spChg>
-        <pc:spChg chg="add del">
-          <ac:chgData name="SHINOHARA Soshi (篠原 想詩)" userId="309c0b21-8b61-4cd5-9d32-07652c56306e" providerId="ADAL" clId="{60D42A6B-AE32-4A06-B461-AA9486421C3B}" dt="2026-09-18T05:24:57.783" v="258" actId="21"/>
-          <ac:spMkLst>
-            <pc:docMk/>
-            <pc:sldMk cId="0" sldId="259"/>
-            <ac:spMk id="15" creationId="{416E2D99-8C5A-832E-B72D-3136EB456A41}"/>
-          </ac:spMkLst>
-        </pc:spChg>
-        <pc:spChg chg="add del">
-          <ac:chgData name="SHINOHARA Soshi (篠原 想詩)" userId="309c0b21-8b61-4cd5-9d32-07652c56306e" providerId="ADAL" clId="{60D42A6B-AE32-4A06-B461-AA9486421C3B}" dt="2026-09-18T05:24:57.783" v="258" actId="21"/>
-          <ac:spMkLst>
-            <pc:docMk/>
-            <pc:sldMk cId="0" sldId="259"/>
-            <ac:spMk id="17" creationId="{2B21E95C-2D0A-5FC1-3149-E4B9CCFAD21E}"/>
-          </ac:spMkLst>
-        </pc:spChg>
-        <pc:spChg chg="add del">
-          <ac:chgData name="SHINOHARA Soshi (篠原 想詩)" userId="309c0b21-8b61-4cd5-9d32-07652c56306e" providerId="ADAL" clId="{60D42A6B-AE32-4A06-B461-AA9486421C3B}" dt="2026-09-18T05:24:57.783" v="258" actId="21"/>
-          <ac:spMkLst>
-            <pc:docMk/>
-            <pc:sldMk cId="0" sldId="259"/>
-            <ac:spMk id="23" creationId="{419E1F2C-F215-144D-EDD1-43FD3B28E70F}"/>
-          </ac:spMkLst>
-        </pc:spChg>
-        <pc:spChg chg="add del">
-          <ac:chgData name="SHINOHARA Soshi (篠原 想詩)" userId="309c0b21-8b61-4cd5-9d32-07652c56306e" providerId="ADAL" clId="{60D42A6B-AE32-4A06-B461-AA9486421C3B}" dt="2026-09-18T05:24:57.783" v="258" actId="21"/>
-          <ac:spMkLst>
-            <pc:docMk/>
-            <pc:sldMk cId="0" sldId="259"/>
-            <ac:spMk id="29" creationId="{6A6720B2-6AE5-C69A-25D4-DA3CC3F19CCD}"/>
-          </ac:spMkLst>
-        </pc:spChg>
-        <pc:spChg chg="add del">
-          <ac:chgData name="SHINOHARA Soshi (篠原 想詩)" userId="309c0b21-8b61-4cd5-9d32-07652c56306e" providerId="ADAL" clId="{60D42A6B-AE32-4A06-B461-AA9486421C3B}" dt="2026-09-18T05:24:57.783" v="258" actId="21"/>
-          <ac:spMkLst>
-            <pc:docMk/>
-            <pc:sldMk cId="0" sldId="259"/>
-            <ac:spMk id="31" creationId="{A0DD7059-571E-3CD1-FCA7-1BE1DCA6BE1C}"/>
-          </ac:spMkLst>
-        </pc:spChg>
-        <pc:spChg chg="del">
-          <ac:chgData name="SHINOHARA Soshi (篠原 想詩)" userId="309c0b21-8b61-4cd5-9d32-07652c56306e" providerId="ADAL" clId="{60D42A6B-AE32-4A06-B461-AA9486421C3B}" dt="2026-09-18T05:24:39.639" v="251" actId="478"/>
-          <ac:spMkLst>
-            <pc:docMk/>
-            <pc:sldMk cId="0" sldId="259"/>
-            <ac:spMk id="20482" creationId="{C2E6D61F-0D42-AF61-3931-B76E4F1180F0}"/>
-          </ac:spMkLst>
-        </pc:spChg>
-        <pc:spChg chg="del">
-          <ac:chgData name="SHINOHARA Soshi (篠原 想詩)" userId="309c0b21-8b61-4cd5-9d32-07652c56306e" providerId="ADAL" clId="{60D42A6B-AE32-4A06-B461-AA9486421C3B}" dt="2026-09-18T05:24:38.450" v="250" actId="478"/>
-          <ac:spMkLst>
-            <pc:docMk/>
-            <pc:sldMk cId="0" sldId="259"/>
-            <ac:spMk id="20483" creationId="{84BA23FB-9E78-A665-BF63-41765197AD3A}"/>
-          </ac:spMkLst>
-        </pc:spChg>
-        <pc:spChg chg="add del">
-          <ac:chgData name="SHINOHARA Soshi (篠原 想詩)" userId="309c0b21-8b61-4cd5-9d32-07652c56306e" providerId="ADAL" clId="{60D42A6B-AE32-4A06-B461-AA9486421C3B}" dt="2026-09-18T05:24:57.783" v="258" actId="21"/>
-          <ac:spMkLst>
-            <pc:docMk/>
-            <pc:sldMk cId="0" sldId="259"/>
-            <ac:spMk id="20485" creationId="{DF9AC646-2B61-3D6E-DFEB-A5150BDEB0C4}"/>
-          </ac:spMkLst>
-        </pc:spChg>
-        <pc:spChg chg="add del">
-          <ac:chgData name="SHINOHARA Soshi (篠原 想詩)" userId="309c0b21-8b61-4cd5-9d32-07652c56306e" providerId="ADAL" clId="{60D42A6B-AE32-4A06-B461-AA9486421C3B}" dt="2026-09-18T05:24:57.783" v="258" actId="21"/>
-          <ac:spMkLst>
-            <pc:docMk/>
-            <pc:sldMk cId="0" sldId="259"/>
-            <ac:spMk id="20487" creationId="{F7FC0BCA-043E-0E54-8C10-046E4FE3C7D0}"/>
-          </ac:spMkLst>
-        </pc:spChg>
-        <pc:spChg chg="add del">
-          <ac:chgData name="SHINOHARA Soshi (篠原 想詩)" userId="309c0b21-8b61-4cd5-9d32-07652c56306e" providerId="ADAL" clId="{60D42A6B-AE32-4A06-B461-AA9486421C3B}" dt="2026-09-18T05:54:47.953" v="1670" actId="21"/>
-          <ac:spMkLst>
-            <pc:docMk/>
-            <pc:sldMk cId="0" sldId="259"/>
-            <ac:spMk id="20495" creationId="{A4D9F973-0BFC-4A86-98E9-A2CEAA78CA76}"/>
-          </ac:spMkLst>
-        </pc:spChg>
-        <pc:spChg chg="add del">
-          <ac:chgData name="SHINOHARA Soshi (篠原 想詩)" userId="309c0b21-8b61-4cd5-9d32-07652c56306e" providerId="ADAL" clId="{60D42A6B-AE32-4A06-B461-AA9486421C3B}" dt="2026-09-18T05:54:47.953" v="1670" actId="21"/>
-          <ac:spMkLst>
-            <pc:docMk/>
-            <pc:sldMk cId="0" sldId="259"/>
-            <ac:spMk id="20497" creationId="{60E1E6C4-9748-E7D8-1558-58C343E33BE3}"/>
-          </ac:spMkLst>
-        </pc:spChg>
-        <pc:spChg chg="add del">
-          <ac:chgData name="SHINOHARA Soshi (篠原 想詩)" userId="309c0b21-8b61-4cd5-9d32-07652c56306e" providerId="ADAL" clId="{60D42A6B-AE32-4A06-B461-AA9486421C3B}" dt="2026-09-18T05:54:47.953" v="1670" actId="21"/>
-          <ac:spMkLst>
-            <pc:docMk/>
-            <pc:sldMk cId="0" sldId="259"/>
-            <ac:spMk id="20499" creationId="{EAA122E3-0D87-FCBF-BA03-998D81E61207}"/>
-          </ac:spMkLst>
-        </pc:spChg>
-        <pc:spChg chg="add del">
-          <ac:chgData name="SHINOHARA Soshi (篠原 想詩)" userId="309c0b21-8b61-4cd5-9d32-07652c56306e" providerId="ADAL" clId="{60D42A6B-AE32-4A06-B461-AA9486421C3B}" dt="2026-09-18T05:54:47.953" v="1670" actId="21"/>
-          <ac:spMkLst>
-            <pc:docMk/>
-            <pc:sldMk cId="0" sldId="259"/>
-            <ac:spMk id="20501" creationId="{CC951E02-3EED-A2A4-78BA-01B7677F5FE0}"/>
-          </ac:spMkLst>
-        </pc:spChg>
-        <pc:spChg chg="add del">
-          <ac:chgData name="SHINOHARA Soshi (篠原 想詩)" userId="309c0b21-8b61-4cd5-9d32-07652c56306e" providerId="ADAL" clId="{60D42A6B-AE32-4A06-B461-AA9486421C3B}" dt="2026-09-18T05:54:47.953" v="1670" actId="21"/>
-          <ac:spMkLst>
-            <pc:docMk/>
-            <pc:sldMk cId="0" sldId="259"/>
-            <ac:spMk id="20503" creationId="{8BD3BB66-8271-E186-77BC-128680E7F29E}"/>
-          </ac:spMkLst>
-        </pc:spChg>
-        <pc:spChg chg="add del">
-          <ac:chgData name="SHINOHARA Soshi (篠原 想詩)" userId="309c0b21-8b61-4cd5-9d32-07652c56306e" providerId="ADAL" clId="{60D42A6B-AE32-4A06-B461-AA9486421C3B}" dt="2026-09-18T05:54:47.953" v="1670" actId="21"/>
-          <ac:spMkLst>
-            <pc:docMk/>
-            <pc:sldMk cId="0" sldId="259"/>
-            <ac:spMk id="20505" creationId="{CD1701D2-1FA7-DA35-1AE9-70AF37EB9638}"/>
-          </ac:spMkLst>
-        </pc:spChg>
-        <pc:spChg chg="add del">
-          <ac:chgData name="SHINOHARA Soshi (篠原 想詩)" userId="309c0b21-8b61-4cd5-9d32-07652c56306e" providerId="ADAL" clId="{60D42A6B-AE32-4A06-B461-AA9486421C3B}" dt="2026-09-18T05:54:47.953" v="1670" actId="21"/>
-          <ac:spMkLst>
-            <pc:docMk/>
-            <pc:sldMk cId="0" sldId="259"/>
-            <ac:spMk id="20509" creationId="{F4B2CC77-088B-2831-4A36-A00BB8BF21FF}"/>
-          </ac:spMkLst>
-        </pc:spChg>
-        <pc:spChg chg="add del mod">
-          <ac:chgData name="SHINOHARA Soshi (篠原 想詩)" userId="309c0b21-8b61-4cd5-9d32-07652c56306e" providerId="ADAL" clId="{60D42A6B-AE32-4A06-B461-AA9486421C3B}" dt="2026-09-18T06:10:46.655" v="2473" actId="21"/>
-          <ac:spMkLst>
-            <pc:docMk/>
-            <pc:sldMk cId="0" sldId="259"/>
-            <ac:spMk id="20511" creationId="{EFF9C31E-7D98-E5C9-EF36-0A4482974082}"/>
-          </ac:spMkLst>
-        </pc:spChg>
-        <pc:spChg chg="add del">
-          <ac:chgData name="SHINOHARA Soshi (篠原 想詩)" userId="309c0b21-8b61-4cd5-9d32-07652c56306e" providerId="ADAL" clId="{60D42A6B-AE32-4A06-B461-AA9486421C3B}" dt="2026-09-18T06:10:46.655" v="2473" actId="21"/>
-          <ac:spMkLst>
-            <pc:docMk/>
-            <pc:sldMk cId="0" sldId="259"/>
-            <ac:spMk id="20513" creationId="{69CA037E-58DF-B94A-390E-DB0582B51D3E}"/>
-          </ac:spMkLst>
-        </pc:spChg>
-        <pc:graphicFrameChg chg="add del">
-          <ac:chgData name="SHINOHARA Soshi (篠原 想詩)" userId="309c0b21-8b61-4cd5-9d32-07652c56306e" providerId="ADAL" clId="{60D42A6B-AE32-4A06-B461-AA9486421C3B}" dt="2026-09-18T05:54:47.953" v="1670" actId="21"/>
-          <ac:graphicFrameMkLst>
-            <pc:docMk/>
-            <pc:sldMk cId="0" sldId="259"/>
-            <ac:graphicFrameMk id="20507" creationId="{8E7682B8-07FA-EC1B-AB2C-C18C0BCA5CD5}"/>
-          </ac:graphicFrameMkLst>
-        </pc:graphicFrameChg>
-        <pc:graphicFrameChg chg="add del mod modGraphic">
-          <ac:chgData name="SHINOHARA Soshi (篠原 想詩)" userId="309c0b21-8b61-4cd5-9d32-07652c56306e" providerId="ADAL" clId="{60D42A6B-AE32-4A06-B461-AA9486421C3B}" dt="2026-09-18T06:10:46.655" v="2473" actId="21"/>
-          <ac:graphicFrameMkLst>
-            <pc:docMk/>
-            <pc:sldMk cId="0" sldId="259"/>
-            <ac:graphicFrameMk id="20515" creationId="{BF03AD17-F94C-3F17-1164-5D87486DAD35}"/>
-          </ac:graphicFrameMkLst>
-        </pc:graphicFrameChg>
-      </pc:sldChg>
-      <pc:sldChg chg="addSp delSp modSp add del mod ord">
-        <pc:chgData name="SHINOHARA Soshi (篠原 想詩)" userId="309c0b21-8b61-4cd5-9d32-07652c56306e" providerId="ADAL" clId="{60D42A6B-AE32-4A06-B461-AA9486421C3B}" dt="2026-09-18T06:11:40.624" v="2511" actId="20577"/>
+      <pc:sldChg chg="modSp mod">
+        <pc:chgData name="SHINOHARA Soshi (篠原 想詩)" userId="309c0b21-8b61-4cd5-9d32-07652c56306e" providerId="ADAL" clId="{60D42A6B-AE32-4A06-B461-AA9486421C3B}" dt="2026-10-22T09:43:08.253" v="2636" actId="1076"/>
         <pc:sldMkLst>
           <pc:docMk/>
           <pc:sldMk cId="0" sldId="260"/>
         </pc:sldMkLst>
-        <pc:spChg chg="add del mod">
-          <ac:chgData name="SHINOHARA Soshi (篠原 想詩)" userId="309c0b21-8b61-4cd5-9d32-07652c56306e" providerId="ADAL" clId="{60D42A6B-AE32-4A06-B461-AA9486421C3B}" dt="2026-09-18T05:20:53.246" v="189" actId="478"/>
-          <ac:spMkLst>
-            <pc:docMk/>
-            <pc:sldMk cId="0" sldId="260"/>
-            <ac:spMk id="3" creationId="{4F55B57D-F8B6-6C1D-4BEA-FDF1012D8018}"/>
-          </ac:spMkLst>
-        </pc:spChg>
-        <pc:spChg chg="add del">
-          <ac:chgData name="SHINOHARA Soshi (篠原 想詩)" userId="309c0b21-8b61-4cd5-9d32-07652c56306e" providerId="ADAL" clId="{60D42A6B-AE32-4A06-B461-AA9486421C3B}" dt="2026-09-18T06:08:16.468" v="2383" actId="478"/>
-          <ac:spMkLst>
-            <pc:docMk/>
-            <pc:sldMk cId="0" sldId="260"/>
-            <ac:spMk id="5" creationId="{431B13A8-3DD4-DFA4-DE7E-C5BF855B41E7}"/>
-          </ac:spMkLst>
-        </pc:spChg>
-        <pc:spChg chg="add del">
-          <ac:chgData name="SHINOHARA Soshi (篠原 想詩)" userId="309c0b21-8b61-4cd5-9d32-07652c56306e" providerId="ADAL" clId="{60D42A6B-AE32-4A06-B461-AA9486421C3B}" dt="2026-09-18T05:37:16.287" v="719" actId="478"/>
-          <ac:spMkLst>
-            <pc:docMk/>
-            <pc:sldMk cId="0" sldId="260"/>
-            <ac:spMk id="7" creationId="{ABD3EDD7-62E8-46C9-CEEB-FFED12304482}"/>
-          </ac:spMkLst>
-        </pc:spChg>
-        <pc:spChg chg="add mod">
-          <ac:chgData name="SHINOHARA Soshi (篠原 想詩)" userId="309c0b21-8b61-4cd5-9d32-07652c56306e" providerId="ADAL" clId="{60D42A6B-AE32-4A06-B461-AA9486421C3B}" dt="2026-09-18T05:53:03.442" v="1652" actId="20577"/>
-          <ac:spMkLst>
-            <pc:docMk/>
-            <pc:sldMk cId="0" sldId="260"/>
-            <ac:spMk id="9" creationId="{286AF094-EB23-DE59-C364-CE66702F5820}"/>
-          </ac:spMkLst>
-        </pc:spChg>
-        <pc:spChg chg="add mod">
-          <ac:chgData name="SHINOHARA Soshi (篠原 想詩)" userId="309c0b21-8b61-4cd5-9d32-07652c56306e" providerId="ADAL" clId="{60D42A6B-AE32-4A06-B461-AA9486421C3B}" dt="2026-09-18T06:11:40.624" v="2511" actId="20577"/>
+        <pc:spChg chg="mod">
+          <ac:chgData name="SHINOHARA Soshi (篠原 想詩)" userId="309c0b21-8b61-4cd5-9d32-07652c56306e" providerId="ADAL" clId="{60D42A6B-AE32-4A06-B461-AA9486421C3B}" dt="2026-10-22T09:42:48.204" v="2635" actId="20577"/>
           <ac:spMkLst>
             <pc:docMk/>
             <pc:sldMk cId="0" sldId="260"/>
             <ac:spMk id="11" creationId="{9062C9EA-A562-CB3D-30B1-0D2FE45C706F}"/>
           </ac:spMkLst>
         </pc:spChg>
-        <pc:spChg chg="add del mod">
-          <ac:chgData name="SHINOHARA Soshi (篠原 想詩)" userId="309c0b21-8b61-4cd5-9d32-07652c56306e" providerId="ADAL" clId="{60D42A6B-AE32-4A06-B461-AA9486421C3B}" dt="2026-09-18T05:26:57.954" v="316" actId="478"/>
-          <ac:spMkLst>
+        <pc:graphicFrameChg chg="mod">
+          <ac:chgData name="SHINOHARA Soshi (篠原 想詩)" userId="309c0b21-8b61-4cd5-9d32-07652c56306e" providerId="ADAL" clId="{60D42A6B-AE32-4A06-B461-AA9486421C3B}" dt="2026-10-22T09:43:08.253" v="2636" actId="1076"/>
+          <ac:graphicFrameMkLst>
             <pc:docMk/>
             <pc:sldMk cId="0" sldId="260"/>
-            <ac:spMk id="13" creationId="{3932B18D-C369-43F3-4CDD-B87A63732FDB}"/>
-          </ac:spMkLst>
-        </pc:spChg>
-        <pc:spChg chg="add del mod">
-          <ac:chgData name="SHINOHARA Soshi (篠原 想詩)" userId="309c0b21-8b61-4cd5-9d32-07652c56306e" providerId="ADAL" clId="{60D42A6B-AE32-4A06-B461-AA9486421C3B}" dt="2026-09-18T05:27:00.072" v="317" actId="478"/>
-          <ac:spMkLst>
-            <pc:docMk/>
-            <pc:sldMk cId="0" sldId="260"/>
-            <ac:spMk id="15" creationId="{89E8F5CB-8474-8F3C-1087-5370B299E16C}"/>
-          </ac:spMkLst>
-        </pc:spChg>
-        <pc:spChg chg="add del mod">
-          <ac:chgData name="SHINOHARA Soshi (篠原 想詩)" userId="309c0b21-8b61-4cd5-9d32-07652c56306e" providerId="ADAL" clId="{60D42A6B-AE32-4A06-B461-AA9486421C3B}" dt="2026-09-18T05:26:57.954" v="316" actId="478"/>
-          <ac:spMkLst>
-            <pc:docMk/>
-            <pc:sldMk cId="0" sldId="260"/>
-            <ac:spMk id="17" creationId="{5F4B4C21-10CC-7BB4-8886-097CC3FBD6A2}"/>
-          </ac:spMkLst>
-        </pc:spChg>
-        <pc:spChg chg="add del mod">
-          <ac:chgData name="SHINOHARA Soshi (篠原 想詩)" userId="309c0b21-8b61-4cd5-9d32-07652c56306e" providerId="ADAL" clId="{60D42A6B-AE32-4A06-B461-AA9486421C3B}" dt="2026-09-18T05:27:00.072" v="317" actId="478"/>
-          <ac:spMkLst>
-            <pc:docMk/>
-            <pc:sldMk cId="0" sldId="260"/>
-            <ac:spMk id="19" creationId="{6566FDEC-E851-4FD8-440B-9AB7B75D8615}"/>
-          </ac:spMkLst>
-        </pc:spChg>
-        <pc:spChg chg="del mod">
-          <ac:chgData name="SHINOHARA Soshi (篠原 想詩)" userId="309c0b21-8b61-4cd5-9d32-07652c56306e" providerId="ADAL" clId="{60D42A6B-AE32-4A06-B461-AA9486421C3B}" dt="2026-09-18T05:26:57.954" v="316" actId="478"/>
-          <ac:spMkLst>
-            <pc:docMk/>
-            <pc:sldMk cId="0" sldId="260"/>
-            <ac:spMk id="21" creationId="{59F512A8-F464-D0D0-9A1A-D5A3570BFD77}"/>
-          </ac:spMkLst>
-        </pc:spChg>
-        <pc:spChg chg="add del mod">
-          <ac:chgData name="SHINOHARA Soshi (篠原 想詩)" userId="309c0b21-8b61-4cd5-9d32-07652c56306e" providerId="ADAL" clId="{60D42A6B-AE32-4A06-B461-AA9486421C3B}" dt="2026-09-18T05:27:00.072" v="317" actId="478"/>
-          <ac:spMkLst>
-            <pc:docMk/>
-            <pc:sldMk cId="0" sldId="260"/>
-            <ac:spMk id="23" creationId="{0790BCF8-C3A8-E5A4-D36A-2A9AED582F98}"/>
-          </ac:spMkLst>
-        </pc:spChg>
-        <pc:spChg chg="add">
-          <ac:chgData name="SHINOHARA Soshi (篠原 想詩)" userId="309c0b21-8b61-4cd5-9d32-07652c56306e" providerId="ADAL" clId="{60D42A6B-AE32-4A06-B461-AA9486421C3B}" dt="2026-09-18T06:08:16.898" v="2384" actId="22"/>
-          <ac:spMkLst>
-            <pc:docMk/>
-            <pc:sldMk cId="0" sldId="260"/>
-            <ac:spMk id="29" creationId="{99BBA5A8-AC1B-3C0B-F774-2765F922C93F}"/>
-          </ac:spMkLst>
-        </pc:spChg>
-        <pc:spChg chg="add del">
-          <ac:chgData name="SHINOHARA Soshi (篠原 想詩)" userId="309c0b21-8b61-4cd5-9d32-07652c56306e" providerId="ADAL" clId="{60D42A6B-AE32-4A06-B461-AA9486421C3B}" dt="2026-09-18T06:08:18.731" v="2385" actId="478"/>
-          <ac:spMkLst>
-            <pc:docMk/>
-            <pc:sldMk cId="0" sldId="260"/>
-            <ac:spMk id="31" creationId="{FA40E3C3-CB5B-5524-9202-BA4ECA6CB4A9}"/>
-          </ac:spMkLst>
-        </pc:spChg>
-        <pc:spChg chg="mod">
-          <ac:chgData name="SHINOHARA Soshi (篠原 想詩)" userId="309c0b21-8b61-4cd5-9d32-07652c56306e" providerId="ADAL" clId="{60D42A6B-AE32-4A06-B461-AA9486421C3B}" dt="2026-09-18T05:53:44.989" v="1660" actId="20577"/>
-          <ac:spMkLst>
-            <pc:docMk/>
-            <pc:sldMk cId="0" sldId="260"/>
-            <ac:spMk id="21506" creationId="{F73DBF07-353A-1DAE-881E-450898FCC584}"/>
-          </ac:spMkLst>
-        </pc:spChg>
-        <pc:spChg chg="del">
-          <ac:chgData name="SHINOHARA Soshi (篠原 想詩)" userId="309c0b21-8b61-4cd5-9d32-07652c56306e" providerId="ADAL" clId="{60D42A6B-AE32-4A06-B461-AA9486421C3B}" dt="2026-09-18T05:18:05.097" v="175" actId="478"/>
-          <ac:spMkLst>
-            <pc:docMk/>
-            <pc:sldMk cId="0" sldId="260"/>
-            <ac:spMk id="21507" creationId="{A317CE7C-B655-40C7-01E2-46D229D3A532}"/>
-          </ac:spMkLst>
-        </pc:spChg>
-        <pc:picChg chg="add del mod">
-          <ac:chgData name="SHINOHARA Soshi (篠原 想詩)" userId="309c0b21-8b61-4cd5-9d32-07652c56306e" providerId="ADAL" clId="{60D42A6B-AE32-4A06-B461-AA9486421C3B}" dt="2026-09-18T05:33:08.130" v="603" actId="478"/>
-          <ac:picMkLst>
-            <pc:docMk/>
-            <pc:sldMk cId="0" sldId="260"/>
-            <ac:picMk id="25" creationId="{FD94B394-67AA-AAF2-7110-7A9DA3C55AB5}"/>
-          </ac:picMkLst>
-        </pc:picChg>
-        <pc:picChg chg="add mod">
-          <ac:chgData name="SHINOHARA Soshi (篠原 想詩)" userId="309c0b21-8b61-4cd5-9d32-07652c56306e" providerId="ADAL" clId="{60D42A6B-AE32-4A06-B461-AA9486421C3B}" dt="2026-09-18T05:54:06.120" v="1663" actId="1076"/>
-          <ac:picMkLst>
-            <pc:docMk/>
-            <pc:sldMk cId="0" sldId="260"/>
-            <ac:picMk id="27" creationId="{9FFAB5E6-B58F-408D-66BD-F06FEFD51917}"/>
-          </ac:picMkLst>
-        </pc:picChg>
-      </pc:sldChg>
-      <pc:sldChg chg="addSp delSp modSp add mod">
-        <pc:chgData name="SHINOHARA Soshi (篠原 想詩)" userId="309c0b21-8b61-4cd5-9d32-07652c56306e" providerId="ADAL" clId="{60D42A6B-AE32-4A06-B461-AA9486421C3B}" dt="2026-09-18T07:24:11.208" v="2544" actId="207"/>
-        <pc:sldMkLst>
-          <pc:docMk/>
-          <pc:sldMk cId="2460916238" sldId="261"/>
-        </pc:sldMkLst>
-        <pc:spChg chg="add del mod">
-          <ac:chgData name="SHINOHARA Soshi (篠原 想詩)" userId="309c0b21-8b61-4cd5-9d32-07652c56306e" providerId="ADAL" clId="{60D42A6B-AE32-4A06-B461-AA9486421C3B}" dt="2026-09-18T05:25:08.832" v="262" actId="478"/>
-          <ac:spMkLst>
-            <pc:docMk/>
-            <pc:sldMk cId="2460916238" sldId="261"/>
-            <ac:spMk id="3" creationId="{CA4D1F53-A14A-7162-186C-AA71923C274E}"/>
-          </ac:spMkLst>
-        </pc:spChg>
-        <pc:spChg chg="add del mod">
-          <ac:chgData name="SHINOHARA Soshi (篠原 想詩)" userId="309c0b21-8b61-4cd5-9d32-07652c56306e" providerId="ADAL" clId="{60D42A6B-AE32-4A06-B461-AA9486421C3B}" dt="2026-09-18T06:07:30.410" v="2336" actId="478"/>
-          <ac:spMkLst>
-            <pc:docMk/>
-            <pc:sldMk cId="2460916238" sldId="261"/>
-            <ac:spMk id="5" creationId="{BE7B8D1F-E32B-7814-B7DE-5AAAAD2D4181}"/>
-          </ac:spMkLst>
-        </pc:spChg>
-        <pc:spChg chg="del">
-          <ac:chgData name="SHINOHARA Soshi (篠原 想詩)" userId="309c0b21-8b61-4cd5-9d32-07652c56306e" providerId="ADAL" clId="{60D42A6B-AE32-4A06-B461-AA9486421C3B}" dt="2026-09-18T06:07:26.110" v="2333" actId="478"/>
-          <ac:spMkLst>
-            <pc:docMk/>
-            <pc:sldMk cId="2460916238" sldId="261"/>
-            <ac:spMk id="6" creationId="{7F4E5446-F46C-48CC-6E65-7B7B2E9503FE}"/>
-          </ac:spMkLst>
-        </pc:spChg>
-        <pc:spChg chg="add del">
-          <ac:chgData name="SHINOHARA Soshi (篠原 想詩)" userId="309c0b21-8b61-4cd5-9d32-07652c56306e" providerId="ADAL" clId="{60D42A6B-AE32-4A06-B461-AA9486421C3B}" dt="2026-09-18T05:24:54.695" v="257" actId="478"/>
-          <ac:spMkLst>
-            <pc:docMk/>
-            <pc:sldMk cId="2460916238" sldId="261"/>
-            <ac:spMk id="7" creationId="{01CE3EA1-F0A8-7424-66A3-DBA858822732}"/>
-          </ac:spMkLst>
-        </pc:spChg>
-        <pc:spChg chg="add del">
-          <ac:chgData name="SHINOHARA Soshi (篠原 想詩)" userId="309c0b21-8b61-4cd5-9d32-07652c56306e" providerId="ADAL" clId="{60D42A6B-AE32-4A06-B461-AA9486421C3B}" dt="2026-09-18T05:24:54.695" v="257" actId="478"/>
-          <ac:spMkLst>
-            <pc:docMk/>
-            <pc:sldMk cId="2460916238" sldId="261"/>
-            <ac:spMk id="9" creationId="{8D09A15F-04FF-CD0E-4017-A04FA5ABA722}"/>
-          </ac:spMkLst>
-        </pc:spChg>
-        <pc:spChg chg="mod">
-          <ac:chgData name="SHINOHARA Soshi (篠原 想詩)" userId="309c0b21-8b61-4cd5-9d32-07652c56306e" providerId="ADAL" clId="{60D42A6B-AE32-4A06-B461-AA9486421C3B}" dt="2026-09-18T06:10:12.703" v="2455" actId="20577"/>
-          <ac:spMkLst>
-            <pc:docMk/>
-            <pc:sldMk cId="2460916238" sldId="261"/>
-            <ac:spMk id="10" creationId="{3ED9BB57-B053-F70B-D524-9A419F78B21D}"/>
-          </ac:spMkLst>
-        </pc:spChg>
-        <pc:spChg chg="add del">
-          <ac:chgData name="SHINOHARA Soshi (篠原 想詩)" userId="309c0b21-8b61-4cd5-9d32-07652c56306e" providerId="ADAL" clId="{60D42A6B-AE32-4A06-B461-AA9486421C3B}" dt="2026-09-18T05:24:54.695" v="257" actId="478"/>
-          <ac:spMkLst>
-            <pc:docMk/>
-            <pc:sldMk cId="2460916238" sldId="261"/>
-            <ac:spMk id="11" creationId="{21434601-AF06-911A-86DB-6D766E08ACF6}"/>
-          </ac:spMkLst>
-        </pc:spChg>
-        <pc:spChg chg="add del">
-          <ac:chgData name="SHINOHARA Soshi (篠原 想詩)" userId="309c0b21-8b61-4cd5-9d32-07652c56306e" providerId="ADAL" clId="{60D42A6B-AE32-4A06-B461-AA9486421C3B}" dt="2026-09-18T05:24:54.695" v="257" actId="478"/>
-          <ac:spMkLst>
-            <pc:docMk/>
-            <pc:sldMk cId="2460916238" sldId="261"/>
-            <ac:spMk id="13" creationId="{0A844F94-308C-40E7-389C-C85C23048104}"/>
-          </ac:spMkLst>
-        </pc:spChg>
-        <pc:spChg chg="mod">
-          <ac:chgData name="SHINOHARA Soshi (篠原 想詩)" userId="309c0b21-8b61-4cd5-9d32-07652c56306e" providerId="ADAL" clId="{60D42A6B-AE32-4A06-B461-AA9486421C3B}" dt="2026-09-18T05:47:59.610" v="1393" actId="1076"/>
-          <ac:spMkLst>
-            <pc:docMk/>
-            <pc:sldMk cId="2460916238" sldId="261"/>
-            <ac:spMk id="14" creationId="{5B0E15B8-93C6-B5DC-8BC8-AE4DFDADDF16}"/>
-          </ac:spMkLst>
-        </pc:spChg>
-        <pc:spChg chg="add del mod">
-          <ac:chgData name="SHINOHARA Soshi (篠原 想詩)" userId="309c0b21-8b61-4cd5-9d32-07652c56306e" providerId="ADAL" clId="{60D42A6B-AE32-4A06-B461-AA9486421C3B}" dt="2026-09-18T05:24:54.695" v="257" actId="478"/>
-          <ac:spMkLst>
-            <pc:docMk/>
-            <pc:sldMk cId="2460916238" sldId="261"/>
-            <ac:spMk id="15" creationId="{95656763-70B1-A3A4-369F-7EF7B623D55F}"/>
-          </ac:spMkLst>
-        </pc:spChg>
-        <pc:spChg chg="add del">
-          <ac:chgData name="SHINOHARA Soshi (篠原 想詩)" userId="309c0b21-8b61-4cd5-9d32-07652c56306e" providerId="ADAL" clId="{60D42A6B-AE32-4A06-B461-AA9486421C3B}" dt="2026-09-18T05:24:54.695" v="257" actId="478"/>
-          <ac:spMkLst>
-            <pc:docMk/>
-            <pc:sldMk cId="2460916238" sldId="261"/>
-            <ac:spMk id="17" creationId="{0F5239F4-8C8C-B0DF-B4B5-A862F57DEB1C}"/>
-          </ac:spMkLst>
-        </pc:spChg>
-        <pc:spChg chg="mod">
-          <ac:chgData name="SHINOHARA Soshi (篠原 想詩)" userId="309c0b21-8b61-4cd5-9d32-07652c56306e" providerId="ADAL" clId="{60D42A6B-AE32-4A06-B461-AA9486421C3B}" dt="2026-09-18T05:47:59.610" v="1393" actId="1076"/>
-          <ac:spMkLst>
-            <pc:docMk/>
-            <pc:sldMk cId="2460916238" sldId="261"/>
-            <ac:spMk id="18" creationId="{497756DF-3408-5C63-2891-8CB7EF569B47}"/>
-          </ac:spMkLst>
-        </pc:spChg>
-        <pc:spChg chg="add del">
-          <ac:chgData name="SHINOHARA Soshi (篠原 想詩)" userId="309c0b21-8b61-4cd5-9d32-07652c56306e" providerId="ADAL" clId="{60D42A6B-AE32-4A06-B461-AA9486421C3B}" dt="2026-09-18T05:24:54.695" v="257" actId="478"/>
-          <ac:spMkLst>
-            <pc:docMk/>
-            <pc:sldMk cId="2460916238" sldId="261"/>
-            <ac:spMk id="19" creationId="{7826C402-562F-4BD5-7C6B-D0FDFEAA603D}"/>
-          </ac:spMkLst>
-        </pc:spChg>
-        <pc:spChg chg="add del">
-          <ac:chgData name="SHINOHARA Soshi (篠原 想詩)" userId="309c0b21-8b61-4cd5-9d32-07652c56306e" providerId="ADAL" clId="{60D42A6B-AE32-4A06-B461-AA9486421C3B}" dt="2026-09-18T05:24:54.695" v="257" actId="478"/>
-          <ac:spMkLst>
-            <pc:docMk/>
-            <pc:sldMk cId="2460916238" sldId="261"/>
-            <ac:spMk id="21" creationId="{6F4993EC-9588-F220-45D8-1A365416A0CA}"/>
-          </ac:spMkLst>
-        </pc:spChg>
-        <pc:spChg chg="mod">
-          <ac:chgData name="SHINOHARA Soshi (篠原 想詩)" userId="309c0b21-8b61-4cd5-9d32-07652c56306e" providerId="ADAL" clId="{60D42A6B-AE32-4A06-B461-AA9486421C3B}" dt="2026-09-18T05:50:02.179" v="1414" actId="1076"/>
-          <ac:spMkLst>
-            <pc:docMk/>
-            <pc:sldMk cId="2460916238" sldId="261"/>
-            <ac:spMk id="22" creationId="{1ED71925-19F6-F7EB-DF01-3604792C541E}"/>
-          </ac:spMkLst>
-        </pc:spChg>
-        <pc:spChg chg="add del">
-          <ac:chgData name="SHINOHARA Soshi (篠原 想詩)" userId="309c0b21-8b61-4cd5-9d32-07652c56306e" providerId="ADAL" clId="{60D42A6B-AE32-4A06-B461-AA9486421C3B}" dt="2026-09-18T05:24:54.695" v="257" actId="478"/>
-          <ac:spMkLst>
-            <pc:docMk/>
-            <pc:sldMk cId="2460916238" sldId="261"/>
-            <ac:spMk id="23" creationId="{9958C36B-2683-47BF-00EE-254029DB53E4}"/>
-          </ac:spMkLst>
-        </pc:spChg>
-        <pc:spChg chg="add mod">
-          <ac:chgData name="SHINOHARA Soshi (篠原 想詩)" userId="309c0b21-8b61-4cd5-9d32-07652c56306e" providerId="ADAL" clId="{60D42A6B-AE32-4A06-B461-AA9486421C3B}" dt="2026-09-18T05:50:02.179" v="1414" actId="1076"/>
-          <ac:spMkLst>
-            <pc:docMk/>
-            <pc:sldMk cId="2460916238" sldId="261"/>
-            <ac:spMk id="25" creationId="{9AA1D80A-7EAB-E5E8-2EB1-FC55B36AF4FB}"/>
-          </ac:spMkLst>
-        </pc:spChg>
-        <pc:spChg chg="add mod">
-          <ac:chgData name="SHINOHARA Soshi (篠原 想詩)" userId="309c0b21-8b61-4cd5-9d32-07652c56306e" providerId="ADAL" clId="{60D42A6B-AE32-4A06-B461-AA9486421C3B}" dt="2026-09-18T05:50:02.179" v="1414" actId="1076"/>
-          <ac:spMkLst>
-            <pc:docMk/>
-            <pc:sldMk cId="2460916238" sldId="261"/>
-            <ac:spMk id="29" creationId="{A3A85E53-59E3-14F1-A43D-43A5D5555EB0}"/>
-          </ac:spMkLst>
-        </pc:spChg>
-        <pc:spChg chg="add mod">
-          <ac:chgData name="SHINOHARA Soshi (篠原 想詩)" userId="309c0b21-8b61-4cd5-9d32-07652c56306e" providerId="ADAL" clId="{60D42A6B-AE32-4A06-B461-AA9486421C3B}" dt="2026-09-18T05:50:02.179" v="1414" actId="1076"/>
-          <ac:spMkLst>
-            <pc:docMk/>
-            <pc:sldMk cId="2460916238" sldId="261"/>
-            <ac:spMk id="31" creationId="{4360A1D8-3337-5B5F-A527-4558554291F7}"/>
-          </ac:spMkLst>
-        </pc:spChg>
-        <pc:spChg chg="add mod">
-          <ac:chgData name="SHINOHARA Soshi (篠原 想詩)" userId="309c0b21-8b61-4cd5-9d32-07652c56306e" providerId="ADAL" clId="{60D42A6B-AE32-4A06-B461-AA9486421C3B}" dt="2026-09-18T05:50:02.179" v="1414" actId="1076"/>
-          <ac:spMkLst>
-            <pc:docMk/>
-            <pc:sldMk cId="2460916238" sldId="261"/>
-            <ac:spMk id="21505" creationId="{927C2915-20BF-81E6-ADAB-0B263E213E91}"/>
-          </ac:spMkLst>
-        </pc:spChg>
-        <pc:spChg chg="mod">
-          <ac:chgData name="SHINOHARA Soshi (篠原 想詩)" userId="309c0b21-8b61-4cd5-9d32-07652c56306e" providerId="ADAL" clId="{60D42A6B-AE32-4A06-B461-AA9486421C3B}" dt="2026-09-18T05:46:55.708" v="1359" actId="403"/>
-          <ac:spMkLst>
-            <pc:docMk/>
-            <pc:sldMk cId="2460916238" sldId="261"/>
-            <ac:spMk id="21506" creationId="{8B5E1CCB-E003-0B0A-94DD-5D464AE71E1F}"/>
-          </ac:spMkLst>
-        </pc:spChg>
-        <pc:spChg chg="add mod">
-          <ac:chgData name="SHINOHARA Soshi (篠原 想詩)" userId="309c0b21-8b61-4cd5-9d32-07652c56306e" providerId="ADAL" clId="{60D42A6B-AE32-4A06-B461-AA9486421C3B}" dt="2026-09-18T06:10:16.367" v="2466" actId="20577"/>
-          <ac:spMkLst>
-            <pc:docMk/>
-            <pc:sldMk cId="2460916238" sldId="261"/>
-            <ac:spMk id="21508" creationId="{2292334C-0E0C-4611-CBB3-F1ED8685F0EE}"/>
-          </ac:spMkLst>
-        </pc:spChg>
-        <pc:spChg chg="mod">
-          <ac:chgData name="SHINOHARA Soshi (篠原 想詩)" userId="309c0b21-8b61-4cd5-9d32-07652c56306e" providerId="ADAL" clId="{60D42A6B-AE32-4A06-B461-AA9486421C3B}" dt="2026-09-18T05:47:59.610" v="1393" actId="1076"/>
-          <ac:spMkLst>
-            <pc:docMk/>
-            <pc:sldMk cId="2460916238" sldId="261"/>
-            <ac:spMk id="21510" creationId="{43FF9372-D4F3-024E-F5FB-EEBCEE3D6C53}"/>
-          </ac:spMkLst>
-        </pc:spChg>
-        <pc:spChg chg="mod">
-          <ac:chgData name="SHINOHARA Soshi (篠原 想詩)" userId="309c0b21-8b61-4cd5-9d32-07652c56306e" providerId="ADAL" clId="{60D42A6B-AE32-4A06-B461-AA9486421C3B}" dt="2026-09-18T05:47:59.610" v="1393" actId="1076"/>
-          <ac:spMkLst>
-            <pc:docMk/>
-            <pc:sldMk cId="2460916238" sldId="261"/>
-            <ac:spMk id="21512" creationId="{89D92C62-0182-0465-1688-F4417EC2F72B}"/>
-          </ac:spMkLst>
-        </pc:spChg>
-        <pc:spChg chg="mod">
-          <ac:chgData name="SHINOHARA Soshi (篠原 想詩)" userId="309c0b21-8b61-4cd5-9d32-07652c56306e" providerId="ADAL" clId="{60D42A6B-AE32-4A06-B461-AA9486421C3B}" dt="2026-09-18T05:50:02.179" v="1414" actId="1076"/>
-          <ac:spMkLst>
-            <pc:docMk/>
-            <pc:sldMk cId="2460916238" sldId="261"/>
-            <ac:spMk id="21514" creationId="{D0A4DD7B-04A4-164A-EDDF-A00AC17F588E}"/>
-          </ac:spMkLst>
-        </pc:spChg>
-        <pc:spChg chg="add mod">
-          <ac:chgData name="SHINOHARA Soshi (篠原 想詩)" userId="309c0b21-8b61-4cd5-9d32-07652c56306e" providerId="ADAL" clId="{60D42A6B-AE32-4A06-B461-AA9486421C3B}" dt="2026-09-18T05:50:02.179" v="1414" actId="1076"/>
-          <ac:spMkLst>
-            <pc:docMk/>
-            <pc:sldMk cId="2460916238" sldId="261"/>
-            <ac:spMk id="21516" creationId="{CE12C862-B8D7-8680-F5A6-9D5626C05174}"/>
-          </ac:spMkLst>
-        </pc:spChg>
-        <pc:spChg chg="add mod">
-          <ac:chgData name="SHINOHARA Soshi (篠原 想詩)" userId="309c0b21-8b61-4cd5-9d32-07652c56306e" providerId="ADAL" clId="{60D42A6B-AE32-4A06-B461-AA9486421C3B}" dt="2026-09-18T05:50:02.179" v="1414" actId="1076"/>
-          <ac:spMkLst>
-            <pc:docMk/>
-            <pc:sldMk cId="2460916238" sldId="261"/>
-            <ac:spMk id="21518" creationId="{0B1D0BFE-19E5-BEBB-29BF-6206205D297A}"/>
-          </ac:spMkLst>
-        </pc:spChg>
-        <pc:spChg chg="add mod">
-          <ac:chgData name="SHINOHARA Soshi (篠原 想詩)" userId="309c0b21-8b61-4cd5-9d32-07652c56306e" providerId="ADAL" clId="{60D42A6B-AE32-4A06-B461-AA9486421C3B}" dt="2026-09-18T07:24:11.208" v="2544" actId="207"/>
-          <ac:spMkLst>
-            <pc:docMk/>
-            <pc:sldMk cId="2460916238" sldId="261"/>
-            <ac:spMk id="21522" creationId="{23394E18-7729-EF9C-1A57-D32D35698E0B}"/>
-          </ac:spMkLst>
-        </pc:spChg>
-        <pc:spChg chg="add del mod">
-          <ac:chgData name="SHINOHARA Soshi (篠原 想詩)" userId="309c0b21-8b61-4cd5-9d32-07652c56306e" providerId="ADAL" clId="{60D42A6B-AE32-4A06-B461-AA9486421C3B}" dt="2026-09-18T05:47:51.381" v="1392" actId="478"/>
-          <ac:spMkLst>
-            <pc:docMk/>
-            <pc:sldMk cId="2460916238" sldId="261"/>
-            <ac:spMk id="21524" creationId="{B2F10FD7-6ED5-4E6F-4153-33B85EE2B03E}"/>
-          </ac:spMkLst>
-        </pc:spChg>
-        <pc:spChg chg="del mod">
-          <ac:chgData name="SHINOHARA Soshi (篠原 想詩)" userId="309c0b21-8b61-4cd5-9d32-07652c56306e" providerId="ADAL" clId="{60D42A6B-AE32-4A06-B461-AA9486421C3B}" dt="2026-09-18T05:47:49.117" v="1391" actId="478"/>
-          <ac:spMkLst>
-            <pc:docMk/>
-            <pc:sldMk cId="2460916238" sldId="261"/>
-            <ac:spMk id="21526" creationId="{720EA9A5-F780-985C-4940-3F9A5D2FEC2F}"/>
-          </ac:spMkLst>
-        </pc:spChg>
-        <pc:spChg chg="add mod">
-          <ac:chgData name="SHINOHARA Soshi (篠原 想詩)" userId="309c0b21-8b61-4cd5-9d32-07652c56306e" providerId="ADAL" clId="{60D42A6B-AE32-4A06-B461-AA9486421C3B}" dt="2026-09-18T06:03:14.359" v="2304" actId="1582"/>
-          <ac:spMkLst>
-            <pc:docMk/>
-            <pc:sldMk cId="2460916238" sldId="261"/>
-            <ac:spMk id="21527" creationId="{231EE372-2D83-A895-742F-441F2D69583B}"/>
-          </ac:spMkLst>
-        </pc:spChg>
-        <pc:spChg chg="add mod">
-          <ac:chgData name="SHINOHARA Soshi (篠原 想詩)" userId="309c0b21-8b61-4cd5-9d32-07652c56306e" providerId="ADAL" clId="{60D42A6B-AE32-4A06-B461-AA9486421C3B}" dt="2026-09-18T05:49:47.348" v="1412" actId="1076"/>
-          <ac:spMkLst>
-            <pc:docMk/>
-            <pc:sldMk cId="2460916238" sldId="261"/>
-            <ac:spMk id="21529" creationId="{08D3BE1E-A7CA-BEB2-ADB6-594EF66852D4}"/>
-          </ac:spMkLst>
-        </pc:spChg>
-        <pc:spChg chg="add mod">
-          <ac:chgData name="SHINOHARA Soshi (篠原 想詩)" userId="309c0b21-8b61-4cd5-9d32-07652c56306e" providerId="ADAL" clId="{60D42A6B-AE32-4A06-B461-AA9486421C3B}" dt="2026-09-18T06:09:45.821" v="2404" actId="20577"/>
-          <ac:spMkLst>
-            <pc:docMk/>
-            <pc:sldMk cId="2460916238" sldId="261"/>
-            <ac:spMk id="21531" creationId="{0E081BA2-CF81-69EE-3F51-8B71713AA293}"/>
-          </ac:spMkLst>
-        </pc:spChg>
-        <pc:spChg chg="add mod">
-          <ac:chgData name="SHINOHARA Soshi (篠原 想詩)" userId="309c0b21-8b61-4cd5-9d32-07652c56306e" providerId="ADAL" clId="{60D42A6B-AE32-4A06-B461-AA9486421C3B}" dt="2026-09-18T06:03:40.075" v="2308" actId="1076"/>
-          <ac:spMkLst>
-            <pc:docMk/>
-            <pc:sldMk cId="2460916238" sldId="261"/>
-            <ac:spMk id="21533" creationId="{B85F4D50-9C37-7186-F9DF-DF2611B8DAE4}"/>
-          </ac:spMkLst>
-        </pc:spChg>
-        <pc:spChg chg="add">
-          <ac:chgData name="SHINOHARA Soshi (篠原 想詩)" userId="309c0b21-8b61-4cd5-9d32-07652c56306e" providerId="ADAL" clId="{60D42A6B-AE32-4A06-B461-AA9486421C3B}" dt="2026-09-18T06:07:26.395" v="2334" actId="22"/>
-          <ac:spMkLst>
-            <pc:docMk/>
-            <pc:sldMk cId="2460916238" sldId="261"/>
-            <ac:spMk id="21535" creationId="{2E47C8EF-6705-D95C-B05D-E243520E31E0}"/>
-          </ac:spMkLst>
-        </pc:spChg>
-        <pc:spChg chg="add del">
-          <ac:chgData name="SHINOHARA Soshi (篠原 想詩)" userId="309c0b21-8b61-4cd5-9d32-07652c56306e" providerId="ADAL" clId="{60D42A6B-AE32-4A06-B461-AA9486421C3B}" dt="2026-09-18T06:07:28.184" v="2335" actId="478"/>
-          <ac:spMkLst>
-            <pc:docMk/>
-            <pc:sldMk cId="2460916238" sldId="261"/>
-            <ac:spMk id="21537" creationId="{24243219-7C45-AC1E-0C8D-E3B5C1DED6B2}"/>
-          </ac:spMkLst>
-        </pc:spChg>
-      </pc:sldChg>
-      <pc:sldChg chg="add del">
-        <pc:chgData name="SHINOHARA Soshi (篠原 想詩)" userId="309c0b21-8b61-4cd5-9d32-07652c56306e" providerId="ADAL" clId="{60D42A6B-AE32-4A06-B461-AA9486421C3B}" dt="2026-09-18T05:26:41.898" v="310"/>
-        <pc:sldMkLst>
-          <pc:docMk/>
-          <pc:sldMk cId="986264629" sldId="262"/>
-        </pc:sldMkLst>
-      </pc:sldChg>
-      <pc:sldChg chg="add del">
-        <pc:chgData name="SHINOHARA Soshi (篠原 想詩)" userId="309c0b21-8b61-4cd5-9d32-07652c56306e" providerId="ADAL" clId="{60D42A6B-AE32-4A06-B461-AA9486421C3B}" dt="2026-09-18T05:26:52.924" v="315" actId="47"/>
-        <pc:sldMkLst>
-          <pc:docMk/>
-          <pc:sldMk cId="3842469057" sldId="262"/>
-        </pc:sldMkLst>
-      </pc:sldChg>
-      <pc:sldChg chg="delSp modSp add mod">
-        <pc:chgData name="SHINOHARA Soshi (篠原 想詩)" userId="309c0b21-8b61-4cd5-9d32-07652c56306e" providerId="ADAL" clId="{60D42A6B-AE32-4A06-B461-AA9486421C3B}" dt="2026-09-18T07:18:17.875" v="2543" actId="1076"/>
-        <pc:sldMkLst>
-          <pc:docMk/>
-          <pc:sldMk cId="2416652295" sldId="263"/>
-        </pc:sldMkLst>
-        <pc:spChg chg="mod">
-          <ac:chgData name="SHINOHARA Soshi (篠原 想詩)" userId="309c0b21-8b61-4cd5-9d32-07652c56306e" providerId="ADAL" clId="{60D42A6B-AE32-4A06-B461-AA9486421C3B}" dt="2026-09-18T06:06:58.138" v="2327" actId="14100"/>
-          <ac:spMkLst>
-            <pc:docMk/>
-            <pc:sldMk cId="2416652295" sldId="263"/>
-            <ac:spMk id="5" creationId="{03ADD616-96E1-C816-722E-D432D1B1434B}"/>
-          </ac:spMkLst>
-        </pc:spChg>
-        <pc:spChg chg="mod">
-          <ac:chgData name="SHINOHARA Soshi (篠原 想詩)" userId="309c0b21-8b61-4cd5-9d32-07652c56306e" providerId="ADAL" clId="{60D42A6B-AE32-4A06-B461-AA9486421C3B}" dt="2026-09-18T06:07:20.645" v="2332" actId="14100"/>
-          <ac:spMkLst>
-            <pc:docMk/>
-            <pc:sldMk cId="2416652295" sldId="263"/>
-            <ac:spMk id="7" creationId="{9D8E4493-09ED-D66D-BB69-F4E17FDDAAE5}"/>
-          </ac:spMkLst>
-        </pc:spChg>
-        <pc:spChg chg="mod">
-          <ac:chgData name="SHINOHARA Soshi (篠原 想詩)" userId="309c0b21-8b61-4cd5-9d32-07652c56306e" providerId="ADAL" clId="{60D42A6B-AE32-4A06-B461-AA9486421C3B}" dt="2026-09-18T05:50:15.383" v="1415" actId="1076"/>
-          <ac:spMkLst>
-            <pc:docMk/>
-            <pc:sldMk cId="2416652295" sldId="263"/>
-            <ac:spMk id="9" creationId="{A76CBF8E-780A-F613-552A-79DF92A79B34}"/>
-          </ac:spMkLst>
-        </pc:spChg>
-        <pc:spChg chg="mod">
-          <ac:chgData name="SHINOHARA Soshi (篠原 想詩)" userId="309c0b21-8b61-4cd5-9d32-07652c56306e" providerId="ADAL" clId="{60D42A6B-AE32-4A06-B461-AA9486421C3B}" dt="2026-09-18T07:18:08.613" v="2541" actId="14100"/>
-          <ac:spMkLst>
-            <pc:docMk/>
-            <pc:sldMk cId="2416652295" sldId="263"/>
-            <ac:spMk id="11" creationId="{334C37F2-BE3E-BFC0-CAB9-D3917FDC0606}"/>
-          </ac:spMkLst>
-        </pc:spChg>
-        <pc:spChg chg="mod">
-          <ac:chgData name="SHINOHARA Soshi (篠原 想詩)" userId="309c0b21-8b61-4cd5-9d32-07652c56306e" providerId="ADAL" clId="{60D42A6B-AE32-4A06-B461-AA9486421C3B}" dt="2026-09-18T06:09:13.314" v="2397" actId="1076"/>
-          <ac:spMkLst>
-            <pc:docMk/>
-            <pc:sldMk cId="2416652295" sldId="263"/>
-            <ac:spMk id="13" creationId="{CFA581EB-E5DD-E949-61AD-F14177A9CC17}"/>
-          </ac:spMkLst>
-        </pc:spChg>
-        <pc:spChg chg="mod">
-          <ac:chgData name="SHINOHARA Soshi (篠原 想詩)" userId="309c0b21-8b61-4cd5-9d32-07652c56306e" providerId="ADAL" clId="{60D42A6B-AE32-4A06-B461-AA9486421C3B}" dt="2026-09-18T06:09:13.314" v="2397" actId="1076"/>
-          <ac:spMkLst>
-            <pc:docMk/>
-            <pc:sldMk cId="2416652295" sldId="263"/>
-            <ac:spMk id="15" creationId="{CBB4D034-4453-9918-E427-6F3BF26F1E67}"/>
-          </ac:spMkLst>
-        </pc:spChg>
-        <pc:spChg chg="mod">
-          <ac:chgData name="SHINOHARA Soshi (篠原 想詩)" userId="309c0b21-8b61-4cd5-9d32-07652c56306e" providerId="ADAL" clId="{60D42A6B-AE32-4A06-B461-AA9486421C3B}" dt="2026-09-18T06:09:17.823" v="2398" actId="1076"/>
-          <ac:spMkLst>
-            <pc:docMk/>
-            <pc:sldMk cId="2416652295" sldId="263"/>
-            <ac:spMk id="17" creationId="{9EA7CA49-8438-F8C9-4C30-426972466047}"/>
-          </ac:spMkLst>
-        </pc:spChg>
-        <pc:spChg chg="mod">
-          <ac:chgData name="SHINOHARA Soshi (篠原 想詩)" userId="309c0b21-8b61-4cd5-9d32-07652c56306e" providerId="ADAL" clId="{60D42A6B-AE32-4A06-B461-AA9486421C3B}" dt="2026-09-18T07:18:17.875" v="2543" actId="1076"/>
-          <ac:spMkLst>
-            <pc:docMk/>
-            <pc:sldMk cId="2416652295" sldId="263"/>
-            <ac:spMk id="19" creationId="{0E391B8E-AB01-AC75-D1D9-4BA5617A534F}"/>
-          </ac:spMkLst>
-        </pc:spChg>
-        <pc:spChg chg="del mod">
-          <ac:chgData name="SHINOHARA Soshi (篠原 想詩)" userId="309c0b21-8b61-4cd5-9d32-07652c56306e" providerId="ADAL" clId="{60D42A6B-AE32-4A06-B461-AA9486421C3B}" dt="2026-09-18T05:49:37.448" v="1407" actId="21"/>
-          <ac:spMkLst>
-            <pc:docMk/>
-            <pc:sldMk cId="2416652295" sldId="263"/>
-            <ac:spMk id="21" creationId="{0A34CEB6-CCB9-988E-2DFF-1ECD24F42D9F}"/>
-          </ac:spMkLst>
-        </pc:spChg>
-        <pc:spChg chg="del mod">
-          <ac:chgData name="SHINOHARA Soshi (篠原 想詩)" userId="309c0b21-8b61-4cd5-9d32-07652c56306e" providerId="ADAL" clId="{60D42A6B-AE32-4A06-B461-AA9486421C3B}" dt="2026-09-18T05:49:37.448" v="1407" actId="21"/>
-          <ac:spMkLst>
-            <pc:docMk/>
-            <pc:sldMk cId="2416652295" sldId="263"/>
-            <ac:spMk id="23" creationId="{00857F23-C44E-A666-426E-21F27FF95978}"/>
-          </ac:spMkLst>
-        </pc:spChg>
-        <pc:spChg chg="mod">
-          <ac:chgData name="SHINOHARA Soshi (篠原 想詩)" userId="309c0b21-8b61-4cd5-9d32-07652c56306e" providerId="ADAL" clId="{60D42A6B-AE32-4A06-B461-AA9486421C3B}" dt="2026-09-18T05:46:41.920" v="1358" actId="1076"/>
-          <ac:spMkLst>
-            <pc:docMk/>
-            <pc:sldMk cId="2416652295" sldId="263"/>
-            <ac:spMk id="21506" creationId="{BBF3B7B6-7F4A-254F-EB33-2638E125F1E0}"/>
-          </ac:spMkLst>
-        </pc:spChg>
+            <ac:graphicFrameMk id="23" creationId="{A1CE0432-81FE-9A98-8528-48DD5FFDE362}"/>
+          </ac:graphicFrameMkLst>
+        </pc:graphicFrameChg>
       </pc:sldChg>
       <pc:sldChg chg="addSp delSp modSp add mod ord">
-        <pc:chgData name="SHINOHARA Soshi (篠原 想詩)" userId="309c0b21-8b61-4cd5-9d32-07652c56306e" providerId="ADAL" clId="{60D42A6B-AE32-4A06-B461-AA9486421C3B}" dt="2026-09-18T07:27:41.343" v="2583" actId="20577"/>
+        <pc:chgData name="SHINOHARA Soshi (篠原 想詩)" userId="309c0b21-8b61-4cd5-9d32-07652c56306e" providerId="ADAL" clId="{60D42A6B-AE32-4A06-B461-AA9486421C3B}" dt="2026-10-22T09:39:10.204" v="2589" actId="20577"/>
         <pc:sldMkLst>
           <pc:docMk/>
           <pc:sldMk cId="147431364" sldId="264"/>
         </pc:sldMkLst>
-        <pc:spChg chg="add del mod">
-          <ac:chgData name="SHINOHARA Soshi (篠原 想詩)" userId="309c0b21-8b61-4cd5-9d32-07652c56306e" providerId="ADAL" clId="{60D42A6B-AE32-4A06-B461-AA9486421C3B}" dt="2026-09-18T06:07:39.375" v="2340" actId="478"/>
-          <ac:spMkLst>
-            <pc:docMk/>
-            <pc:sldMk cId="147431364" sldId="264"/>
-            <ac:spMk id="3" creationId="{307B1FFF-4372-E844-97E8-30ADF086F187}"/>
-          </ac:spMkLst>
-        </pc:spChg>
-        <pc:spChg chg="del">
-          <ac:chgData name="SHINOHARA Soshi (篠原 想詩)" userId="309c0b21-8b61-4cd5-9d32-07652c56306e" providerId="ADAL" clId="{60D42A6B-AE32-4A06-B461-AA9486421C3B}" dt="2026-09-18T06:07:36.040" v="2337" actId="478"/>
-          <ac:spMkLst>
-            <pc:docMk/>
-            <pc:sldMk cId="147431364" sldId="264"/>
-            <ac:spMk id="5" creationId="{05EB874F-BED0-70CE-2524-0004B0E0A7AB}"/>
-          </ac:spMkLst>
-        </pc:spChg>
         <pc:spChg chg="add mod">
-          <ac:chgData name="SHINOHARA Soshi (篠原 想詩)" userId="309c0b21-8b61-4cd5-9d32-07652c56306e" providerId="ADAL" clId="{60D42A6B-AE32-4A06-B461-AA9486421C3B}" dt="2026-09-18T05:55:29.688" v="1687" actId="1076"/>
-          <ac:spMkLst>
-            <pc:docMk/>
-            <pc:sldMk cId="147431364" sldId="264"/>
-            <ac:spMk id="6" creationId="{9F0FB3CC-52F3-1B56-A3C9-4771819CFED5}"/>
-          </ac:spMkLst>
-        </pc:spChg>
-        <pc:spChg chg="del">
-          <ac:chgData name="SHINOHARA Soshi (篠原 想詩)" userId="309c0b21-8b61-4cd5-9d32-07652c56306e" providerId="ADAL" clId="{60D42A6B-AE32-4A06-B461-AA9486421C3B}" dt="2026-09-18T05:54:43.421" v="1669" actId="478"/>
-          <ac:spMkLst>
-            <pc:docMk/>
-            <pc:sldMk cId="147431364" sldId="264"/>
-            <ac:spMk id="7" creationId="{32051751-D992-8D98-D7B3-5B3E77D972D0}"/>
-          </ac:spMkLst>
-        </pc:spChg>
-        <pc:spChg chg="del">
-          <ac:chgData name="SHINOHARA Soshi (篠原 想詩)" userId="309c0b21-8b61-4cd5-9d32-07652c56306e" providerId="ADAL" clId="{60D42A6B-AE32-4A06-B461-AA9486421C3B}" dt="2026-09-18T05:54:42.710" v="1668" actId="478"/>
-          <ac:spMkLst>
-            <pc:docMk/>
-            <pc:sldMk cId="147431364" sldId="264"/>
-            <ac:spMk id="9" creationId="{40DA71E2-5169-C226-9716-1D29245292DA}"/>
-          </ac:spMkLst>
-        </pc:spChg>
-        <pc:spChg chg="add mod">
-          <ac:chgData name="SHINOHARA Soshi (篠原 想詩)" userId="309c0b21-8b61-4cd5-9d32-07652c56306e" providerId="ADAL" clId="{60D42A6B-AE32-4A06-B461-AA9486421C3B}" dt="2026-09-18T05:57:01.641" v="1782" actId="20577"/>
-          <ac:spMkLst>
-            <pc:docMk/>
-            <pc:sldMk cId="147431364" sldId="264"/>
-            <ac:spMk id="10" creationId="{A99D0592-4AAB-EE9D-86AD-508AC56407B7}"/>
-          </ac:spMkLst>
-        </pc:spChg>
-        <pc:spChg chg="del">
-          <ac:chgData name="SHINOHARA Soshi (篠原 想詩)" userId="309c0b21-8b61-4cd5-9d32-07652c56306e" providerId="ADAL" clId="{60D42A6B-AE32-4A06-B461-AA9486421C3B}" dt="2026-09-18T05:54:42.710" v="1668" actId="478"/>
-          <ac:spMkLst>
-            <pc:docMk/>
-            <pc:sldMk cId="147431364" sldId="264"/>
-            <ac:spMk id="11" creationId="{5A0F1061-0D3B-DF52-4C20-A9727B3AD83E}"/>
-          </ac:spMkLst>
-        </pc:spChg>
-        <pc:spChg chg="del">
-          <ac:chgData name="SHINOHARA Soshi (篠原 想詩)" userId="309c0b21-8b61-4cd5-9d32-07652c56306e" providerId="ADAL" clId="{60D42A6B-AE32-4A06-B461-AA9486421C3B}" dt="2026-09-18T05:54:42.710" v="1668" actId="478"/>
-          <ac:spMkLst>
-            <pc:docMk/>
-            <pc:sldMk cId="147431364" sldId="264"/>
-            <ac:spMk id="13" creationId="{F83BA511-67DA-15B1-A537-77506D5113E2}"/>
-          </ac:spMkLst>
-        </pc:spChg>
-        <pc:spChg chg="add mod">
-          <ac:chgData name="SHINOHARA Soshi (篠原 想詩)" userId="309c0b21-8b61-4cd5-9d32-07652c56306e" providerId="ADAL" clId="{60D42A6B-AE32-4A06-B461-AA9486421C3B}" dt="2026-09-18T06:08:39.880" v="2390" actId="1076"/>
-          <ac:spMkLst>
-            <pc:docMk/>
-            <pc:sldMk cId="147431364" sldId="264"/>
-            <ac:spMk id="14" creationId="{E01BB2FC-B37F-D766-FE9D-4C8FAD15E35A}"/>
-          </ac:spMkLst>
-        </pc:spChg>
-        <pc:spChg chg="del">
-          <ac:chgData name="SHINOHARA Soshi (篠原 想詩)" userId="309c0b21-8b61-4cd5-9d32-07652c56306e" providerId="ADAL" clId="{60D42A6B-AE32-4A06-B461-AA9486421C3B}" dt="2026-09-18T05:54:42.710" v="1668" actId="478"/>
-          <ac:spMkLst>
-            <pc:docMk/>
-            <pc:sldMk cId="147431364" sldId="264"/>
-            <ac:spMk id="15" creationId="{17E3DE3F-0A9D-878D-5147-69C69CDCFAB7}"/>
-          </ac:spMkLst>
-        </pc:spChg>
-        <pc:spChg chg="del">
-          <ac:chgData name="SHINOHARA Soshi (篠原 想詩)" userId="309c0b21-8b61-4cd5-9d32-07652c56306e" providerId="ADAL" clId="{60D42A6B-AE32-4A06-B461-AA9486421C3B}" dt="2026-09-18T05:54:42.710" v="1668" actId="478"/>
-          <ac:spMkLst>
-            <pc:docMk/>
-            <pc:sldMk cId="147431364" sldId="264"/>
-            <ac:spMk id="17" creationId="{F414B563-D382-0346-6704-8887DDD4FEDF}"/>
-          </ac:spMkLst>
-        </pc:spChg>
-        <pc:spChg chg="add mod">
-          <ac:chgData name="SHINOHARA Soshi (篠原 想詩)" userId="309c0b21-8b61-4cd5-9d32-07652c56306e" providerId="ADAL" clId="{60D42A6B-AE32-4A06-B461-AA9486421C3B}" dt="2026-09-18T07:27:41.343" v="2583" actId="20577"/>
-          <ac:spMkLst>
-            <pc:docMk/>
-            <pc:sldMk cId="147431364" sldId="264"/>
-            <ac:spMk id="18" creationId="{65F3A6C4-9A81-1EF9-8F56-E2D36B994E0B}"/>
-          </ac:spMkLst>
-        </pc:spChg>
-        <pc:spChg chg="del">
-          <ac:chgData name="SHINOHARA Soshi (篠原 想詩)" userId="309c0b21-8b61-4cd5-9d32-07652c56306e" providerId="ADAL" clId="{60D42A6B-AE32-4A06-B461-AA9486421C3B}" dt="2026-09-18T05:54:42.710" v="1668" actId="478"/>
-          <ac:spMkLst>
-            <pc:docMk/>
-            <pc:sldMk cId="147431364" sldId="264"/>
-            <ac:spMk id="19" creationId="{3CA7ABDB-9CF4-7419-A3F0-372837F4CA68}"/>
-          </ac:spMkLst>
-        </pc:spChg>
-        <pc:spChg chg="add mod">
-          <ac:chgData name="SHINOHARA Soshi (篠原 想詩)" userId="309c0b21-8b61-4cd5-9d32-07652c56306e" providerId="ADAL" clId="{60D42A6B-AE32-4A06-B461-AA9486421C3B}" dt="2026-09-18T06:08:39.880" v="2390" actId="1076"/>
-          <ac:spMkLst>
-            <pc:docMk/>
-            <pc:sldMk cId="147431364" sldId="264"/>
-            <ac:spMk id="21" creationId="{51637B88-5226-9238-B14D-891D3D348264}"/>
-          </ac:spMkLst>
-        </pc:spChg>
-        <pc:spChg chg="add mod">
-          <ac:chgData name="SHINOHARA Soshi (篠原 想詩)" userId="309c0b21-8b61-4cd5-9d32-07652c56306e" providerId="ADAL" clId="{60D42A6B-AE32-4A06-B461-AA9486421C3B}" dt="2026-09-18T06:08:34.632" v="2389" actId="1076"/>
-          <ac:spMkLst>
-            <pc:docMk/>
-            <pc:sldMk cId="147431364" sldId="264"/>
-            <ac:spMk id="25" creationId="{90B734DB-F072-0773-4A91-F2D0428DC85B}"/>
-          </ac:spMkLst>
-        </pc:spChg>
-        <pc:spChg chg="add">
-          <ac:chgData name="SHINOHARA Soshi (篠原 想詩)" userId="309c0b21-8b61-4cd5-9d32-07652c56306e" providerId="ADAL" clId="{60D42A6B-AE32-4A06-B461-AA9486421C3B}" dt="2026-09-18T06:07:36.711" v="2338" actId="22"/>
-          <ac:spMkLst>
-            <pc:docMk/>
-            <pc:sldMk cId="147431364" sldId="264"/>
-            <ac:spMk id="27" creationId="{4196054C-6AD3-7A06-15DA-5D1815E3D737}"/>
-          </ac:spMkLst>
-        </pc:spChg>
-        <pc:spChg chg="add mod">
-          <ac:chgData name="SHINOHARA Soshi (篠原 想詩)" userId="309c0b21-8b61-4cd5-9d32-07652c56306e" providerId="ADAL" clId="{60D42A6B-AE32-4A06-B461-AA9486421C3B}" dt="2026-09-18T06:08:55.477" v="2393" actId="14100"/>
+          <ac:chgData name="SHINOHARA Soshi (篠原 想詩)" userId="309c0b21-8b61-4cd5-9d32-07652c56306e" providerId="ADAL" clId="{60D42A6B-AE32-4A06-B461-AA9486421C3B}" dt="2026-10-22T09:39:01.380" v="2584" actId="14100"/>
           <ac:spMkLst>
             <pc:docMk/>
             <pc:sldMk cId="147431364" sldId="264"/>
@@ -1116,299 +164,29 @@
           </ac:spMkLst>
         </pc:spChg>
         <pc:spChg chg="mod">
-          <ac:chgData name="SHINOHARA Soshi (篠原 想詩)" userId="309c0b21-8b61-4cd5-9d32-07652c56306e" providerId="ADAL" clId="{60D42A6B-AE32-4A06-B461-AA9486421C3B}" dt="2026-09-18T06:01:54.966" v="2261" actId="207"/>
+          <ac:chgData name="SHINOHARA Soshi (篠原 想詩)" userId="309c0b21-8b61-4cd5-9d32-07652c56306e" providerId="ADAL" clId="{60D42A6B-AE32-4A06-B461-AA9486421C3B}" dt="2026-10-22T09:39:10.204" v="2589" actId="20577"/>
           <ac:spMkLst>
             <pc:docMk/>
             <pc:sldMk cId="147431364" sldId="264"/>
             <ac:spMk id="21506" creationId="{64226943-6F0D-9B1F-EB98-B1CB9F46A659}"/>
           </ac:spMkLst>
         </pc:spChg>
-        <pc:graphicFrameChg chg="add mod modGraphic">
-          <ac:chgData name="SHINOHARA Soshi (篠原 想詩)" userId="309c0b21-8b61-4cd5-9d32-07652c56306e" providerId="ADAL" clId="{60D42A6B-AE32-4A06-B461-AA9486421C3B}" dt="2026-09-18T06:11:57.996" v="2515" actId="20577"/>
-          <ac:graphicFrameMkLst>
-            <pc:docMk/>
-            <pc:sldMk cId="147431364" sldId="264"/>
-            <ac:graphicFrameMk id="23" creationId="{A1CE0432-81FE-9A98-8528-48DD5FFDE362}"/>
-          </ac:graphicFrameMkLst>
-        </pc:graphicFrameChg>
       </pc:sldChg>
-      <pc:sldChg chg="addSp delSp add del mod">
-        <pc:chgData name="SHINOHARA Soshi (篠原 想詩)" userId="309c0b21-8b61-4cd5-9d32-07652c56306e" providerId="ADAL" clId="{60D42A6B-AE32-4A06-B461-AA9486421C3B}" dt="2026-09-18T06:08:57.444" v="2394" actId="47"/>
-        <pc:sldMkLst>
-          <pc:docMk/>
-          <pc:sldMk cId="1314201938" sldId="265"/>
-        </pc:sldMkLst>
-        <pc:spChg chg="del">
-          <ac:chgData name="SHINOHARA Soshi (篠原 想詩)" userId="309c0b21-8b61-4cd5-9d32-07652c56306e" providerId="ADAL" clId="{60D42A6B-AE32-4A06-B461-AA9486421C3B}" dt="2026-09-18T06:05:23.662" v="2314" actId="478"/>
-          <ac:spMkLst>
-            <pc:docMk/>
-            <pc:sldMk cId="1314201938" sldId="265"/>
-            <ac:spMk id="3" creationId="{E7EF5306-233C-D888-C4F9-869857861AC2}"/>
-          </ac:spMkLst>
-        </pc:spChg>
-        <pc:spChg chg="add del">
-          <ac:chgData name="SHINOHARA Soshi (篠原 想詩)" userId="309c0b21-8b61-4cd5-9d32-07652c56306e" providerId="ADAL" clId="{60D42A6B-AE32-4A06-B461-AA9486421C3B}" dt="2026-09-18T06:08:07.935" v="2381" actId="478"/>
-          <ac:spMkLst>
-            <pc:docMk/>
-            <pc:sldMk cId="1314201938" sldId="265"/>
-            <ac:spMk id="5" creationId="{2FA5BB3F-AB34-D2DF-4D36-1FCD30EAFEBF}"/>
-          </ac:spMkLst>
-        </pc:spChg>
-        <pc:spChg chg="del">
-          <ac:chgData name="SHINOHARA Soshi (篠原 想詩)" userId="309c0b21-8b61-4cd5-9d32-07652c56306e" providerId="ADAL" clId="{60D42A6B-AE32-4A06-B461-AA9486421C3B}" dt="2026-09-18T06:05:19.005" v="2313" actId="478"/>
-          <ac:spMkLst>
-            <pc:docMk/>
-            <pc:sldMk cId="1314201938" sldId="265"/>
-            <ac:spMk id="6" creationId="{5A1063EE-9E6D-631E-F8F0-44B6D334FDDF}"/>
-          </ac:spMkLst>
-        </pc:spChg>
-        <pc:spChg chg="del">
-          <ac:chgData name="SHINOHARA Soshi (篠原 想詩)" userId="309c0b21-8b61-4cd5-9d32-07652c56306e" providerId="ADAL" clId="{60D42A6B-AE32-4A06-B461-AA9486421C3B}" dt="2026-09-18T06:05:19.005" v="2313" actId="478"/>
-          <ac:spMkLst>
-            <pc:docMk/>
-            <pc:sldMk cId="1314201938" sldId="265"/>
-            <ac:spMk id="10" creationId="{36257D8E-473D-A3A2-03E5-7CA4F72923D1}"/>
-          </ac:spMkLst>
-        </pc:spChg>
-        <pc:spChg chg="del">
-          <ac:chgData name="SHINOHARA Soshi (篠原 想詩)" userId="309c0b21-8b61-4cd5-9d32-07652c56306e" providerId="ADAL" clId="{60D42A6B-AE32-4A06-B461-AA9486421C3B}" dt="2026-09-18T06:05:19.005" v="2313" actId="478"/>
-          <ac:spMkLst>
-            <pc:docMk/>
-            <pc:sldMk cId="1314201938" sldId="265"/>
-            <ac:spMk id="14" creationId="{97ED53A4-D1E1-F356-C32D-C4DF01E9D78A}"/>
-          </ac:spMkLst>
-        </pc:spChg>
-        <pc:spChg chg="del">
-          <ac:chgData name="SHINOHARA Soshi (篠原 想詩)" userId="309c0b21-8b61-4cd5-9d32-07652c56306e" providerId="ADAL" clId="{60D42A6B-AE32-4A06-B461-AA9486421C3B}" dt="2026-09-18T06:05:19.005" v="2313" actId="478"/>
-          <ac:spMkLst>
-            <pc:docMk/>
-            <pc:sldMk cId="1314201938" sldId="265"/>
-            <ac:spMk id="18" creationId="{C7C043CB-6ECC-E00B-D998-006A6A1A1EE3}"/>
-          </ac:spMkLst>
-        </pc:spChg>
-        <pc:spChg chg="del">
-          <ac:chgData name="SHINOHARA Soshi (篠原 想詩)" userId="309c0b21-8b61-4cd5-9d32-07652c56306e" providerId="ADAL" clId="{60D42A6B-AE32-4A06-B461-AA9486421C3B}" dt="2026-09-18T06:05:19.005" v="2313" actId="478"/>
-          <ac:spMkLst>
-            <pc:docMk/>
-            <pc:sldMk cId="1314201938" sldId="265"/>
-            <ac:spMk id="21" creationId="{01BC4F24-814E-B738-E9F9-62CD2ECE9CD4}"/>
-          </ac:spMkLst>
-        </pc:spChg>
-        <pc:spChg chg="del">
-          <ac:chgData name="SHINOHARA Soshi (篠原 想詩)" userId="309c0b21-8b61-4cd5-9d32-07652c56306e" providerId="ADAL" clId="{60D42A6B-AE32-4A06-B461-AA9486421C3B}" dt="2026-09-18T06:05:30.240" v="2316" actId="478"/>
-          <ac:spMkLst>
-            <pc:docMk/>
-            <pc:sldMk cId="1314201938" sldId="265"/>
-            <ac:spMk id="25" creationId="{5E0BD695-208B-8E25-EE99-545B14AAEDDD}"/>
-          </ac:spMkLst>
-        </pc:spChg>
-        <pc:graphicFrameChg chg="del">
-          <ac:chgData name="SHINOHARA Soshi (篠原 想詩)" userId="309c0b21-8b61-4cd5-9d32-07652c56306e" providerId="ADAL" clId="{60D42A6B-AE32-4A06-B461-AA9486421C3B}" dt="2026-09-18T06:05:27.563" v="2315" actId="478"/>
-          <ac:graphicFrameMkLst>
-            <pc:docMk/>
-            <pc:sldMk cId="1314201938" sldId="265"/>
-            <ac:graphicFrameMk id="23" creationId="{1EE2691D-2C68-50A1-72EA-5FC142209032}"/>
-          </ac:graphicFrameMkLst>
-        </pc:graphicFrameChg>
-      </pc:sldChg>
-      <pc:sldChg chg="addSp delSp modSp add mod">
-        <pc:chgData name="SHINOHARA Soshi (篠原 想詩)" userId="309c0b21-8b61-4cd5-9d32-07652c56306e" providerId="ADAL" clId="{60D42A6B-AE32-4A06-B461-AA9486421C3B}" dt="2026-09-18T06:15:35.154" v="2535" actId="1076"/>
+      <pc:sldChg chg="modSp mod">
+        <pc:chgData name="SHINOHARA Soshi (篠原 想詩)" userId="309c0b21-8b61-4cd5-9d32-07652c56306e" providerId="ADAL" clId="{60D42A6B-AE32-4A06-B461-AA9486421C3B}" dt="2026-10-22T09:42:21.533" v="2631" actId="20577"/>
         <pc:sldMkLst>
           <pc:docMk/>
           <pc:sldMk cId="3249971736" sldId="265"/>
         </pc:sldMkLst>
-        <pc:spChg chg="add del">
-          <ac:chgData name="SHINOHARA Soshi (篠原 想詩)" userId="309c0b21-8b61-4cd5-9d32-07652c56306e" providerId="ADAL" clId="{60D42A6B-AE32-4A06-B461-AA9486421C3B}" dt="2026-09-18T06:10:53.489" v="2476" actId="478"/>
-          <ac:spMkLst>
-            <pc:docMk/>
-            <pc:sldMk cId="3249971736" sldId="265"/>
-            <ac:spMk id="3" creationId="{6455A74A-3145-43E9-0FEA-96984B6C3345}"/>
-          </ac:spMkLst>
-        </pc:spChg>
-        <pc:spChg chg="add del">
-          <ac:chgData name="SHINOHARA Soshi (篠原 想詩)" userId="309c0b21-8b61-4cd5-9d32-07652c56306e" providerId="ADAL" clId="{60D42A6B-AE32-4A06-B461-AA9486421C3B}" dt="2026-09-18T06:10:55.834" v="2477" actId="478"/>
-          <ac:spMkLst>
-            <pc:docMk/>
-            <pc:sldMk cId="3249971736" sldId="265"/>
-            <ac:spMk id="5" creationId="{A951B59B-374D-286A-33A5-2D7F49AA888B}"/>
-          </ac:spMkLst>
-        </pc:spChg>
-        <pc:spChg chg="del">
-          <ac:chgData name="SHINOHARA Soshi (篠原 想詩)" userId="309c0b21-8b61-4cd5-9d32-07652c56306e" providerId="ADAL" clId="{60D42A6B-AE32-4A06-B461-AA9486421C3B}" dt="2026-09-18T06:10:42.448" v="2472" actId="478"/>
-          <ac:spMkLst>
-            <pc:docMk/>
-            <pc:sldMk cId="3249971736" sldId="265"/>
-            <ac:spMk id="6" creationId="{1CF1F0CB-11DA-7A96-97F4-CD39540D3032}"/>
-          </ac:spMkLst>
-        </pc:spChg>
-        <pc:spChg chg="del">
-          <ac:chgData name="SHINOHARA Soshi (篠原 想詩)" userId="309c0b21-8b61-4cd5-9d32-07652c56306e" providerId="ADAL" clId="{60D42A6B-AE32-4A06-B461-AA9486421C3B}" dt="2026-09-18T06:10:42.448" v="2472" actId="478"/>
-          <ac:spMkLst>
-            <pc:docMk/>
-            <pc:sldMk cId="3249971736" sldId="265"/>
-            <ac:spMk id="10" creationId="{9D0F0D21-0F87-47E7-8D1D-9E026C31F900}"/>
-          </ac:spMkLst>
-        </pc:spChg>
-        <pc:spChg chg="del">
-          <ac:chgData name="SHINOHARA Soshi (篠原 想詩)" userId="309c0b21-8b61-4cd5-9d32-07652c56306e" providerId="ADAL" clId="{60D42A6B-AE32-4A06-B461-AA9486421C3B}" dt="2026-09-18T06:10:42.448" v="2472" actId="478"/>
-          <ac:spMkLst>
-            <pc:docMk/>
-            <pc:sldMk cId="3249971736" sldId="265"/>
-            <ac:spMk id="14" creationId="{84292A5C-EF93-1D6D-D96F-63339C36B5DA}"/>
-          </ac:spMkLst>
-        </pc:spChg>
-        <pc:spChg chg="del">
-          <ac:chgData name="SHINOHARA Soshi (篠原 想詩)" userId="309c0b21-8b61-4cd5-9d32-07652c56306e" providerId="ADAL" clId="{60D42A6B-AE32-4A06-B461-AA9486421C3B}" dt="2026-09-18T06:10:42.448" v="2472" actId="478"/>
-          <ac:spMkLst>
-            <pc:docMk/>
-            <pc:sldMk cId="3249971736" sldId="265"/>
-            <ac:spMk id="18" creationId="{000861EA-2373-894B-6A08-36763DE3141E}"/>
-          </ac:spMkLst>
-        </pc:spChg>
-        <pc:spChg chg="del">
-          <ac:chgData name="SHINOHARA Soshi (篠原 想詩)" userId="309c0b21-8b61-4cd5-9d32-07652c56306e" providerId="ADAL" clId="{60D42A6B-AE32-4A06-B461-AA9486421C3B}" dt="2026-09-18T06:10:42.448" v="2472" actId="478"/>
-          <ac:spMkLst>
-            <pc:docMk/>
-            <pc:sldMk cId="3249971736" sldId="265"/>
-            <ac:spMk id="21" creationId="{70FA87B6-0C29-4AC4-3931-2C2B3D9862AC}"/>
-          </ac:spMkLst>
-        </pc:spChg>
-        <pc:spChg chg="del">
-          <ac:chgData name="SHINOHARA Soshi (篠原 想詩)" userId="309c0b21-8b61-4cd5-9d32-07652c56306e" providerId="ADAL" clId="{60D42A6B-AE32-4A06-B461-AA9486421C3B}" dt="2026-09-18T06:10:42.448" v="2472" actId="478"/>
-          <ac:spMkLst>
-            <pc:docMk/>
-            <pc:sldMk cId="3249971736" sldId="265"/>
-            <ac:spMk id="25" creationId="{892490C8-31AD-E3FF-0ABF-416A7E172DAD}"/>
-          </ac:spMkLst>
-        </pc:spChg>
-        <pc:spChg chg="del mod">
-          <ac:chgData name="SHINOHARA Soshi (篠原 想詩)" userId="309c0b21-8b61-4cd5-9d32-07652c56306e" providerId="ADAL" clId="{60D42A6B-AE32-4A06-B461-AA9486421C3B}" dt="2026-09-18T06:10:40.390" v="2471" actId="478"/>
-          <ac:spMkLst>
-            <pc:docMk/>
-            <pc:sldMk cId="3249971736" sldId="265"/>
-            <ac:spMk id="29" creationId="{B46D97C3-DBD4-B9B1-258F-034692CBEEA3}"/>
-          </ac:spMkLst>
-        </pc:spChg>
-        <pc:spChg chg="mod">
-          <ac:chgData name="SHINOHARA Soshi (篠原 想詩)" userId="309c0b21-8b61-4cd5-9d32-07652c56306e" providerId="ADAL" clId="{60D42A6B-AE32-4A06-B461-AA9486421C3B}" dt="2026-09-18T06:11:01.130" v="2507" actId="20577"/>
-          <ac:spMkLst>
-            <pc:docMk/>
-            <pc:sldMk cId="3249971736" sldId="265"/>
-            <ac:spMk id="21506" creationId="{EE83C36C-337B-3CAA-0B83-0A1517A40289}"/>
-          </ac:spMkLst>
-        </pc:spChg>
-        <pc:graphicFrameChg chg="add mod modGraphic">
-          <ac:chgData name="SHINOHARA Soshi (篠原 想詩)" userId="309c0b21-8b61-4cd5-9d32-07652c56306e" providerId="ADAL" clId="{60D42A6B-AE32-4A06-B461-AA9486421C3B}" dt="2026-09-18T06:15:35.154" v="2535" actId="1076"/>
+        <pc:graphicFrameChg chg="modGraphic">
+          <ac:chgData name="SHINOHARA Soshi (篠原 想詩)" userId="309c0b21-8b61-4cd5-9d32-07652c56306e" providerId="ADAL" clId="{60D42A6B-AE32-4A06-B461-AA9486421C3B}" dt="2026-10-22T09:42:21.533" v="2631" actId="20577"/>
           <ac:graphicFrameMkLst>
             <pc:docMk/>
             <pc:sldMk cId="3249971736" sldId="265"/>
             <ac:graphicFrameMk id="8" creationId="{58D35AA5-77A7-64BC-8911-FEFE11A99615}"/>
           </ac:graphicFrameMkLst>
         </pc:graphicFrameChg>
-        <pc:graphicFrameChg chg="del">
-          <ac:chgData name="SHINOHARA Soshi (篠原 想詩)" userId="309c0b21-8b61-4cd5-9d32-07652c56306e" providerId="ADAL" clId="{60D42A6B-AE32-4A06-B461-AA9486421C3B}" dt="2026-09-18T06:10:42.448" v="2472" actId="478"/>
-          <ac:graphicFrameMkLst>
-            <pc:docMk/>
-            <pc:sldMk cId="3249971736" sldId="265"/>
-            <ac:graphicFrameMk id="23" creationId="{CA1BBA50-64D8-27C8-734A-9DB62746C46C}"/>
-          </ac:graphicFrameMkLst>
-        </pc:graphicFrameChg>
       </pc:sldChg>
-      <pc:sldMasterChg chg="del delSldLayout">
-        <pc:chgData name="SHINOHARA Soshi (篠原 想詩)" userId="309c0b21-8b61-4cd5-9d32-07652c56306e" providerId="ADAL" clId="{60D42A6B-AE32-4A06-B461-AA9486421C3B}" dt="2026-09-18T06:09:01.320" v="2396" actId="47"/>
-        <pc:sldMasterMkLst>
-          <pc:docMk/>
-          <pc:sldMasterMk cId="3019807980" sldId="2147483648"/>
-        </pc:sldMasterMkLst>
-        <pc:sldLayoutChg chg="del">
-          <pc:chgData name="SHINOHARA Soshi (篠原 想詩)" userId="309c0b21-8b61-4cd5-9d32-07652c56306e" providerId="ADAL" clId="{60D42A6B-AE32-4A06-B461-AA9486421C3B}" dt="2026-09-18T06:09:01.320" v="2396" actId="47"/>
-          <pc:sldLayoutMkLst>
-            <pc:docMk/>
-            <pc:sldMasterMk cId="3019807980" sldId="2147483648"/>
-            <pc:sldLayoutMk cId="181740245" sldId="2147483649"/>
-          </pc:sldLayoutMkLst>
-        </pc:sldLayoutChg>
-        <pc:sldLayoutChg chg="del">
-          <pc:chgData name="SHINOHARA Soshi (篠原 想詩)" userId="309c0b21-8b61-4cd5-9d32-07652c56306e" providerId="ADAL" clId="{60D42A6B-AE32-4A06-B461-AA9486421C3B}" dt="2026-09-18T06:09:01.320" v="2396" actId="47"/>
-          <pc:sldLayoutMkLst>
-            <pc:docMk/>
-            <pc:sldMasterMk cId="3019807980" sldId="2147483648"/>
-            <pc:sldLayoutMk cId="1262986352" sldId="2147483650"/>
-          </pc:sldLayoutMkLst>
-        </pc:sldLayoutChg>
-        <pc:sldLayoutChg chg="del">
-          <pc:chgData name="SHINOHARA Soshi (篠原 想詩)" userId="309c0b21-8b61-4cd5-9d32-07652c56306e" providerId="ADAL" clId="{60D42A6B-AE32-4A06-B461-AA9486421C3B}" dt="2026-09-18T06:09:01.320" v="2396" actId="47"/>
-          <pc:sldLayoutMkLst>
-            <pc:docMk/>
-            <pc:sldMasterMk cId="3019807980" sldId="2147483648"/>
-            <pc:sldLayoutMk cId="1801365498" sldId="2147483651"/>
-          </pc:sldLayoutMkLst>
-        </pc:sldLayoutChg>
-        <pc:sldLayoutChg chg="del">
-          <pc:chgData name="SHINOHARA Soshi (篠原 想詩)" userId="309c0b21-8b61-4cd5-9d32-07652c56306e" providerId="ADAL" clId="{60D42A6B-AE32-4A06-B461-AA9486421C3B}" dt="2026-09-18T06:09:01.320" v="2396" actId="47"/>
-          <pc:sldLayoutMkLst>
-            <pc:docMk/>
-            <pc:sldMasterMk cId="3019807980" sldId="2147483648"/>
-            <pc:sldLayoutMk cId="1707429675" sldId="2147483652"/>
-          </pc:sldLayoutMkLst>
-        </pc:sldLayoutChg>
-        <pc:sldLayoutChg chg="del">
-          <pc:chgData name="SHINOHARA Soshi (篠原 想詩)" userId="309c0b21-8b61-4cd5-9d32-07652c56306e" providerId="ADAL" clId="{60D42A6B-AE32-4A06-B461-AA9486421C3B}" dt="2026-09-18T06:09:01.320" v="2396" actId="47"/>
-          <pc:sldLayoutMkLst>
-            <pc:docMk/>
-            <pc:sldMasterMk cId="3019807980" sldId="2147483648"/>
-            <pc:sldLayoutMk cId="3447607662" sldId="2147483653"/>
-          </pc:sldLayoutMkLst>
-        </pc:sldLayoutChg>
-        <pc:sldLayoutChg chg="del">
-          <pc:chgData name="SHINOHARA Soshi (篠原 想詩)" userId="309c0b21-8b61-4cd5-9d32-07652c56306e" providerId="ADAL" clId="{60D42A6B-AE32-4A06-B461-AA9486421C3B}" dt="2026-09-18T06:09:01.320" v="2396" actId="47"/>
-          <pc:sldLayoutMkLst>
-            <pc:docMk/>
-            <pc:sldMasterMk cId="3019807980" sldId="2147483648"/>
-            <pc:sldLayoutMk cId="3774007086" sldId="2147483654"/>
-          </pc:sldLayoutMkLst>
-        </pc:sldLayoutChg>
-        <pc:sldLayoutChg chg="del">
-          <pc:chgData name="SHINOHARA Soshi (篠原 想詩)" userId="309c0b21-8b61-4cd5-9d32-07652c56306e" providerId="ADAL" clId="{60D42A6B-AE32-4A06-B461-AA9486421C3B}" dt="2026-09-18T06:09:01.320" v="2396" actId="47"/>
-          <pc:sldLayoutMkLst>
-            <pc:docMk/>
-            <pc:sldMasterMk cId="3019807980" sldId="2147483648"/>
-            <pc:sldLayoutMk cId="2525697723" sldId="2147483655"/>
-          </pc:sldLayoutMkLst>
-        </pc:sldLayoutChg>
-        <pc:sldLayoutChg chg="del">
-          <pc:chgData name="SHINOHARA Soshi (篠原 想詩)" userId="309c0b21-8b61-4cd5-9d32-07652c56306e" providerId="ADAL" clId="{60D42A6B-AE32-4A06-B461-AA9486421C3B}" dt="2026-09-18T06:09:01.320" v="2396" actId="47"/>
-          <pc:sldLayoutMkLst>
-            <pc:docMk/>
-            <pc:sldMasterMk cId="3019807980" sldId="2147483648"/>
-            <pc:sldLayoutMk cId="1592917292" sldId="2147483656"/>
-          </pc:sldLayoutMkLst>
-        </pc:sldLayoutChg>
-        <pc:sldLayoutChg chg="del">
-          <pc:chgData name="SHINOHARA Soshi (篠原 想詩)" userId="309c0b21-8b61-4cd5-9d32-07652c56306e" providerId="ADAL" clId="{60D42A6B-AE32-4A06-B461-AA9486421C3B}" dt="2026-09-18T06:09:01.320" v="2396" actId="47"/>
-          <pc:sldLayoutMkLst>
-            <pc:docMk/>
-            <pc:sldMasterMk cId="3019807980" sldId="2147483648"/>
-            <pc:sldLayoutMk cId="2073493225" sldId="2147483657"/>
-          </pc:sldLayoutMkLst>
-        </pc:sldLayoutChg>
-        <pc:sldLayoutChg chg="del">
-          <pc:chgData name="SHINOHARA Soshi (篠原 想詩)" userId="309c0b21-8b61-4cd5-9d32-07652c56306e" providerId="ADAL" clId="{60D42A6B-AE32-4A06-B461-AA9486421C3B}" dt="2026-09-18T06:09:01.320" v="2396" actId="47"/>
-          <pc:sldLayoutMkLst>
-            <pc:docMk/>
-            <pc:sldMasterMk cId="3019807980" sldId="2147483648"/>
-            <pc:sldLayoutMk cId="468604226" sldId="2147483658"/>
-          </pc:sldLayoutMkLst>
-        </pc:sldLayoutChg>
-        <pc:sldLayoutChg chg="del">
-          <pc:chgData name="SHINOHARA Soshi (篠原 想詩)" userId="309c0b21-8b61-4cd5-9d32-07652c56306e" providerId="ADAL" clId="{60D42A6B-AE32-4A06-B461-AA9486421C3B}" dt="2026-09-18T06:09:01.320" v="2396" actId="47"/>
-          <pc:sldLayoutMkLst>
-            <pc:docMk/>
-            <pc:sldMasterMk cId="3019807980" sldId="2147483648"/>
-            <pc:sldLayoutMk cId="1426030442" sldId="2147483659"/>
-          </pc:sldLayoutMkLst>
-        </pc:sldLayoutChg>
-      </pc:sldMasterChg>
     </pc:docChg>
   </pc:docChgLst>
 </pc:chgInfo>
@@ -5771,7 +4549,7 @@
                 <a:ea typeface="Amazon Ember" panose="020B0603020204020204" pitchFamily="34" charset="0"/>
                 <a:cs typeface="Amazon Ember" panose="020B0603020204020204" pitchFamily="34" charset="0"/>
               </a:rPr>
-              <a:t>定型業務と報告期間の位置づけ</a:t>
+              <a:t>報告の位置づけ　三つの業務テーマ</a:t>
             </a:r>
             <a:endParaRPr lang="ja-JP" altLang="en-US" sz="3600" dirty="0">
               <a:solidFill>
@@ -5876,7 +4654,7 @@
                 <a:latin typeface="Meiryo"/>
                 <a:ea typeface="Meiryo"/>
               </a:rPr>
-              <a:t>引継ぎ3テーマを集中遂行：0確認マクロは運用確定、管理手順書は案2冊(未承認)、棚卸しマクロは実機検証待ち。</a:t>
+              <a:t>結論：下期は与えられた三つの業務テーマを中心に進捗。</a:t>
             </a:r>
             <a:endParaRPr lang="en-US" altLang="ja-JP" b="0" dirty="0">
               <a:solidFill>
@@ -5903,7 +4681,7 @@
                 <a:latin typeface="Meiryo"/>
                 <a:ea typeface="Meiryo"/>
               </a:rPr>
-              <a:t>定型業務はB列差異修正1件(9/24・L2限定)。設計変更は0件で、記録・基盤の運用と整備に集中した(下表)。</a:t>
+              <a:t>棚卸(EGPro-MES差異確認)は上期からの継続テーマ。以降、管理表のテーマ順に報告する。</a:t>
             </a:r>
             <a:endParaRPr lang="en-US" altLang="ja-JP" b="0" dirty="0">
               <a:solidFill>
@@ -5953,756 +4731,262 @@
           </a:p>
         </p:txBody>
       </p:sp>
-      <p:graphicFrame>
-        <p:nvGraphicFramePr>
-          <p:cNvPr id="23" name="T59">
+      <p:sp>
+        <p:nvSpPr>
+          <p:cNvPr id="9001" name="TB_theme_list">
             <a:extLst>
               <a:ext uri="{FF2B5EF4-FFF2-40B4-BE49-F238E27FC236}">
-                <a16:creationId xmlns:a16="http://schemas.microsoft.com/office/drawing/2014/main" id="{A1CE0432-81FE-9A98-8528-48DD5FFDE362}"/>
+                <a16:creationId xmlns:a16="http://schemas.microsoft.com/office/drawing/2014/main" id="{334C37F2-BE3E-BFC0-CAB9-D3917FDC0606}"/>
               </a:ext>
             </a:extLst>
           </p:cNvPr>
-          <p:cNvGraphicFramePr>
-            <a:graphicFrameLocks noGrp="1"/>
-          </p:cNvGraphicFramePr>
-          <p:nvPr>
-            <p:extLst>
-              <p:ext uri="{D42A27DB-BD31-4B8C-83A1-F6EECF244321}">
-                <p14:modId xmlns:p14="http://schemas.microsoft.com/office/powerpoint/2010/main" val="2037148714"/>
-              </p:ext>
-            </p:extLst>
-          </p:nvPr>
-        </p:nvGraphicFramePr>
-        <p:xfrm>
-          <a:off x="540000" y="2800000"/>
-          <a:ext cx="10656000" cy="2060000"/>
-        </p:xfrm>
-        <a:graphic>
-          <a:graphicData uri="http://schemas.openxmlformats.org/drawingml/2006/table">
-            <a:tbl>
-              <a:tblPr firstRow="1"/>
-              <a:tblGrid>
-                <a:gridCol w="3200000">
-                  <a:extLst>
-                    <a:ext uri="{9D8B030D-6E8A-4147-A177-3AD203B41FA5}">
-                      <a16:colId xmlns:a16="http://schemas.microsoft.com/office/drawing/2014/main" val="20000"/>
-                    </a:ext>
-                  </a:extLst>
-                </a:gridCol>
-                <a:gridCol w="2900000">
-                  <a:extLst>
-                    <a:ext uri="{9D8B030D-6E8A-4147-A177-3AD203B41FA5}">
-                      <a16:colId xmlns:a16="http://schemas.microsoft.com/office/drawing/2014/main" val="20001"/>
-                    </a:ext>
-                  </a:extLst>
-                </a:gridCol>
-                <a:gridCol w="4556000">
-                  <a:extLst>
-                    <a:ext uri="{9D8B030D-6E8A-4147-A177-3AD203B41FA5}">
-                      <a16:colId xmlns:a16="http://schemas.microsoft.com/office/drawing/2014/main" val="20002"/>
-                    </a:ext>
-                  </a:extLst>
-                </a:gridCol>
-              </a:tblGrid>
-              <a:tr h="460000">
-                <a:tc>
-                  <a:txBody>
-                    <a:bodyPr/>
-                    <a:lstStyle/>
-                    <a:p>
-                      <a:pPr algn="l"/>
-                      <a:r>
-                        <a:rPr lang="ja-JP" altLang="en-US" sz="1400" b="1" dirty="0">
-                          <a:solidFill>
-                            <a:srgbClr val="000000"/>
-                          </a:solidFill>
-                          <a:latin typeface="Meiryo"/>
-                          <a:ea typeface="Meiryo"/>
-                        </a:rPr>
-                        <a:t>業務</a:t>
-                      </a:r>
-                    </a:p>
-                  </a:txBody>
-                  <a:tcPr marL="72000" marR="72000" marT="36000" marB="36000" anchor="ctr">
-                    <a:lnL w="9525" cap="flat">
-                      <a:solidFill>
-                        <a:srgbClr val="9B9B9B"/>
-                      </a:solidFill>
-                    </a:lnL>
-                    <a:lnR w="9525" cap="flat">
-                      <a:solidFill>
-                        <a:srgbClr val="9B9B9B"/>
-                      </a:solidFill>
-                    </a:lnR>
-                    <a:lnT w="9525" cap="flat">
-                      <a:solidFill>
-                        <a:srgbClr val="9B9B9B"/>
-                      </a:solidFill>
-                    </a:lnT>
-                    <a:lnB w="9525" cap="flat">
-                      <a:solidFill>
-                        <a:srgbClr val="9B9B9B"/>
-                      </a:solidFill>
-                    </a:lnB>
-                    <a:solidFill>
-                      <a:srgbClr val="E9E9E9"/>
-                    </a:solidFill>
-                  </a:tcPr>
-                </a:tc>
-                <a:tc>
-                  <a:txBody>
-                    <a:bodyPr/>
-                    <a:lstStyle/>
-                    <a:p>
-                      <a:pPr algn="l"/>
-                      <a:r>
-                        <a:rPr lang="ja-JP" altLang="en-US" sz="1400" b="1" dirty="0">
-                          <a:solidFill>
-                            <a:srgbClr val="000000"/>
-                          </a:solidFill>
-                          <a:latin typeface="Meiryo"/>
-                          <a:ea typeface="Meiryo"/>
-                        </a:rPr>
-                        <a:t>9/18以降の実績</a:t>
-                      </a:r>
-                    </a:p>
-                  </a:txBody>
-                  <a:tcPr marL="72000" marR="72000" marT="36000" marB="36000" anchor="ctr">
-                    <a:lnL w="9525" cap="flat">
-                      <a:solidFill>
-                        <a:srgbClr val="9B9B9B"/>
-                      </a:solidFill>
-                    </a:lnL>
-                    <a:lnR w="9525" cap="flat">
-                      <a:solidFill>
-                        <a:srgbClr val="9B9B9B"/>
-                      </a:solidFill>
-                    </a:lnR>
-                    <a:lnT w="9525" cap="flat">
-                      <a:solidFill>
-                        <a:srgbClr val="9B9B9B"/>
-                      </a:solidFill>
-                    </a:lnT>
-                    <a:lnB w="9525" cap="flat">
-                      <a:solidFill>
-                        <a:srgbClr val="9B9B9B"/>
-                      </a:solidFill>
-                    </a:lnB>
-                    <a:solidFill>
-                      <a:srgbClr val="E9E9E9"/>
-                    </a:solidFill>
-                  </a:tcPr>
-                </a:tc>
-                <a:tc>
-                  <a:txBody>
-                    <a:bodyPr/>
-                    <a:lstStyle/>
-                    <a:p>
-                      <a:pPr algn="l"/>
-                      <a:r>
-                        <a:rPr lang="ja-JP" altLang="en-US" sz="1400" b="1" dirty="0">
-                          <a:solidFill>
-                            <a:srgbClr val="000000"/>
-                          </a:solidFill>
-                          <a:latin typeface="Meiryo"/>
-                          <a:ea typeface="Meiryo"/>
-                        </a:rPr>
-                        <a:t>備考</a:t>
-                      </a:r>
-                    </a:p>
-                  </a:txBody>
-                  <a:tcPr marL="72000" marR="72000" marT="36000" marB="36000" anchor="ctr">
-                    <a:lnL w="9525" cap="flat">
-                      <a:solidFill>
-                        <a:srgbClr val="9B9B9B"/>
-                      </a:solidFill>
-                    </a:lnL>
-                    <a:lnR w="9525" cap="flat">
-                      <a:solidFill>
-                        <a:srgbClr val="9B9B9B"/>
-                      </a:solidFill>
-                    </a:lnR>
-                    <a:lnT w="9525" cap="flat">
-                      <a:solidFill>
-                        <a:srgbClr val="9B9B9B"/>
-                      </a:solidFill>
-                    </a:lnT>
-                    <a:lnB w="9525" cap="flat">
-                      <a:solidFill>
-                        <a:srgbClr val="9B9B9B"/>
-                      </a:solidFill>
-                    </a:lnB>
-                    <a:solidFill>
-                      <a:srgbClr val="E9E9E9"/>
-                    </a:solidFill>
-                  </a:tcPr>
-                </a:tc>
-                <a:extLst>
-                  <a:ext uri="{0D108BD9-81ED-4DB2-BD59-A6C34878D82A}">
-                    <a16:rowId xmlns:a16="http://schemas.microsoft.com/office/drawing/2014/main" val="10000"/>
-                  </a:ext>
-                </a:extLst>
-              </a:tr>
-              <a:tr h="400000">
-                <a:tc>
-                  <a:txBody>
-                    <a:bodyPr/>
-                    <a:lstStyle/>
-                    <a:p>
-                      <a:pPr algn="l"/>
-                      <a:r>
-                        <a:rPr lang="ja-JP" altLang="en-US" sz="1400" b="0" dirty="0">
-                          <a:solidFill>
-                            <a:srgbClr val="000000"/>
-                          </a:solidFill>
-                          <a:latin typeface="Meiryo"/>
-                          <a:ea typeface="Meiryo"/>
-                        </a:rPr>
-                        <a:t>JOB作成・不足部品リスト</a:t>
-                      </a:r>
-                    </a:p>
-                  </a:txBody>
-                  <a:tcPr marL="72000" marR="72000" marT="36000" marB="36000" anchor="ctr">
-                    <a:lnL w="9525" cap="flat">
-                      <a:solidFill>
-                        <a:srgbClr val="9B9B9B"/>
-                      </a:solidFill>
-                    </a:lnL>
-                    <a:lnR w="9525" cap="flat">
-                      <a:solidFill>
-                        <a:srgbClr val="9B9B9B"/>
-                      </a:solidFill>
-                    </a:lnR>
-                    <a:lnT w="9525" cap="flat">
-                      <a:solidFill>
-                        <a:srgbClr val="9B9B9B"/>
-                      </a:solidFill>
-                    </a:lnT>
-                    <a:lnB w="9525" cap="flat">
-                      <a:solidFill>
-                        <a:srgbClr val="9B9B9B"/>
-                      </a:solidFill>
-                    </a:lnB>
-                    <a:solidFill>
-                      <a:srgbClr val="FFFFFF"/>
-                    </a:solidFill>
-                  </a:tcPr>
-                </a:tc>
-                <a:tc>
-                  <a:txBody>
-                    <a:bodyPr/>
-                    <a:lstStyle/>
-                    <a:p>
-                      <a:pPr algn="l"/>
-                      <a:r>
-                        <a:rPr lang="ja-JP" altLang="en-US" sz="1400" b="0" dirty="0">
-                          <a:solidFill>
-                            <a:srgbClr val="000000"/>
-                          </a:solidFill>
-                          <a:latin typeface="Meiryo"/>
-                          <a:ea typeface="Meiryo"/>
-                        </a:rPr>
-                        <a:t>B列差異修正1件(9/24)</a:t>
-                      </a:r>
-                    </a:p>
-                  </a:txBody>
-                  <a:tcPr marL="72000" marR="72000" marT="36000" marB="36000" anchor="ctr">
-                    <a:lnL w="9525" cap="flat">
-                      <a:solidFill>
-                        <a:srgbClr val="9B9B9B"/>
-                      </a:solidFill>
-                    </a:lnL>
-                    <a:lnR w="9525" cap="flat">
-                      <a:solidFill>
-                        <a:srgbClr val="9B9B9B"/>
-                      </a:solidFill>
-                    </a:lnR>
-                    <a:lnT w="9525" cap="flat">
-                      <a:solidFill>
-                        <a:srgbClr val="9B9B9B"/>
-                      </a:solidFill>
-                    </a:lnT>
-                    <a:lnB w="9525" cap="flat">
-                      <a:solidFill>
-                        <a:srgbClr val="9B9B9B"/>
-                      </a:solidFill>
-                    </a:lnB>
-                    <a:solidFill>
-                      <a:srgbClr val="FFFFFF"/>
-                    </a:solidFill>
-                  </a:tcPr>
-                </a:tc>
-                <a:tc>
-                  <a:txBody>
-                    <a:bodyPr/>
-                    <a:lstStyle/>
-                    <a:p>
-                      <a:pPr algn="l"/>
-                      <a:r>
-                        <a:rPr lang="ja-JP" altLang="en-US" sz="1400" b="0" dirty="0">
-                          <a:solidFill>
-                            <a:srgbClr val="000000"/>
-                          </a:solidFill>
-                          <a:latin typeface="Meiryo"/>
-                          <a:ea typeface="Meiryo"/>
-                        </a:rPr>
-                        <a:t>L2限定。恒久運用は11月以降</a:t>
-                      </a:r>
-                    </a:p>
-                  </a:txBody>
-                  <a:tcPr marL="72000" marR="72000" marT="36000" marB="36000" anchor="ctr">
-                    <a:lnL w="9525" cap="flat">
-                      <a:solidFill>
-                        <a:srgbClr val="9B9B9B"/>
-                      </a:solidFill>
-                    </a:lnL>
-                    <a:lnR w="9525" cap="flat">
-                      <a:solidFill>
-                        <a:srgbClr val="9B9B9B"/>
-                      </a:solidFill>
-                    </a:lnR>
-                    <a:lnT w="9525" cap="flat">
-                      <a:solidFill>
-                        <a:srgbClr val="9B9B9B"/>
-                      </a:solidFill>
-                    </a:lnT>
-                    <a:lnB w="9525" cap="flat">
-                      <a:solidFill>
-                        <a:srgbClr val="9B9B9B"/>
-                      </a:solidFill>
-                    </a:lnB>
-                    <a:solidFill>
-                      <a:srgbClr val="FFFFFF"/>
-                    </a:solidFill>
-                  </a:tcPr>
-                </a:tc>
-                <a:extLst>
-                  <a:ext uri="{0D108BD9-81ED-4DB2-BD59-A6C34878D82A}">
-                    <a16:rowId xmlns:a16="http://schemas.microsoft.com/office/drawing/2014/main" val="10001"/>
-                  </a:ext>
-                </a:extLst>
-              </a:tr>
-              <a:tr h="400000">
-                <a:tc>
-                  <a:txBody>
-                    <a:bodyPr/>
-                    <a:lstStyle/>
-                    <a:p>
-                      <a:pPr algn="l"/>
-                      <a:r>
-                        <a:rPr lang="ja-JP" altLang="en-US" sz="1400" b="0" dirty="0">
-                          <a:solidFill>
-                            <a:srgbClr val="000000"/>
-                          </a:solidFill>
-                          <a:latin typeface="Meiryo"/>
-                          <a:ea typeface="Meiryo"/>
-                        </a:rPr>
-                        <a:t>記録の運用</a:t>
-                      </a:r>
-                    </a:p>
-                  </a:txBody>
-                  <a:tcPr marL="72000" marR="72000" marT="36000" marB="36000" anchor="ctr">
-                    <a:lnL w="9525" cap="flat">
-                      <a:solidFill>
-                        <a:srgbClr val="9B9B9B"/>
-                      </a:solidFill>
-                    </a:lnL>
-                    <a:lnR w="9525" cap="flat">
-                      <a:solidFill>
-                        <a:srgbClr val="9B9B9B"/>
-                      </a:solidFill>
-                    </a:lnR>
-                    <a:lnT w="9525" cap="flat">
-                      <a:solidFill>
-                        <a:srgbClr val="9B9B9B"/>
-                      </a:solidFill>
-                    </a:lnT>
-                    <a:lnB w="9525" cap="flat">
-                      <a:solidFill>
-                        <a:srgbClr val="9B9B9B"/>
-                      </a:solidFill>
-                    </a:lnB>
-                    <a:solidFill>
-                      <a:srgbClr val="FFFFFF"/>
-                    </a:solidFill>
-                  </a:tcPr>
-                </a:tc>
-                <a:tc>
-                  <a:txBody>
-                    <a:bodyPr/>
-                    <a:lstStyle/>
-                    <a:p>
-                      <a:pPr algn="l"/>
-                      <a:r>
-                        <a:rPr lang="ja-JP" altLang="en-US" sz="1400" b="0" dirty="0">
-                          <a:solidFill>
-                            <a:srgbClr val="000000"/>
-                          </a:solidFill>
-                          <a:latin typeface="Meiryo"/>
-                          <a:ea typeface="Meiryo"/>
-                        </a:rPr>
-                        <a:t>日報15本/週報3本</a:t>
-                      </a:r>
-                    </a:p>
-                  </a:txBody>
-                  <a:tcPr marL="72000" marR="72000" marT="36000" marB="36000" anchor="ctr">
-                    <a:lnL w="9525" cap="flat">
-                      <a:solidFill>
-                        <a:srgbClr val="9B9B9B"/>
-                      </a:solidFill>
-                    </a:lnL>
-                    <a:lnR w="9525" cap="flat">
-                      <a:solidFill>
-                        <a:srgbClr val="9B9B9B"/>
-                      </a:solidFill>
-                    </a:lnR>
-                    <a:lnT w="9525" cap="flat">
-                      <a:solidFill>
-                        <a:srgbClr val="9B9B9B"/>
-                      </a:solidFill>
-                    </a:lnT>
-                    <a:lnB w="9525" cap="flat">
-                      <a:solidFill>
-                        <a:srgbClr val="9B9B9B"/>
-                      </a:solidFill>
-                    </a:lnB>
-                    <a:solidFill>
-                      <a:srgbClr val="FFFFFF"/>
-                    </a:solidFill>
-                  </a:tcPr>
-                </a:tc>
-                <a:tc>
-                  <a:txBody>
-                    <a:bodyPr/>
-                    <a:lstStyle/>
-                    <a:p>
-                      <a:pPr algn="l"/>
-                      <a:r>
-                        <a:rPr lang="ja-JP" altLang="en-US" sz="1400" b="0" dirty="0">
-                          <a:solidFill>
-                            <a:srgbClr val="000000"/>
-                          </a:solidFill>
-                          <a:latin typeface="Meiryo"/>
-                          <a:ea typeface="Meiryo"/>
-                        </a:rPr>
-                        <a:t>毎日作成。W42は完了済み</a:t>
-                      </a:r>
-                    </a:p>
-                  </a:txBody>
-                  <a:tcPr marL="72000" marR="72000" marT="36000" marB="36000" anchor="ctr">
-                    <a:lnL w="9525" cap="flat">
-                      <a:solidFill>
-                        <a:srgbClr val="9B9B9B"/>
-                      </a:solidFill>
-                    </a:lnL>
-                    <a:lnR w="9525" cap="flat">
-                      <a:solidFill>
-                        <a:srgbClr val="9B9B9B"/>
-                      </a:solidFill>
-                    </a:lnR>
-                    <a:lnT w="9525" cap="flat">
-                      <a:solidFill>
-                        <a:srgbClr val="9B9B9B"/>
-                      </a:solidFill>
-                    </a:lnT>
-                    <a:lnB w="9525" cap="flat">
-                      <a:solidFill>
-                        <a:srgbClr val="9B9B9B"/>
-                      </a:solidFill>
-                    </a:lnB>
-                    <a:solidFill>
-                      <a:srgbClr val="FFFFFF"/>
-                    </a:solidFill>
-                  </a:tcPr>
-                </a:tc>
-                <a:extLst>
-                  <a:ext uri="{0D108BD9-81ED-4DB2-BD59-A6C34878D82A}">
-                    <a16:rowId xmlns:a16="http://schemas.microsoft.com/office/drawing/2014/main" val="10002"/>
-                  </a:ext>
-                </a:extLst>
-              </a:tr>
-              <a:tr h="400000">
-                <a:tc>
-                  <a:txBody>
-                    <a:bodyPr/>
-                    <a:lstStyle/>
-                    <a:p>
-                      <a:pPr algn="l"/>
-                      <a:r>
-                        <a:rPr lang="ja-JP" altLang="en-US" sz="1400" b="0" dirty="0">
-                          <a:solidFill>
-                            <a:srgbClr val="000000"/>
-                          </a:solidFill>
-                          <a:latin typeface="Meiryo"/>
-                          <a:ea typeface="Meiryo"/>
-                        </a:rPr>
-                        <a:t>保管庫のGitHub移管</a:t>
-                      </a:r>
-                    </a:p>
-                  </a:txBody>
-                  <a:tcPr marL="72000" marR="72000" marT="36000" marB="36000" anchor="ctr">
-                    <a:lnL w="9525" cap="flat">
-                      <a:solidFill>
-                        <a:srgbClr val="9B9B9B"/>
-                      </a:solidFill>
-                    </a:lnL>
-                    <a:lnR w="9525" cap="flat">
-                      <a:solidFill>
-                        <a:srgbClr val="9B9B9B"/>
-                      </a:solidFill>
-                    </a:lnR>
-                    <a:lnT w="9525" cap="flat">
-                      <a:solidFill>
-                        <a:srgbClr val="9B9B9B"/>
-                      </a:solidFill>
-                    </a:lnT>
-                    <a:lnB w="9525" cap="flat">
-                      <a:solidFill>
-                        <a:srgbClr val="9B9B9B"/>
-                      </a:solidFill>
-                    </a:lnB>
-                    <a:solidFill>
-                      <a:srgbClr val="FFFFFF"/>
-                    </a:solidFill>
-                  </a:tcPr>
-                </a:tc>
-                <a:tc>
-                  <a:txBody>
-                    <a:bodyPr/>
-                    <a:lstStyle/>
-                    <a:p>
-                      <a:pPr algn="l"/>
-                      <a:r>
-                        <a:rPr lang="ja-JP" altLang="en-US" sz="1400" b="0" dirty="0">
-                          <a:solidFill>
-                            <a:srgbClr val="000000"/>
-                          </a:solidFill>
-                          <a:latin typeface="Meiryo"/>
-                          <a:ea typeface="Meiryo"/>
-                        </a:rPr>
-                        <a:t>3,135ファイル・issue57件</a:t>
-                      </a:r>
-                    </a:p>
-                  </a:txBody>
-                  <a:tcPr marL="72000" marR="72000" marT="36000" marB="36000" anchor="ctr">
-                    <a:lnL w="9525" cap="flat">
-                      <a:solidFill>
-                        <a:srgbClr val="9B9B9B"/>
-                      </a:solidFill>
-                    </a:lnL>
-                    <a:lnR w="9525" cap="flat">
-                      <a:solidFill>
-                        <a:srgbClr val="9B9B9B"/>
-                      </a:solidFill>
-                    </a:lnR>
-                    <a:lnT w="9525" cap="flat">
-                      <a:solidFill>
-                        <a:srgbClr val="9B9B9B"/>
-                      </a:solidFill>
-                    </a:lnT>
-                    <a:lnB w="9525" cap="flat">
-                      <a:solidFill>
-                        <a:srgbClr val="9B9B9B"/>
-                      </a:solidFill>
-                    </a:lnB>
-                    <a:solidFill>
-                      <a:srgbClr val="FFFFFF"/>
-                    </a:solidFill>
-                  </a:tcPr>
-                </a:tc>
-                <a:tc>
-                  <a:txBody>
-                    <a:bodyPr/>
-                    <a:lstStyle/>
-                    <a:p>
-                      <a:pPr algn="l"/>
-                      <a:r>
-                        <a:rPr lang="ja-JP" altLang="en-US" sz="1400" b="0" dirty="0">
-                          <a:solidFill>
-                            <a:srgbClr val="000000"/>
-                          </a:solidFill>
-                          <a:latin typeface="Meiryo"/>
-                          <a:ea typeface="Meiryo"/>
-                        </a:rPr>
-                        <a:t>同期は毎日17:30に自動実行</a:t>
-                      </a:r>
-                    </a:p>
-                  </a:txBody>
-                  <a:tcPr marL="72000" marR="72000" marT="36000" marB="36000" anchor="ctr">
-                    <a:lnL w="9525" cap="flat">
-                      <a:solidFill>
-                        <a:srgbClr val="9B9B9B"/>
-                      </a:solidFill>
-                    </a:lnL>
-                    <a:lnR w="9525" cap="flat">
-                      <a:solidFill>
-                        <a:srgbClr val="9B9B9B"/>
-                      </a:solidFill>
-                    </a:lnR>
-                    <a:lnT w="9525" cap="flat">
-                      <a:solidFill>
-                        <a:srgbClr val="9B9B9B"/>
-                      </a:solidFill>
-                    </a:lnT>
-                    <a:lnB w="9525" cap="flat">
-                      <a:solidFill>
-                        <a:srgbClr val="9B9B9B"/>
-                      </a:solidFill>
-                    </a:lnB>
-                    <a:solidFill>
-                      <a:srgbClr val="FFFFFF"/>
-                    </a:solidFill>
-                  </a:tcPr>
-                </a:tc>
-                <a:extLst>
-                  <a:ext uri="{0D108BD9-81ED-4DB2-BD59-A6C34878D82A}">
-                    <a16:rowId xmlns:a16="http://schemas.microsoft.com/office/drawing/2014/main" val="10003"/>
-                  </a:ext>
-                </a:extLst>
-              </a:tr>
-              <a:tr h="400000">
-                <a:tc>
-                  <a:txBody>
-                    <a:bodyPr/>
-                    <a:lstStyle/>
-                    <a:p>
-                      <a:pPr algn="l"/>
-                      <a:r>
-                        <a:rPr lang="ja-JP" altLang="en-US" sz="1400" b="0" dirty="0">
-                          <a:solidFill>
-                            <a:srgbClr val="000000"/>
-                          </a:solidFill>
-                          <a:latin typeface="Meiryo"/>
-                          <a:ea typeface="Meiryo"/>
-                        </a:rPr>
-                        <a:t>スナップショット容量</a:t>
-                      </a:r>
-                    </a:p>
-                  </a:txBody>
-                  <a:tcPr marL="72000" marR="72000" marT="36000" marB="36000" anchor="ctr">
-                    <a:lnL w="9525" cap="flat">
-                      <a:solidFill>
-                        <a:srgbClr val="9B9B9B"/>
-                      </a:solidFill>
-                    </a:lnL>
-                    <a:lnR w="9525" cap="flat">
-                      <a:solidFill>
-                        <a:srgbClr val="9B9B9B"/>
-                      </a:solidFill>
-                    </a:lnR>
-                    <a:lnT w="9525" cap="flat">
-                      <a:solidFill>
-                        <a:srgbClr val="9B9B9B"/>
-                      </a:solidFill>
-                    </a:lnT>
-                    <a:lnB w="9525" cap="flat">
-                      <a:solidFill>
-                        <a:srgbClr val="9B9B9B"/>
-                      </a:solidFill>
-                    </a:lnB>
-                    <a:solidFill>
-                      <a:srgbClr val="FFFFFF"/>
-                    </a:solidFill>
-                  </a:tcPr>
-                </a:tc>
-                <a:tc>
-                  <a:txBody>
-                    <a:bodyPr/>
-                    <a:lstStyle/>
-                    <a:p>
-                      <a:pPr algn="l"/>
-                      <a:r>
-                        <a:rPr lang="ja-JP" altLang="en-US" sz="1400" b="0" dirty="0">
-                          <a:solidFill>
-                            <a:srgbClr val="000000"/>
-                          </a:solidFill>
-                          <a:latin typeface="Meiryo"/>
-                          <a:ea typeface="Meiryo"/>
-                        </a:rPr>
-                        <a:t>56.1GB→0.59GB</a:t>
-                      </a:r>
-                    </a:p>
-                  </a:txBody>
-                  <a:tcPr marL="72000" marR="72000" marT="36000" marB="36000" anchor="ctr">
-                    <a:lnL w="9525" cap="flat">
-                      <a:solidFill>
-                        <a:srgbClr val="9B9B9B"/>
-                      </a:solidFill>
-                    </a:lnL>
-                    <a:lnR w="9525" cap="flat">
-                      <a:solidFill>
-                        <a:srgbClr val="9B9B9B"/>
-                      </a:solidFill>
-                    </a:lnR>
-                    <a:lnT w="9525" cap="flat">
-                      <a:solidFill>
-                        <a:srgbClr val="9B9B9B"/>
-                      </a:solidFill>
-                    </a:lnT>
-                    <a:lnB w="9525" cap="flat">
-                      <a:solidFill>
-                        <a:srgbClr val="9B9B9B"/>
-                      </a:solidFill>
-                    </a:lnB>
-                    <a:solidFill>
-                      <a:srgbClr val="FFFFFF"/>
-                    </a:solidFill>
-                  </a:tcPr>
-                </a:tc>
-                <a:tc>
-                  <a:txBody>
-                    <a:bodyPr/>
-                    <a:lstStyle/>
-                    <a:p>
-                      <a:pPr algn="l"/>
-                      <a:r>
-                        <a:rPr lang="ja-JP" altLang="en-US" sz="1400" b="0" dirty="0">
-                          <a:solidFill>
-                            <a:srgbClr val="000000"/>
-                          </a:solidFill>
-                          <a:latin typeface="Meiryo"/>
-                          <a:ea typeface="Meiryo"/>
-                        </a:rPr>
-                        <a:t>除外を許可リスト化(10/8)</a:t>
-                      </a:r>
-                    </a:p>
-                  </a:txBody>
-                  <a:tcPr marL="72000" marR="72000" marT="36000" marB="36000" anchor="ctr">
-                    <a:lnL w="9525" cap="flat">
-                      <a:solidFill>
-                        <a:srgbClr val="9B9B9B"/>
-                      </a:solidFill>
-                    </a:lnL>
-                    <a:lnR w="9525" cap="flat">
-                      <a:solidFill>
-                        <a:srgbClr val="9B9B9B"/>
-                      </a:solidFill>
-                    </a:lnR>
-                    <a:lnT w="9525" cap="flat">
-                      <a:solidFill>
-                        <a:srgbClr val="9B9B9B"/>
-                      </a:solidFill>
-                    </a:lnT>
-                    <a:lnB w="9525" cap="flat">
-                      <a:solidFill>
-                        <a:srgbClr val="9B9B9B"/>
-                      </a:solidFill>
-                    </a:lnB>
-                    <a:solidFill>
-                      <a:srgbClr val="FFFFFF"/>
-                    </a:solidFill>
-                  </a:tcPr>
-                </a:tc>
-                <a:extLst>
-                  <a:ext uri="{0D108BD9-81ED-4DB2-BD59-A6C34878D82A}">
-                    <a16:rowId xmlns:a16="http://schemas.microsoft.com/office/drawing/2014/main" val="10004"/>
-                  </a:ext>
-                </a:extLst>
-              </a:tr>
-            </a:tbl>
-          </a:graphicData>
-        </a:graphic>
-      </p:graphicFrame>
+          <p:cNvSpPr txBox="1"/>
+          <p:nvPr/>
+        </p:nvSpPr>
+        <p:spPr>
+          <a:xfrm>
+            <a:off x="457200" y="2743200"/>
+            <a:ext cx="3520440" cy="1371600"/>
+          </a:xfrm>
+          <a:prstGeom prst="rect">
+            <a:avLst/>
+          </a:prstGeom>
+          <a:noFill/>
+        </p:spPr>
+        <p:txBody>
+          <a:bodyPr wrap="square" lIns="0" tIns="0" rIns="0" bIns="0" anchor="t">
+            <a:noAutofit/>
+          </a:bodyPr>
+          <a:lstStyle/>
+          <a:p>
+            <a:pPr algn="l">
+              <a:lnSpc>
+                <a:spcPct val="112000"/>
+              </a:lnSpc>
+              <a:spcAft>
+                <a:spcPts val="400"/>
+              </a:spcAft>
+            </a:pPr>
+            <a:r>
+              <a:rPr lang="ja-JP" altLang="en-US" b="0" dirty="0" sz="1200">
+                <a:solidFill>
+                  <a:srgbClr val="000000"/>
+                </a:solidFill>
+                <a:latin typeface="Meiryo"/>
+                <a:ea typeface="Meiryo"/>
+              </a:rPr>
+              <a:t>・テーマ1 管理方法確立：12月末に初版登録</a:t>
+            </a:r>
+            <a:endParaRPr lang="en-US" altLang="ja-JP" b="0" dirty="0">
+              <a:solidFill>
+                <a:srgbClr val="000000"/>
+              </a:solidFill>
+              <a:latin typeface="Meiryo"/>
+              <a:ea typeface="Meiryo"/>
+            </a:endParaRPr>
+          </a:p>
+          <a:p>
+            <a:pPr algn="l">
+              <a:lnSpc>
+                <a:spcPct val="112000"/>
+              </a:lnSpc>
+              <a:spcAft>
+                <a:spcPts val="400"/>
+              </a:spcAft>
+            </a:pPr>
+            <a:r>
+              <a:rPr lang="ja-JP" altLang="en-US" b="0" dirty="0" sz="1200">
+                <a:solidFill>
+                  <a:srgbClr val="000000"/>
+                </a:solidFill>
+                <a:latin typeface="Meiryo"/>
+                <a:ea typeface="Meiryo"/>
+              </a:rPr>
+              <a:t>・テーマ2 棚卸のツール改善：10月末に本番</a:t>
+            </a:r>
+            <a:endParaRPr lang="en-US" altLang="ja-JP" b="0" dirty="0">
+              <a:solidFill>
+                <a:srgbClr val="000000"/>
+              </a:solidFill>
+              <a:latin typeface="Meiryo"/>
+              <a:ea typeface="Meiryo"/>
+            </a:endParaRPr>
+          </a:p>
+          <a:p>
+            <a:pPr algn="l">
+              <a:lnSpc>
+                <a:spcPct val="112000"/>
+              </a:lnSpc>
+              <a:spcAft>
+                <a:spcPts val="400"/>
+              </a:spcAft>
+            </a:pPr>
+            <a:r>
+              <a:rPr lang="ja-JP" altLang="en-US" b="0" dirty="0" sz="1200">
+                <a:solidFill>
+                  <a:srgbClr val="000000"/>
+                </a:solidFill>
+                <a:latin typeface="Meiryo"/>
+                <a:ea typeface="Meiryo"/>
+              </a:rPr>
+              <a:t>・テーマ3 鹿島引き込み改修：導入時までに整備</a:t>
+            </a:r>
+            <a:endParaRPr lang="en-US" altLang="ja-JP" b="0" dirty="0">
+              <a:solidFill>
+                <a:srgbClr val="000000"/>
+              </a:solidFill>
+              <a:latin typeface="Meiryo"/>
+              <a:ea typeface="Meiryo"/>
+            </a:endParaRPr>
+          </a:p>
+        </p:txBody>
+      </p:sp>
+      <p:sp>
+        <p:nvSpPr>
+          <p:cNvPr id="9002" name="TB_cap_ge">
+            <a:extLst>
+              <a:ext uri="{FF2B5EF4-FFF2-40B4-BE49-F238E27FC236}">
+                <a16:creationId xmlns:a16="http://schemas.microsoft.com/office/drawing/2014/main" id="{90B734DB-F072-0773-4A91-F2D0428DC85B}"/>
+              </a:ext>
+            </a:extLst>
+          </p:cNvPr>
+          <p:cNvSpPr txBox="1"/>
+          <p:nvPr/>
+        </p:nvSpPr>
+        <p:spPr>
+          <a:xfrm>
+            <a:off x="4160520" y="2587752"/>
+            <a:ext cx="7589520" cy="324000"/>
+          </a:xfrm>
+          <a:prstGeom prst="rect">
+            <a:avLst/>
+          </a:prstGeom>
+          <a:noFill/>
+        </p:spPr>
+        <p:txBody>
+          <a:bodyPr wrap="square" lIns="0" tIns="0" rIns="0" bIns="0" anchor="t">
+            <a:noAutofit/>
+          </a:bodyPr>
+          <a:lstStyle/>
+          <a:p>
+            <a:pPr algn="l">
+              <a:lnSpc>
+                <a:spcPct val="112000"/>
+              </a:lnSpc>
+              <a:spcAft>
+                <a:spcPts val="400"/>
+              </a:spcAft>
+            </a:pPr>
+            <a:r>
+              <a:rPr lang="ja-JP" altLang="en-US" b="1" dirty="0">
+                <a:solidFill>
+                  <a:srgbClr val="000000"/>
+                </a:solidFill>
+                <a:latin typeface="Meiryo"/>
+                <a:ea typeface="Meiryo"/>
+              </a:rPr>
+              <a:t>▲活動テーマ進捗管理表(下期)：報告はこの3テーマの順</a:t>
+            </a:r>
+          </a:p>
+        </p:txBody>
+      </p:sp>
+      <p:pic>
+        <p:nvPicPr>
+          <p:cNvPr id="21507" name="IMG_geki" descr="下期キャプチャ.png"/>
+          <p:cNvPicPr>
+            <a:picLocks noChangeAspect="1"/>
+          </p:cNvPicPr>
+          <p:nvPr/>
+        </p:nvPicPr>
+        <p:blipFill>
+          <a:blip r:embed="rId2"/>
+          <a:stretch>
+            <a:fillRect/>
+          </a:stretch>
+        </p:blipFill>
+        <p:spPr>
+          <a:xfrm>
+            <a:off x="4160520" y="2907792"/>
+            <a:ext cx="7406640" cy="3695808"/>
+          </a:xfrm>
+          <a:prstGeom prst="rect">
+            <a:avLst/>
+          </a:prstGeom>
+        </p:spPr>
+      </p:pic>
+      <p:sp>
+        <p:nvSpPr>
+          <p:cNvPr id="9003" name="TB_cap_jo">
+            <a:extLst>
+              <a:ext uri="{FF2B5EF4-FFF2-40B4-BE49-F238E27FC236}">
+                <a16:creationId xmlns:a16="http://schemas.microsoft.com/office/drawing/2014/main" id="{90B734DB-F072-0773-4A91-F2D0428DC85B}"/>
+              </a:ext>
+            </a:extLst>
+          </p:cNvPr>
+          <p:cNvSpPr txBox="1"/>
+          <p:nvPr/>
+        </p:nvSpPr>
+        <p:spPr>
+          <a:xfrm>
+            <a:off x="457200" y="4224528"/>
+            <a:ext cx="3474720" cy="324000"/>
+          </a:xfrm>
+          <a:prstGeom prst="rect">
+            <a:avLst/>
+          </a:prstGeom>
+          <a:noFill/>
+        </p:spPr>
+        <p:txBody>
+          <a:bodyPr wrap="square" lIns="0" tIns="0" rIns="0" bIns="0" anchor="t">
+            <a:noAutofit/>
+          </a:bodyPr>
+          <a:lstStyle/>
+          <a:p>
+            <a:pPr algn="l">
+              <a:lnSpc>
+                <a:spcPct val="112000"/>
+              </a:lnSpc>
+              <a:spcAft>
+                <a:spcPts val="400"/>
+              </a:spcAft>
+            </a:pPr>
+            <a:r>
+              <a:rPr lang="ja-JP" altLang="en-US" b="1" dirty="0">
+                <a:solidFill>
+                  <a:srgbClr val="000000"/>
+                </a:solidFill>
+                <a:latin typeface="Meiryo"/>
+                <a:ea typeface="Meiryo"/>
+              </a:rPr>
+              <a:t>▲同(上期)：棚卸は継続テーマ</a:t>
+            </a:r>
+          </a:p>
+        </p:txBody>
+      </p:sp>
+      <p:pic>
+        <p:nvPicPr>
+          <p:cNvPr id="21508" name="IMG_joki" descr="上期キャプチャ.png"/>
+          <p:cNvPicPr>
+            <a:picLocks noChangeAspect="1"/>
+          </p:cNvPicPr>
+          <p:nvPr/>
+        </p:nvPicPr>
+        <p:blipFill>
+          <a:blip r:embed="rId3"/>
+          <a:stretch>
+            <a:fillRect/>
+          </a:stretch>
+        </p:blipFill>
+        <p:spPr>
+          <a:xfrm>
+            <a:off x="457200" y="4526280"/>
+            <a:ext cx="3474720" cy="1936776"/>
+          </a:xfrm>
+          <a:prstGeom prst="rect">
+            <a:avLst/>
+          </a:prstGeom>
+        </p:spPr>
+      </p:pic>
     </p:spTree>
   </p:cSld>
   <p:clrMapOvr>
@@ -6768,7 +5052,7 @@
                 <a:latin typeface="Meiryo"/>
                 <a:ea typeface="Meiryo"/>
               </a:rPr>
-              <a:t>テーマ1　0確認マクロver.2の運用確定</a:t>
+              <a:t>テーマ1　Pana-CIM/LNBの管理方法確立</a:t>
             </a:r>
             <a:endParaRPr lang="ja-JP" altLang="en-US" sz="3600" dirty="0">
               <a:solidFill>
@@ -6860,7 +5144,7 @@
                 <a:latin typeface="Meiryo"/>
                 <a:ea typeface="Meiryo"/>
               </a:rPr>
-              <a:t>実施時期：9〜10月</a:t>
+              <a:t>実施時期：〜12月末</a:t>
             </a:r>
           </a:p>
         </p:txBody>
@@ -6958,7 +5242,7 @@
                 <a:latin typeface="Meiryo"/>
                 <a:ea typeface="Meiryo"/>
               </a:rPr>
-              <a:t>・目標：質問票35問の回答を運用手順書へ反映し、本番準備を完了させる。</a:t>
+              <a:t>・目標：管理文書の初版登録を12月末までに完了させる。</a:t>
             </a:r>
             <a:endParaRPr lang="en-US" altLang="ja-JP" b="0" dirty="0">
               <a:solidFill>
@@ -6985,7 +5269,7 @@
                 <a:latin typeface="Meiryo"/>
                 <a:ea typeface="Meiryo"/>
               </a:rPr>
-              <a:t>・実績：反映は完了(10/15)。本番は10月末(予定)で、日程は10/28会議で確定。</a:t>
+              <a:t>・実績：管理手順書案2冊(107頁/99頁)を実物様式どおり作成。文書に載せる図7点も作成済み。</a:t>
             </a:r>
             <a:endParaRPr lang="en-US" altLang="ja-JP" b="0" dirty="0">
               <a:solidFill>
@@ -7090,7 +5374,7 @@
                 <a:latin typeface="Meiryo"/>
                 <a:ea typeface="Meiryo"/>
               </a:rPr>
-              <a:t>・照合スクリプトで原因の切り分け(入力CSV起因/マクロ起因)を機械化した。</a:t>
+              <a:t>・10/19の三者レビューと10/21の作成チーム確認に向け、レビュー用の準備を進めた。</a:t>
             </a:r>
             <a:endParaRPr lang="en-US" altLang="ja-JP" b="0" dirty="0">
               <a:solidFill>
@@ -7117,7 +5401,7 @@
                 <a:latin typeface="Meiryo"/>
                 <a:ea typeface="Meiryo"/>
               </a:rPr>
-              <a:t>・10/2に無変更のまま実機で成功し、ver.2を運用として採用した。</a:t>
+              <a:t>・残タスクは図の登録・再起動手順の原文突合・印刷範囲の再設定に絞った。</a:t>
             </a:r>
             <a:endParaRPr lang="en-US" altLang="ja-JP" b="0" dirty="0">
               <a:solidFill>
@@ -7222,7 +5506,7 @@
                 <a:latin typeface="Meiryo"/>
                 <a:ea typeface="Meiryo"/>
               </a:rPr>
-              <a:t>・対象5,848件(入力CSV 29,246行)。10/2版は再計算で6,084件と一致。</a:t>
+              <a:t>・案2冊：107頁/99頁(未承認)。図は相関図・データフロー図など7点。</a:t>
             </a:r>
           </a:p>
           <a:p>
@@ -7242,7 +5526,7 @@
                 <a:latin typeface="Meiryo"/>
                 <a:ea typeface="Meiryo"/>
               </a:rPr>
-              <a:t>・正本は共有サーバーの「0確認マクロ_ver2.xlsm」。反映は10/15。</a:t>
+              <a:t>・レビュー：10/19(三者)・10/21(作成チーム)。期限：初版登録12月末、LNB点検項目の登録12/28。</a:t>
             </a:r>
           </a:p>
           <a:p>
@@ -7262,27 +5546,7 @@
                 <a:latin typeface="Meiryo"/>
                 <a:ea typeface="Meiryo"/>
               </a:rPr>
-              <a:t>・効果：原因の切り分けを機械化(推測→照合)。工数の前後比較は本番時に測定(未測定)。</a:t>
-            </a:r>
-          </a:p>
-          <a:p>
-            <a:pPr algn="l">
-              <a:lnSpc>
-                <a:spcPct val="112000"/>
-              </a:lnSpc>
-              <a:spcAft>
-                <a:spcPts val="400"/>
-              </a:spcAft>
-            </a:pPr>
-            <a:r>
-              <a:rPr lang="ja-JP" altLang="en-US" b="0" dirty="0">
-                <a:solidFill>
-                  <a:srgbClr val="000000"/>
-                </a:solidFill>
-                <a:latin typeface="Meiryo"/>
-                <a:ea typeface="Meiryo"/>
-              </a:rPr>
-              <a:t>→ 次の展開：未決4件とxlsmへの実装2件を消化し、本番で全件照合と消し込み結果を確認する。</a:t>
+              <a:t>→ 次の展開：10/28までに相関図と画像を追加し、同日の会議で承認をいただく。</a:t>
             </a:r>
           </a:p>
         </p:txBody>
@@ -7357,1128 +5621,12 @@
                 <a:latin typeface="Meiryo"/>
                 <a:ea typeface="Meiryo"/>
               </a:rPr>
-              <a:t>テーマ2　PanaCIM・LNB管理手順書の整備</a:t>
+              <a:t>テーマ2　EGPro-MES差異確認(棚卸)のツール改善</a:t>
             </a:r>
             <a:endParaRPr lang="ja-JP" altLang="en-US" sz="3600" dirty="0">
               <a:solidFill>
                 <a:schemeClr val="bg1"/>
               </a:solidFill>
-            </a:endParaRPr>
-          </a:p>
-        </p:txBody>
-      </p:sp>
-      <p:sp>
-        <p:nvSpPr>
-          <p:cNvPr id="10" name="TB32">
-            <a:extLst>
-              <a:ext uri="{FF2B5EF4-FFF2-40B4-BE49-F238E27FC236}">
-                <a16:creationId xmlns:a16="http://schemas.microsoft.com/office/drawing/2014/main" id="{3ED9BB57-B053-F70B-D524-9A419F78B21D}"/>
-              </a:ext>
-            </a:extLst>
-          </p:cNvPr>
-          <p:cNvSpPr txBox="1"/>
-          <p:nvPr/>
-        </p:nvSpPr>
-        <p:spPr>
-          <a:xfrm>
-            <a:off x="540000" y="1687100"/>
-            <a:ext cx="2160000" cy="324000"/>
-          </a:xfrm>
-          <a:prstGeom prst="rect">
-            <a:avLst/>
-          </a:prstGeom>
-          <a:noFill/>
-        </p:spPr>
-        <p:txBody>
-          <a:bodyPr wrap="square" lIns="0" tIns="0" rIns="0" bIns="0" anchor="t">
-            <a:noAutofit/>
-          </a:bodyPr>
-          <a:lstStyle/>
-          <a:p>
-            <a:pPr algn="l">
-              <a:lnSpc>
-                <a:spcPct val="112000"/>
-              </a:lnSpc>
-              <a:spcAft>
-                <a:spcPts val="400"/>
-              </a:spcAft>
-            </a:pPr>
-            <a:r>
-              <a:rPr lang="ja-JP" altLang="en-US" sz="2000" b="1" dirty="0">
-                <a:solidFill>
-                  <a:srgbClr val="000000"/>
-                </a:solidFill>
-                <a:latin typeface="Meiryo"/>
-                <a:ea typeface="Meiryo"/>
-              </a:rPr>
-              <a:t>背景（解決前）</a:t>
-            </a:r>
-          </a:p>
-        </p:txBody>
-      </p:sp>
-      <p:sp>
-        <p:nvSpPr>
-          <p:cNvPr id="14" name="S33">
-            <a:extLst>
-              <a:ext uri="{FF2B5EF4-FFF2-40B4-BE49-F238E27FC236}">
-                <a16:creationId xmlns:a16="http://schemas.microsoft.com/office/drawing/2014/main" id="{5B0E15B8-93C6-B5DC-8BC8-AE4DFDADDF16}"/>
-              </a:ext>
-            </a:extLst>
-          </p:cNvPr>
-          <p:cNvSpPr/>
-          <p:nvPr/>
-        </p:nvSpPr>
-        <p:spPr>
-          <a:xfrm>
-            <a:off x="540000" y="2047100"/>
-            <a:ext cx="2268000" cy="720000"/>
-          </a:xfrm>
-          <a:prstGeom prst="roundRect">
-            <a:avLst/>
-          </a:prstGeom>
-          <a:solidFill>
-            <a:srgbClr val="F2F2F2"/>
-          </a:solidFill>
-          <a:ln w="9525">
-            <a:solidFill>
-              <a:srgbClr val="9B9B9B"/>
-            </a:solidFill>
-          </a:ln>
-        </p:spPr>
-        <p:txBody>
-          <a:bodyPr wrap="square" lIns="72000" tIns="36000" rIns="72000" bIns="36000" anchor="ctr">
-            <a:noAutofit/>
-          </a:bodyPr>
-          <a:lstStyle/>
-          <a:p>
-            <a:pPr algn="ctr">
-              <a:lnSpc>
-                <a:spcPct val="105000"/>
-              </a:lnSpc>
-            </a:pPr>
-            <a:r>
-              <a:rPr lang="ja-JP" altLang="en-US" sz="1600" b="0" dirty="0">
-                <a:solidFill>
-                  <a:srgbClr val="000000"/>
-                </a:solidFill>
-                <a:latin typeface="Meiryo"/>
-                <a:ea typeface="Meiryo"/>
-              </a:rPr>
-              <a:t>草案に引用元が無い</a:t>
-            </a:r>
-          </a:p>
-        </p:txBody>
-      </p:sp>
-      <p:sp>
-        <p:nvSpPr>
-          <p:cNvPr id="18" name="S34">
-            <a:extLst>
-              <a:ext uri="{FF2B5EF4-FFF2-40B4-BE49-F238E27FC236}">
-                <a16:creationId xmlns:a16="http://schemas.microsoft.com/office/drawing/2014/main" id="{497756DF-3408-5C63-2891-8CB7EF569B47}"/>
-              </a:ext>
-            </a:extLst>
-          </p:cNvPr>
-          <p:cNvSpPr/>
-          <p:nvPr/>
-        </p:nvSpPr>
-        <p:spPr>
-          <a:xfrm>
-            <a:off x="2880000" y="2263100"/>
-            <a:ext cx="468000" cy="288000"/>
-          </a:xfrm>
-          <a:prstGeom prst="rightArrow">
-            <a:avLst/>
-          </a:prstGeom>
-          <a:solidFill>
-            <a:srgbClr val="C9C9C9"/>
-          </a:solidFill>
-          <a:ln>
-            <a:noFill/>
-          </a:ln>
-        </p:spPr>
-        <p:txBody>
-          <a:bodyPr wrap="square" lIns="72000" tIns="36000" rIns="72000" bIns="36000" anchor="ctr">
-            <a:noAutofit/>
-          </a:bodyPr>
-          <a:lstStyle/>
-          <a:p>
-            <a:pPr algn="ctr">
-              <a:lnSpc>
-                <a:spcPct val="105000"/>
-              </a:lnSpc>
-            </a:pPr>
-            <a:endParaRPr sz="2800"/>
-          </a:p>
-        </p:txBody>
-      </p:sp>
-      <p:sp>
-        <p:nvSpPr>
-          <p:cNvPr id="22" name="S35">
-            <a:extLst>
-              <a:ext uri="{FF2B5EF4-FFF2-40B4-BE49-F238E27FC236}">
-                <a16:creationId xmlns:a16="http://schemas.microsoft.com/office/drawing/2014/main" id="{1ED71925-19F6-F7EB-DF01-3604792C541E}"/>
-              </a:ext>
-            </a:extLst>
-          </p:cNvPr>
-          <p:cNvSpPr/>
-          <p:nvPr/>
-        </p:nvSpPr>
-        <p:spPr>
-          <a:xfrm>
-            <a:off x="3420000" y="2047100"/>
-            <a:ext cx="2376000" cy="720000"/>
-          </a:xfrm>
-          <a:prstGeom prst="roundRect">
-            <a:avLst/>
-          </a:prstGeom>
-          <a:solidFill>
-            <a:srgbClr val="F2F2F2"/>
-          </a:solidFill>
-          <a:ln w="9525">
-            <a:solidFill>
-              <a:srgbClr val="9B9B9B"/>
-            </a:solidFill>
-          </a:ln>
-        </p:spPr>
-        <p:txBody>
-          <a:bodyPr wrap="square" lIns="72000" tIns="36000" rIns="72000" bIns="36000" anchor="ctr">
-            <a:noAutofit/>
-          </a:bodyPr>
-          <a:lstStyle/>
-          <a:p>
-            <a:pPr algn="ctr">
-              <a:lnSpc>
-                <a:spcPct val="105000"/>
-              </a:lnSpc>
-            </a:pPr>
-            <a:r>
-              <a:rPr lang="ja-JP" altLang="en-US" sz="1600" b="0" dirty="0">
-                <a:solidFill>
-                  <a:srgbClr val="000000"/>
-                </a:solidFill>
-                <a:latin typeface="Meiryo"/>
-                <a:ea typeface="Meiryo"/>
-              </a:rPr>
-              <a:t>再起動手順が2種混在</a:t>
-            </a:r>
-          </a:p>
-        </p:txBody>
-      </p:sp>
-      <p:sp>
-        <p:nvSpPr>
-          <p:cNvPr id="25" name="S36">
-            <a:extLst>
-              <a:ext uri="{FF2B5EF4-FFF2-40B4-BE49-F238E27FC236}">
-                <a16:creationId xmlns:a16="http://schemas.microsoft.com/office/drawing/2014/main" id="{9AA1D80A-7EAB-E5E8-2EB1-FC55B36AF4FB}"/>
-              </a:ext>
-            </a:extLst>
-          </p:cNvPr>
-          <p:cNvSpPr/>
-          <p:nvPr/>
-        </p:nvSpPr>
-        <p:spPr>
-          <a:xfrm>
-            <a:off x="5868000" y="2263100"/>
-            <a:ext cx="468000" cy="288000"/>
-          </a:xfrm>
-          <a:prstGeom prst="rightArrow">
-            <a:avLst/>
-          </a:prstGeom>
-          <a:solidFill>
-            <a:srgbClr val="C9C9C9"/>
-          </a:solidFill>
-          <a:ln>
-            <a:noFill/>
-          </a:ln>
-        </p:spPr>
-        <p:txBody>
-          <a:bodyPr wrap="square" lIns="72000" tIns="36000" rIns="72000" bIns="36000" anchor="ctr">
-            <a:noAutofit/>
-          </a:bodyPr>
-          <a:lstStyle/>
-          <a:p>
-            <a:pPr algn="ctr">
-              <a:lnSpc>
-                <a:spcPct val="105000"/>
-              </a:lnSpc>
-            </a:pPr>
-            <a:endParaRPr sz="2800"/>
-          </a:p>
-        </p:txBody>
-      </p:sp>
-      <p:sp>
-        <p:nvSpPr>
-          <p:cNvPr id="27" name="S37">
-            <a:extLst>
-              <a:ext uri="{FF2B5EF4-FFF2-40B4-BE49-F238E27FC236}">
-                <a16:creationId xmlns:a16="http://schemas.microsoft.com/office/drawing/2014/main" id="{575B3615-02E5-2F13-6748-B3B281746601}"/>
-              </a:ext>
-            </a:extLst>
-          </p:cNvPr>
-          <p:cNvSpPr/>
-          <p:nvPr/>
-        </p:nvSpPr>
-        <p:spPr>
-          <a:xfrm>
-            <a:off x="6408000" y="2047100"/>
-            <a:ext cx="2376000" cy="720000"/>
-          </a:xfrm>
-          <a:prstGeom prst="roundRect">
-            <a:avLst/>
-          </a:prstGeom>
-          <a:solidFill>
-            <a:srgbClr val="F2F2F2"/>
-          </a:solidFill>
-          <a:ln w="9525">
-            <a:solidFill>
-              <a:srgbClr val="9B9B9B"/>
-            </a:solidFill>
-          </a:ln>
-        </p:spPr>
-        <p:txBody>
-          <a:bodyPr wrap="square" lIns="72000" tIns="36000" rIns="72000" bIns="36000" anchor="ctr">
-            <a:noAutofit/>
-          </a:bodyPr>
-          <a:lstStyle/>
-          <a:p>
-            <a:pPr algn="ctr">
-              <a:lnSpc>
-                <a:spcPct val="105000"/>
-              </a:lnSpc>
-            </a:pPr>
-            <a:r>
-              <a:rPr lang="ja-JP" altLang="en-US" sz="1600" b="0" dirty="0">
-                <a:solidFill>
-                  <a:srgbClr val="000000"/>
-                </a:solidFill>
-                <a:latin typeface="Meiryo"/>
-                <a:ea typeface="Meiryo"/>
-              </a:rPr>
-              <a:t>停止と起動の区切りが無い</a:t>
-            </a:r>
-          </a:p>
-        </p:txBody>
-      </p:sp>
-      <p:sp>
-        <p:nvSpPr>
-          <p:cNvPr id="29" name="S38">
-            <a:extLst>
-              <a:ext uri="{FF2B5EF4-FFF2-40B4-BE49-F238E27FC236}">
-                <a16:creationId xmlns:a16="http://schemas.microsoft.com/office/drawing/2014/main" id="{A3A85E53-59E3-14F1-A43D-43A5D5555EB0}"/>
-              </a:ext>
-            </a:extLst>
-          </p:cNvPr>
-          <p:cNvSpPr/>
-          <p:nvPr/>
-        </p:nvSpPr>
-        <p:spPr>
-          <a:xfrm>
-            <a:off x="8856000" y="2263100"/>
-            <a:ext cx="468000" cy="288000"/>
-          </a:xfrm>
-          <a:prstGeom prst="rightArrow">
-            <a:avLst/>
-          </a:prstGeom>
-          <a:solidFill>
-            <a:srgbClr val="C9C9C9"/>
-          </a:solidFill>
-          <a:ln>
-            <a:noFill/>
-          </a:ln>
-        </p:spPr>
-        <p:txBody>
-          <a:bodyPr wrap="square" lIns="72000" tIns="36000" rIns="72000" bIns="36000" anchor="ctr">
-            <a:noAutofit/>
-          </a:bodyPr>
-          <a:lstStyle/>
-          <a:p>
-            <a:pPr algn="ctr">
-              <a:lnSpc>
-                <a:spcPct val="105000"/>
-              </a:lnSpc>
-            </a:pPr>
-            <a:endParaRPr sz="2800"/>
-          </a:p>
-        </p:txBody>
-      </p:sp>
-      <p:sp>
-        <p:nvSpPr>
-          <p:cNvPr id="31" name="S39">
-            <a:extLst>
-              <a:ext uri="{FF2B5EF4-FFF2-40B4-BE49-F238E27FC236}">
-                <a16:creationId xmlns:a16="http://schemas.microsoft.com/office/drawing/2014/main" id="{4360A1D8-3337-5B5F-A527-4558554291F7}"/>
-              </a:ext>
-            </a:extLst>
-          </p:cNvPr>
-          <p:cNvSpPr/>
-          <p:nvPr/>
-        </p:nvSpPr>
-        <p:spPr>
-          <a:xfrm>
-            <a:off x="9396000" y="2047100"/>
-            <a:ext cx="2232000" cy="720000"/>
-          </a:xfrm>
-          <a:prstGeom prst="roundRect">
-            <a:avLst/>
-          </a:prstGeom>
-          <a:solidFill>
-            <a:srgbClr val="E2E2E2"/>
-          </a:solidFill>
-          <a:ln w="9525">
-            <a:solidFill>
-              <a:srgbClr val="C00000"/>
-            </a:solidFill>
-          </a:ln>
-        </p:spPr>
-        <p:txBody>
-          <a:bodyPr wrap="square" lIns="72000" tIns="36000" rIns="72000" bIns="36000" anchor="ctr">
-            <a:noAutofit/>
-          </a:bodyPr>
-          <a:lstStyle/>
-          <a:p>
-            <a:pPr algn="ctr">
-              <a:lnSpc>
-                <a:spcPct val="105000"/>
-              </a:lnSpc>
-            </a:pPr>
-            <a:r>
-              <a:rPr lang="ja-JP" altLang="en-US" sz="1600" b="0" dirty="0">
-                <a:solidFill>
-                  <a:srgbClr val="C00000"/>
-                </a:solidFill>
-                <a:latin typeface="Meiryo"/>
-                <a:ea typeface="Meiryo"/>
-              </a:rPr>
-              <a:t>誤実行で生産停止</a:t>
-            </a:r>
-          </a:p>
-        </p:txBody>
-      </p:sp>
-      <p:sp>
-        <p:nvSpPr>
-          <p:cNvPr id="21505" name="TB40">
-            <a:extLst>
-              <a:ext uri="{FF2B5EF4-FFF2-40B4-BE49-F238E27FC236}">
-                <a16:creationId xmlns:a16="http://schemas.microsoft.com/office/drawing/2014/main" id="{927C2915-20BF-81E6-ADAB-0B263E213E91}"/>
-              </a:ext>
-            </a:extLst>
-          </p:cNvPr>
-          <p:cNvSpPr txBox="1"/>
-          <p:nvPr/>
-        </p:nvSpPr>
-        <p:spPr>
-          <a:xfrm>
-            <a:off x="540000" y="2911100"/>
-            <a:ext cx="11088000" cy="324000"/>
-          </a:xfrm>
-          <a:prstGeom prst="rect">
-            <a:avLst/>
-          </a:prstGeom>
-          <a:noFill/>
-        </p:spPr>
-        <p:txBody>
-          <a:bodyPr wrap="square" lIns="0" tIns="0" rIns="0" bIns="0" anchor="t">
-            <a:noAutofit/>
-          </a:bodyPr>
-          <a:lstStyle/>
-          <a:p>
-            <a:pPr algn="l">
-              <a:lnSpc>
-                <a:spcPct val="112000"/>
-              </a:lnSpc>
-              <a:spcAft>
-                <a:spcPts val="400"/>
-              </a:spcAft>
-            </a:pPr>
-            <a:r>
-              <a:rPr lang="ja-JP" altLang="en-US" b="0" dirty="0">
-                <a:solidFill>
-                  <a:srgbClr val="666666"/>
-                </a:solidFill>
-                <a:latin typeface="Meiryo"/>
-                <a:ea typeface="Meiryo"/>
-              </a:rPr>
-              <a:t>→ 異常時の手順は冒頭が「全ラインの生産と作業を停止」</a:t>
-            </a:r>
-          </a:p>
-        </p:txBody>
-      </p:sp>
-      <p:sp>
-        <p:nvSpPr>
-          <p:cNvPr id="21508" name="TB41">
-            <a:extLst>
-              <a:ext uri="{FF2B5EF4-FFF2-40B4-BE49-F238E27FC236}">
-                <a16:creationId xmlns:a16="http://schemas.microsoft.com/office/drawing/2014/main" id="{2292334C-0E0C-4611-CBB3-F1ED8685F0EE}"/>
-              </a:ext>
-            </a:extLst>
-          </p:cNvPr>
-          <p:cNvSpPr txBox="1"/>
-          <p:nvPr/>
-        </p:nvSpPr>
-        <p:spPr>
-          <a:xfrm>
-            <a:off x="540000" y="3523100"/>
-            <a:ext cx="2160000" cy="324000"/>
-          </a:xfrm>
-          <a:prstGeom prst="rect">
-            <a:avLst/>
-          </a:prstGeom>
-          <a:noFill/>
-        </p:spPr>
-        <p:txBody>
-          <a:bodyPr wrap="square" lIns="0" tIns="0" rIns="0" bIns="0" anchor="t">
-            <a:noAutofit/>
-          </a:bodyPr>
-          <a:lstStyle/>
-          <a:p>
-            <a:pPr algn="l">
-              <a:lnSpc>
-                <a:spcPct val="112000"/>
-              </a:lnSpc>
-              <a:spcAft>
-                <a:spcPts val="400"/>
-              </a:spcAft>
-            </a:pPr>
-            <a:r>
-              <a:rPr lang="ja-JP" altLang="en-US" sz="2000" b="1" dirty="0">
-                <a:solidFill>
-                  <a:srgbClr val="000000"/>
-                </a:solidFill>
-                <a:latin typeface="Meiryo"/>
-                <a:ea typeface="Meiryo"/>
-              </a:rPr>
-              <a:t>やったこと（解決後）</a:t>
-            </a:r>
-          </a:p>
-        </p:txBody>
-      </p:sp>
-      <p:sp>
-        <p:nvSpPr>
-          <p:cNvPr id="21510" name="S42">
-            <a:extLst>
-              <a:ext uri="{FF2B5EF4-FFF2-40B4-BE49-F238E27FC236}">
-                <a16:creationId xmlns:a16="http://schemas.microsoft.com/office/drawing/2014/main" id="{43FF9372-D4F3-024E-F5FB-EEBCEE3D6C53}"/>
-              </a:ext>
-            </a:extLst>
-          </p:cNvPr>
-          <p:cNvSpPr/>
-          <p:nvPr/>
-        </p:nvSpPr>
-        <p:spPr>
-          <a:xfrm>
-            <a:off x="540000" y="3883100"/>
-            <a:ext cx="2268000" cy="720000"/>
-          </a:xfrm>
-          <a:prstGeom prst="roundRect">
-            <a:avLst/>
-          </a:prstGeom>
-          <a:solidFill>
-            <a:srgbClr val="F2F2F2"/>
-          </a:solidFill>
-          <a:ln w="9525">
-            <a:solidFill>
-              <a:srgbClr val="9B9B9B"/>
-            </a:solidFill>
-          </a:ln>
-        </p:spPr>
-        <p:txBody>
-          <a:bodyPr wrap="square" lIns="72000" tIns="36000" rIns="72000" bIns="36000" anchor="ctr">
-            <a:noAutofit/>
-          </a:bodyPr>
-          <a:lstStyle/>
-          <a:p>
-            <a:pPr algn="ctr">
-              <a:lnSpc>
-                <a:spcPct val="105000"/>
-              </a:lnSpc>
-            </a:pPr>
-            <a:r>
-              <a:rPr lang="ja-JP" altLang="en-US" sz="1600" b="0" dirty="0">
-                <a:solidFill>
-                  <a:srgbClr val="000000"/>
-                </a:solidFill>
-                <a:latin typeface="Meiryo"/>
-                <a:ea typeface="Meiryo"/>
-              </a:rPr>
-              <a:t>公式資料の</a:t>
-            </a:r>
-          </a:p>
-          <a:p>
-            <a:pPr algn="ctr">
-              <a:lnSpc>
-                <a:spcPct val="105000"/>
-              </a:lnSpc>
-            </a:pPr>
-            <a:r>
-              <a:rPr lang="ja-JP" altLang="en-US" sz="1600" b="0" dirty="0">
-                <a:solidFill>
-                  <a:srgbClr val="000000"/>
-                </a:solidFill>
-                <a:latin typeface="Meiryo"/>
-                <a:ea typeface="Meiryo"/>
-              </a:rPr>
-              <a:t>本文を反映</a:t>
-            </a:r>
-          </a:p>
-        </p:txBody>
-      </p:sp>
-      <p:sp>
-        <p:nvSpPr>
-          <p:cNvPr id="21512" name="S43">
-            <a:extLst>
-              <a:ext uri="{FF2B5EF4-FFF2-40B4-BE49-F238E27FC236}">
-                <a16:creationId xmlns:a16="http://schemas.microsoft.com/office/drawing/2014/main" id="{89D92C62-0182-0465-1688-F4417EC2F72B}"/>
-              </a:ext>
-            </a:extLst>
-          </p:cNvPr>
-          <p:cNvSpPr/>
-          <p:nvPr/>
-        </p:nvSpPr>
-        <p:spPr>
-          <a:xfrm>
-            <a:off x="2880000" y="4099100"/>
-            <a:ext cx="468000" cy="288000"/>
-          </a:xfrm>
-          <a:prstGeom prst="rightArrow">
-            <a:avLst/>
-          </a:prstGeom>
-          <a:solidFill>
-            <a:srgbClr val="C9C9C9"/>
-          </a:solidFill>
-          <a:ln>
-            <a:noFill/>
-          </a:ln>
-        </p:spPr>
-        <p:txBody>
-          <a:bodyPr wrap="square" lIns="72000" tIns="36000" rIns="72000" bIns="36000" anchor="ctr">
-            <a:noAutofit/>
-          </a:bodyPr>
-          <a:lstStyle/>
-          <a:p>
-            <a:pPr algn="ctr">
-              <a:lnSpc>
-                <a:spcPct val="105000"/>
-              </a:lnSpc>
-            </a:pPr>
-            <a:endParaRPr sz="2800"/>
-          </a:p>
-        </p:txBody>
-      </p:sp>
-      <p:sp>
-        <p:nvSpPr>
-          <p:cNvPr id="21514" name="S44">
-            <a:extLst>
-              <a:ext uri="{FF2B5EF4-FFF2-40B4-BE49-F238E27FC236}">
-                <a16:creationId xmlns:a16="http://schemas.microsoft.com/office/drawing/2014/main" id="{D0A4DD7B-04A4-164A-EDDF-A00AC17F588E}"/>
-              </a:ext>
-            </a:extLst>
-          </p:cNvPr>
-          <p:cNvSpPr/>
-          <p:nvPr/>
-        </p:nvSpPr>
-        <p:spPr>
-          <a:xfrm>
-            <a:off x="3420000" y="3883100"/>
-            <a:ext cx="2376000" cy="720000"/>
-          </a:xfrm>
-          <a:prstGeom prst="roundRect">
-            <a:avLst/>
-          </a:prstGeom>
-          <a:solidFill>
-            <a:srgbClr val="F2F2F2"/>
-          </a:solidFill>
-          <a:ln w="9525">
-            <a:solidFill>
-              <a:srgbClr val="9B9B9B"/>
-            </a:solidFill>
-          </a:ln>
-        </p:spPr>
-        <p:txBody>
-          <a:bodyPr wrap="square" lIns="72000" tIns="36000" rIns="72000" bIns="36000" anchor="ctr">
-            <a:noAutofit/>
-          </a:bodyPr>
-          <a:lstStyle/>
-          <a:p>
-            <a:pPr algn="ctr">
-              <a:lnSpc>
-                <a:spcPct val="105000"/>
-              </a:lnSpc>
-            </a:pPr>
-            <a:r>
-              <a:rPr lang="ja-JP" altLang="en-US" sz="1600" b="0" dirty="0">
-                <a:solidFill>
-                  <a:srgbClr val="000000"/>
-                </a:solidFill>
-                <a:latin typeface="Meiryo"/>
-                <a:ea typeface="Meiryo"/>
-              </a:rPr>
-              <a:t>月次と異常時を分離</a:t>
-            </a:r>
-          </a:p>
-        </p:txBody>
-      </p:sp>
-      <p:sp>
-        <p:nvSpPr>
-          <p:cNvPr id="21516" name="S45">
-            <a:extLst>
-              <a:ext uri="{FF2B5EF4-FFF2-40B4-BE49-F238E27FC236}">
-                <a16:creationId xmlns:a16="http://schemas.microsoft.com/office/drawing/2014/main" id="{CE12C862-B8D7-8680-F5A6-9D5626C05174}"/>
-              </a:ext>
-            </a:extLst>
-          </p:cNvPr>
-          <p:cNvSpPr/>
-          <p:nvPr/>
-        </p:nvSpPr>
-        <p:spPr>
-          <a:xfrm>
-            <a:off x="5868000" y="4099100"/>
-            <a:ext cx="468000" cy="288000"/>
-          </a:xfrm>
-          <a:prstGeom prst="rightArrow">
-            <a:avLst/>
-          </a:prstGeom>
-          <a:solidFill>
-            <a:srgbClr val="C9C9C9"/>
-          </a:solidFill>
-          <a:ln>
-            <a:noFill/>
-          </a:ln>
-        </p:spPr>
-        <p:txBody>
-          <a:bodyPr wrap="square" lIns="72000" tIns="36000" rIns="72000" bIns="36000" anchor="ctr">
-            <a:noAutofit/>
-          </a:bodyPr>
-          <a:lstStyle/>
-          <a:p>
-            <a:pPr algn="ctr">
-              <a:lnSpc>
-                <a:spcPct val="105000"/>
-              </a:lnSpc>
-            </a:pPr>
-            <a:endParaRPr sz="2800"/>
-          </a:p>
-        </p:txBody>
-      </p:sp>
-      <p:sp>
-        <p:nvSpPr>
-          <p:cNvPr id="21518" name="S46">
-            <a:extLst>
-              <a:ext uri="{FF2B5EF4-FFF2-40B4-BE49-F238E27FC236}">
-                <a16:creationId xmlns:a16="http://schemas.microsoft.com/office/drawing/2014/main" id="{0B1D0BFE-19E5-BEBB-29BF-6206205D297A}"/>
-              </a:ext>
-            </a:extLst>
-          </p:cNvPr>
-          <p:cNvSpPr/>
-          <p:nvPr/>
-        </p:nvSpPr>
-        <p:spPr>
-          <a:xfrm>
-            <a:off x="6408000" y="3883100"/>
-            <a:ext cx="2376000" cy="720000"/>
-          </a:xfrm>
-          <a:prstGeom prst="roundRect">
-            <a:avLst/>
-          </a:prstGeom>
-          <a:solidFill>
-            <a:srgbClr val="F2F2F2"/>
-          </a:solidFill>
-          <a:ln w="9525">
-            <a:solidFill>
-              <a:srgbClr val="9B9B9B"/>
-            </a:solidFill>
-          </a:ln>
-        </p:spPr>
-        <p:txBody>
-          <a:bodyPr wrap="square" lIns="72000" tIns="36000" rIns="72000" bIns="36000" anchor="ctr">
-            <a:noAutofit/>
-          </a:bodyPr>
-          <a:lstStyle/>
-          <a:p>
-            <a:pPr algn="ctr">
-              <a:lnSpc>
-                <a:spcPct val="105000"/>
-              </a:lnSpc>
-            </a:pPr>
-            <a:r>
-              <a:rPr lang="ja-JP" altLang="en-US" sz="1600" b="0" dirty="0">
-                <a:solidFill>
-                  <a:srgbClr val="000000"/>
-                </a:solidFill>
-                <a:latin typeface="Meiryo"/>
-                <a:ea typeface="Meiryo"/>
-              </a:rPr>
-              <a:t>停止1〜6／起動7〜14</a:t>
-            </a:r>
-          </a:p>
-        </p:txBody>
-      </p:sp>
-      <p:sp>
-        <p:nvSpPr>
-          <p:cNvPr id="21520" name="S47">
-            <a:extLst>
-              <a:ext uri="{FF2B5EF4-FFF2-40B4-BE49-F238E27FC236}">
-                <a16:creationId xmlns:a16="http://schemas.microsoft.com/office/drawing/2014/main" id="{07C8C824-0855-F504-5ED2-033E183E5AC7}"/>
-              </a:ext>
-            </a:extLst>
-          </p:cNvPr>
-          <p:cNvSpPr/>
-          <p:nvPr/>
-        </p:nvSpPr>
-        <p:spPr>
-          <a:xfrm>
-            <a:off x="8856000" y="4099100"/>
-            <a:ext cx="468000" cy="288000"/>
-          </a:xfrm>
-          <a:prstGeom prst="rightArrow">
-            <a:avLst/>
-          </a:prstGeom>
-          <a:solidFill>
-            <a:srgbClr val="C9C9C9"/>
-          </a:solidFill>
-          <a:ln>
-            <a:noFill/>
-          </a:ln>
-        </p:spPr>
-        <p:txBody>
-          <a:bodyPr wrap="square" lIns="72000" tIns="36000" rIns="72000" bIns="36000" anchor="ctr">
-            <a:noAutofit/>
-          </a:bodyPr>
-          <a:lstStyle/>
-          <a:p>
-            <a:pPr algn="ctr">
-              <a:lnSpc>
-                <a:spcPct val="105000"/>
-              </a:lnSpc>
-            </a:pPr>
-            <a:endParaRPr sz="2800"/>
-          </a:p>
-        </p:txBody>
-      </p:sp>
-      <p:sp>
-        <p:nvSpPr>
-          <p:cNvPr id="21522" name="S48">
-            <a:extLst>
-              <a:ext uri="{FF2B5EF4-FFF2-40B4-BE49-F238E27FC236}">
-                <a16:creationId xmlns:a16="http://schemas.microsoft.com/office/drawing/2014/main" id="{23394E18-7729-EF9C-1A57-D32D35698E0B}"/>
-              </a:ext>
-            </a:extLst>
-          </p:cNvPr>
-          <p:cNvSpPr/>
-          <p:nvPr/>
-        </p:nvSpPr>
-        <p:spPr>
-          <a:xfrm>
-            <a:off x="9396000" y="3883100"/>
-            <a:ext cx="2232000" cy="720000"/>
-          </a:xfrm>
-          <a:prstGeom prst="roundRect">
-            <a:avLst/>
-          </a:prstGeom>
-          <a:solidFill>
-            <a:schemeClr val="accent1">
-              <a:lumMod val="90000"/>
-            </a:schemeClr>
-          </a:solidFill>
-          <a:ln w="9525">
-            <a:solidFill>
-              <a:srgbClr val="9B9B9B"/>
-            </a:solidFill>
-          </a:ln>
-        </p:spPr>
-        <p:txBody>
-          <a:bodyPr wrap="square" lIns="72000" tIns="36000" rIns="72000" bIns="36000" anchor="ctr">
-            <a:noAutofit/>
-          </a:bodyPr>
-          <a:lstStyle/>
-          <a:p>
-            <a:pPr algn="ctr">
-              <a:lnSpc>
-                <a:spcPct val="105000"/>
-              </a:lnSpc>
-            </a:pPr>
-            <a:r>
-              <a:rPr lang="ja-JP" altLang="en-US" sz="1600" b="1" dirty="0">
-                <a:solidFill>
-                  <a:srgbClr val="000000"/>
-                </a:solidFill>
-                <a:latin typeface="Meiryo"/>
-                <a:ea typeface="Meiryo"/>
-              </a:rPr>
-              <a:t>管理手順書案2冊作成</a:t>
-            </a:r>
-          </a:p>
-        </p:txBody>
-      </p:sp>
-      <p:sp>
-        <p:nvSpPr>
-          <p:cNvPr id="21527" name="右大かっこ 21526">
-            <a:extLst>
-              <a:ext uri="{FF2B5EF4-FFF2-40B4-BE49-F238E27FC236}">
-                <a16:creationId xmlns:a16="http://schemas.microsoft.com/office/drawing/2014/main" id="{231EE372-2D83-A895-742F-441F2D69583B}"/>
-              </a:ext>
-            </a:extLst>
-          </p:cNvPr>
-          <p:cNvSpPr/>
-          <p:nvPr/>
-        </p:nvSpPr>
-        <p:spPr>
-          <a:xfrm rot="16200000">
-            <a:off x="5873412" y="-2819756"/>
-            <a:ext cx="445175" cy="9216537"/>
-          </a:xfrm>
-          <a:prstGeom prst="rightBracket">
-            <a:avLst/>
-          </a:prstGeom>
-          <a:ln w="38100"/>
-        </p:spPr>
-        <p:style>
-          <a:lnRef idx="1">
-            <a:schemeClr val="accent1"/>
-          </a:lnRef>
-          <a:fillRef idx="0">
-            <a:schemeClr val="accent1"/>
-          </a:fillRef>
-          <a:effectRef idx="0">
-            <a:schemeClr val="accent1"/>
-          </a:effectRef>
-          <a:fontRef idx="minor">
-            <a:schemeClr val="tx1"/>
-          </a:fontRef>
-        </p:style>
-        <p:txBody>
-          <a:bodyPr rtlCol="0" anchor="ctr"/>
-          <a:lstStyle/>
-          <a:p>
-            <a:pPr algn="ctr"/>
-            <a:endParaRPr kumimoji="1" lang="ja-JP" altLang="en-US">
-              <a:solidFill>
-                <a:schemeClr val="accent5">
-                  <a:lumMod val="50000"/>
-                </a:schemeClr>
-              </a:solidFill>
-            </a:endParaRPr>
-          </a:p>
-        </p:txBody>
-      </p:sp>
-      <p:sp>
-        <p:nvSpPr>
-          <p:cNvPr id="21529" name="TB28">
-            <a:extLst>
-              <a:ext uri="{FF2B5EF4-FFF2-40B4-BE49-F238E27FC236}">
-                <a16:creationId xmlns:a16="http://schemas.microsoft.com/office/drawing/2014/main" id="{08D3BE1E-A7CA-BEB2-ADB6-594EF66852D4}"/>
-              </a:ext>
-            </a:extLst>
-          </p:cNvPr>
-          <p:cNvSpPr txBox="1"/>
-          <p:nvPr/>
-        </p:nvSpPr>
-        <p:spPr>
-          <a:xfrm>
-            <a:off x="540000" y="4968559"/>
-            <a:ext cx="5040000" cy="288000"/>
-          </a:xfrm>
-          <a:prstGeom prst="rect">
-            <a:avLst/>
-          </a:prstGeom>
-          <a:noFill/>
-        </p:spPr>
-        <p:txBody>
-          <a:bodyPr wrap="square" lIns="0" tIns="0" rIns="0" bIns="0" anchor="t">
-            <a:noAutofit/>
-          </a:bodyPr>
-          <a:lstStyle/>
-          <a:p>
-            <a:pPr algn="l">
-              <a:lnSpc>
-                <a:spcPct val="112000"/>
-              </a:lnSpc>
-              <a:spcAft>
-                <a:spcPts val="400"/>
-              </a:spcAft>
-            </a:pPr>
-            <a:r>
-              <a:rPr lang="ja-JP" altLang="en-US" b="1" dirty="0">
-                <a:solidFill>
-                  <a:srgbClr val="000000"/>
-                </a:solidFill>
-                <a:latin typeface="Meiryo"/>
-                <a:ea typeface="Meiryo"/>
-              </a:rPr>
-              <a:t>数字</a:t>
-            </a:r>
-          </a:p>
-        </p:txBody>
-      </p:sp>
-      <p:sp>
-        <p:nvSpPr>
-          <p:cNvPr id="21531" name="TB29">
-            <a:extLst>
-              <a:ext uri="{FF2B5EF4-FFF2-40B4-BE49-F238E27FC236}">
-                <a16:creationId xmlns:a16="http://schemas.microsoft.com/office/drawing/2014/main" id="{0E081BA2-CF81-69EE-3F51-8B71713AA293}"/>
-              </a:ext>
-            </a:extLst>
-          </p:cNvPr>
-          <p:cNvSpPr txBox="1"/>
-          <p:nvPr/>
-        </p:nvSpPr>
-        <p:spPr>
-          <a:xfrm>
-            <a:off x="391933" y="5251100"/>
-            <a:ext cx="10656000" cy="936000"/>
-          </a:xfrm>
-          <a:prstGeom prst="rect">
-            <a:avLst/>
-          </a:prstGeom>
-          <a:noFill/>
-        </p:spPr>
-        <p:txBody>
-          <a:bodyPr wrap="square" lIns="0" tIns="0" rIns="0" bIns="0" anchor="t">
-            <a:noAutofit/>
-          </a:bodyPr>
-          <a:lstStyle/>
-          <a:p>
-            <a:pPr algn="l">
-              <a:lnSpc>
-                <a:spcPct val="112000"/>
-              </a:lnSpc>
-              <a:spcAft>
-                <a:spcPts val="400"/>
-              </a:spcAft>
-            </a:pPr>
-            <a:r>
-              <a:rPr lang="ja-JP" altLang="en-US" b="0" dirty="0">
-                <a:solidFill>
-                  <a:srgbClr val="000000"/>
-                </a:solidFill>
-                <a:latin typeface="Meiryo"/>
-                <a:ea typeface="Meiryo"/>
-              </a:rPr>
-              <a:t>・目標：案2冊の承認 → 実績：案2冊を作成(107頁/99頁、未承認)。管理書v0.12・LNB管理書v0.11に反映。</a:t>
-            </a:r>
-            <a:endParaRPr lang="en-US" altLang="ja-JP" b="0" dirty="0">
-              <a:solidFill>
-                <a:srgbClr val="000000"/>
-              </a:solidFill>
-              <a:latin typeface="Meiryo"/>
-              <a:ea typeface="Meiryo"/>
-            </a:endParaRPr>
-          </a:p>
-          <a:p>
-            <a:pPr algn="l">
-              <a:lnSpc>
-                <a:spcPct val="112000"/>
-              </a:lnSpc>
-              <a:spcAft>
-                <a:spcPts val="400"/>
-              </a:spcAft>
-            </a:pPr>
-            <a:r>
-              <a:rPr lang="ja-JP" altLang="en-US" b="0" dirty="0">
-                <a:solidFill>
-                  <a:srgbClr val="000000"/>
-                </a:solidFill>
-                <a:latin typeface="Meiryo"/>
-                <a:ea typeface="Meiryo"/>
-              </a:rPr>
-              <a:t>・会議で決定した方針に基づき、再起動手順の掲載を統合した。</a:t>
-            </a:r>
-            <a:endParaRPr lang="en-US" altLang="ja-JP" b="0" dirty="0">
-              <a:solidFill>
-                <a:srgbClr val="000000"/>
-              </a:solidFill>
-              <a:latin typeface="Meiryo"/>
-              <a:ea typeface="Meiryo"/>
-            </a:endParaRPr>
-          </a:p>
-          <a:p>
-            <a:pPr algn="l">
-              <a:lnSpc>
-                <a:spcPct val="112000"/>
-              </a:lnSpc>
-              <a:spcAft>
-                <a:spcPts val="400"/>
-              </a:spcAft>
-            </a:pPr>
-            <a:r>
-              <a:rPr lang="ja-JP" altLang="en-US" b="0" dirty="0">
-                <a:solidFill>
-                  <a:srgbClr val="000000"/>
-                </a:solidFill>
-                <a:latin typeface="Meiryo"/>
-                <a:ea typeface="Meiryo"/>
-              </a:rPr>
-              <a:t>→ 次の展開：相関図と画像の追加は10/28まで。LNB点検項目の登録は12/28。</a:t>
-            </a:r>
-            <a:endParaRPr lang="en-US" altLang="ja-JP" b="0" dirty="0">
-              <a:solidFill>
-                <a:srgbClr val="000000"/>
-              </a:solidFill>
-              <a:latin typeface="Meiryo"/>
-              <a:ea typeface="Meiryo"/>
-            </a:endParaRPr>
-          </a:p>
-        </p:txBody>
-      </p:sp>
-      <p:sp>
-        <p:nvSpPr>
-          <p:cNvPr id="21533" name="テキスト ボックス 21532">
-            <a:extLst>
-              <a:ext uri="{FF2B5EF4-FFF2-40B4-BE49-F238E27FC236}">
-                <a16:creationId xmlns:a16="http://schemas.microsoft.com/office/drawing/2014/main" id="{B85F4D50-9C37-7186-F9DF-DF2611B8DAE4}"/>
-              </a:ext>
-            </a:extLst>
-          </p:cNvPr>
-          <p:cNvSpPr txBox="1"/>
-          <p:nvPr/>
-        </p:nvSpPr>
-        <p:spPr>
-          <a:xfrm>
-            <a:off x="4068000" y="1137917"/>
-            <a:ext cx="3600000" cy="350865"/>
-          </a:xfrm>
-          <a:prstGeom prst="rect">
-            <a:avLst/>
-          </a:prstGeom>
-          <a:noFill/>
-          <a:ln>
-            <a:solidFill>
-              <a:schemeClr val="tx2"/>
-            </a:solidFill>
-          </a:ln>
-        </p:spPr>
-        <p:txBody>
-          <a:bodyPr wrap="square">
-            <a:spAutoFit/>
-          </a:bodyPr>
-          <a:lstStyle/>
-          <a:p>
-            <a:pPr algn="ctr">
-              <a:lnSpc>
-                <a:spcPct val="105000"/>
-              </a:lnSpc>
-            </a:pPr>
-            <a:r>
-              <a:rPr lang="ja-JP" altLang="en-US" sz="1600" dirty="0">
-                <a:solidFill>
-                  <a:schemeClr val="tx1">
-                    <a:lumMod val="95000"/>
-                    <a:lumOff val="5000"/>
-                  </a:schemeClr>
-                </a:solidFill>
-                <a:latin typeface="Meiryo"/>
-                <a:ea typeface="Meiryo"/>
-              </a:rPr>
-              <a:t>10/14 会議で統合方針を決定</a:t>
-            </a:r>
-            <a:endParaRPr lang="ja-JP" altLang="en-US" sz="1600" b="0" dirty="0">
-              <a:solidFill>
-                <a:schemeClr val="tx1">
-                  <a:lumMod val="95000"/>
-                  <a:lumOff val="5000"/>
-                </a:schemeClr>
-              </a:solidFill>
-              <a:latin typeface="Meiryo"/>
-              <a:ea typeface="Meiryo"/>
             </a:endParaRPr>
           </a:p>
         </p:txBody>
@@ -8518,6 +5666,477 @@
           <a:lstStyle/>
           <a:p>
             <a:endParaRPr lang="ja-JP"/>
+          </a:p>
+        </p:txBody>
+      </p:sp>
+      <p:sp>
+        <p:nvSpPr>
+          <p:cNvPr id="9101" name="TB21">
+            <a:extLst>
+              <a:ext uri="{FF2B5EF4-FFF2-40B4-BE49-F238E27FC236}">
+                <a16:creationId xmlns:a16="http://schemas.microsoft.com/office/drawing/2014/main" id="{9D8E4493-09ED-D66D-BB69-F4E17FDDAAE5}"/>
+              </a:ext>
+            </a:extLst>
+          </p:cNvPr>
+          <p:cNvSpPr txBox="1"/>
+          <p:nvPr/>
+        </p:nvSpPr>
+        <p:spPr>
+          <a:xfrm>
+            <a:off x="36000" y="928195"/>
+            <a:ext cx="2871216" cy="288000"/>
+          </a:xfrm>
+          <a:prstGeom prst="rect">
+            <a:avLst/>
+          </a:prstGeom>
+          <a:noFill/>
+        </p:spPr>
+        <p:txBody>
+          <a:bodyPr wrap="square" lIns="0" tIns="0" rIns="0" bIns="0" anchor="t">
+            <a:noAutofit/>
+          </a:bodyPr>
+          <a:lstStyle/>
+          <a:p>
+            <a:pPr algn="l">
+              <a:lnSpc>
+                <a:spcPct val="112000"/>
+              </a:lnSpc>
+              <a:spcAft>
+                <a:spcPts val="400"/>
+              </a:spcAft>
+            </a:pPr>
+            <a:r>
+              <a:rPr lang="ja-JP" altLang="en-US" sz="1400" b="0" dirty="0">
+                <a:solidFill>
+                  <a:srgbClr val="666666"/>
+                </a:solidFill>
+                <a:latin typeface="Meiryo"/>
+                <a:ea typeface="Meiryo"/>
+              </a:rPr>
+              <a:t>実施時期：9〜10月(本番10月末)</a:t>
+            </a:r>
+          </a:p>
+        </p:txBody>
+      </p:sp>
+      <p:sp>
+        <p:nvSpPr>
+          <p:cNvPr id="9102" name="TB22">
+            <a:extLst>
+              <a:ext uri="{FF2B5EF4-FFF2-40B4-BE49-F238E27FC236}">
+                <a16:creationId xmlns:a16="http://schemas.microsoft.com/office/drawing/2014/main" id="{A76CBF8E-780A-F613-552A-79DF92A79B34}"/>
+              </a:ext>
+            </a:extLst>
+          </p:cNvPr>
+          <p:cNvSpPr txBox="1"/>
+          <p:nvPr/>
+        </p:nvSpPr>
+        <p:spPr>
+          <a:xfrm>
+            <a:off x="540000" y="1512800"/>
+            <a:ext cx="5040000" cy="288000"/>
+          </a:xfrm>
+          <a:prstGeom prst="rect">
+            <a:avLst/>
+          </a:prstGeom>
+          <a:noFill/>
+        </p:spPr>
+        <p:txBody>
+          <a:bodyPr wrap="square" lIns="0" tIns="0" rIns="0" bIns="0" anchor="t">
+            <a:noAutofit/>
+          </a:bodyPr>
+          <a:lstStyle/>
+          <a:p>
+            <a:pPr algn="l">
+              <a:lnSpc>
+                <a:spcPct val="112000"/>
+              </a:lnSpc>
+              <a:spcAft>
+                <a:spcPts val="400"/>
+              </a:spcAft>
+            </a:pPr>
+            <a:r>
+              <a:rPr lang="ja-JP" altLang="en-US" b="1" dirty="0">
+                <a:solidFill>
+                  <a:srgbClr val="000000"/>
+                </a:solidFill>
+                <a:latin typeface="Meiryo"/>
+                <a:ea typeface="Meiryo"/>
+              </a:rPr>
+              <a:t>前提と0確認マクロとは</a:t>
+            </a:r>
+          </a:p>
+        </p:txBody>
+      </p:sp>
+      <p:sp>
+        <p:nvSpPr>
+          <p:cNvPr id="9103" name="TB23">
+            <a:extLst>
+              <a:ext uri="{FF2B5EF4-FFF2-40B4-BE49-F238E27FC236}">
+                <a16:creationId xmlns:a16="http://schemas.microsoft.com/office/drawing/2014/main" id="{334C37F2-BE3E-BFC0-CAB9-D3917FDC0606}"/>
+              </a:ext>
+            </a:extLst>
+          </p:cNvPr>
+          <p:cNvSpPr txBox="1"/>
+          <p:nvPr/>
+        </p:nvSpPr>
+        <p:spPr>
+          <a:xfrm>
+            <a:off x="756000" y="1813174"/>
+            <a:ext cx="10656000" cy="1119581"/>
+          </a:xfrm>
+          <a:prstGeom prst="rect">
+            <a:avLst/>
+          </a:prstGeom>
+          <a:noFill/>
+        </p:spPr>
+        <p:txBody>
+          <a:bodyPr wrap="square" lIns="0" tIns="0" rIns="0" bIns="0" anchor="t">
+            <a:noAutofit/>
+          </a:bodyPr>
+          <a:lstStyle/>
+          <a:p>
+            <a:pPr algn="l">
+              <a:lnSpc>
+                <a:spcPct val="112000"/>
+              </a:lnSpc>
+              <a:spcAft>
+                <a:spcPts val="400"/>
+              </a:spcAft>
+            </a:pPr>
+            <a:r>
+              <a:rPr lang="ja-JP" altLang="en-US" b="0" dirty="0">
+                <a:solidFill>
+                  <a:srgbClr val="000000"/>
+                </a:solidFill>
+                <a:latin typeface="Meiryo"/>
+                <a:ea typeface="Meiryo"/>
+              </a:rPr>
+              <a:t>・棚卸の手順は既に確立しており、実装要件も充足。</a:t>
+            </a:r>
+            <a:endParaRPr lang="en-US" altLang="ja-JP" b="0" dirty="0">
+              <a:solidFill>
+                <a:srgbClr val="000000"/>
+              </a:solidFill>
+              <a:latin typeface="Meiryo"/>
+              <a:ea typeface="Meiryo"/>
+            </a:endParaRPr>
+          </a:p>
+          <a:p>
+            <a:pPr algn="l">
+              <a:lnSpc>
+                <a:spcPct val="112000"/>
+              </a:lnSpc>
+              <a:spcAft>
+                <a:spcPts val="400"/>
+              </a:spcAft>
+            </a:pPr>
+            <a:r>
+              <a:rPr lang="ja-JP" altLang="en-US" b="0" dirty="0">
+                <a:solidFill>
+                  <a:srgbClr val="000000"/>
+                </a:solidFill>
+                <a:latin typeface="Meiryo"/>
+                <a:ea typeface="Meiryo"/>
+              </a:rPr>
+              <a:t>・0確認マクロ＝EG-Pro倉庫在庫CSVから、「0確認」で始まり在庫数上限以下の品目を抽出しA列へ書き出すツール。抽出分が在庫ゼロ確認(消し込み)の対象。</a:t>
+            </a:r>
+            <a:endParaRPr lang="en-US" altLang="ja-JP" b="0" dirty="0">
+              <a:solidFill>
+                <a:srgbClr val="000000"/>
+              </a:solidFill>
+              <a:latin typeface="Meiryo"/>
+              <a:ea typeface="Meiryo"/>
+            </a:endParaRPr>
+          </a:p>
+        </p:txBody>
+      </p:sp>
+      <p:sp>
+        <p:nvSpPr>
+          <p:cNvPr id="9104" name="TB24">
+            <a:extLst>
+              <a:ext uri="{FF2B5EF4-FFF2-40B4-BE49-F238E27FC236}">
+                <a16:creationId xmlns:a16="http://schemas.microsoft.com/office/drawing/2014/main" id="{CFA581EB-E5DD-E949-61AD-F14177A9CC17}"/>
+              </a:ext>
+            </a:extLst>
+          </p:cNvPr>
+          <p:cNvSpPr txBox="1"/>
+          <p:nvPr/>
+        </p:nvSpPr>
+        <p:spPr>
+          <a:xfrm>
+            <a:off x="540000" y="3043668"/>
+            <a:ext cx="5040000" cy="288000"/>
+          </a:xfrm>
+          <a:prstGeom prst="rect">
+            <a:avLst/>
+          </a:prstGeom>
+          <a:noFill/>
+        </p:spPr>
+        <p:txBody>
+          <a:bodyPr wrap="square" lIns="0" tIns="0" rIns="0" bIns="0" anchor="t">
+            <a:noAutofit/>
+          </a:bodyPr>
+          <a:lstStyle/>
+          <a:p>
+            <a:pPr algn="l">
+              <a:lnSpc>
+                <a:spcPct val="112000"/>
+              </a:lnSpc>
+              <a:spcAft>
+                <a:spcPts val="400"/>
+              </a:spcAft>
+            </a:pPr>
+            <a:r>
+              <a:rPr lang="ja-JP" altLang="en-US" b="1" dirty="0">
+                <a:solidFill>
+                  <a:srgbClr val="000000"/>
+                </a:solidFill>
+                <a:latin typeface="Meiryo"/>
+                <a:ea typeface="Meiryo"/>
+              </a:rPr>
+              <a:t>やったこと（改修の3ポイント）</a:t>
+            </a:r>
+          </a:p>
+        </p:txBody>
+      </p:sp>
+      <p:sp>
+        <p:nvSpPr>
+          <p:cNvPr id="9105" name="TB25">
+            <a:extLst>
+              <a:ext uri="{FF2B5EF4-FFF2-40B4-BE49-F238E27FC236}">
+                <a16:creationId xmlns:a16="http://schemas.microsoft.com/office/drawing/2014/main" id="{CBB4D034-4453-9918-E427-6F3BF26F1E67}"/>
+              </a:ext>
+            </a:extLst>
+          </p:cNvPr>
+          <p:cNvSpPr txBox="1"/>
+          <p:nvPr/>
+        </p:nvSpPr>
+        <p:spPr>
+          <a:xfrm>
+            <a:off x="756000" y="3442581"/>
+            <a:ext cx="10656000" cy="771569"/>
+          </a:xfrm>
+          <a:prstGeom prst="rect">
+            <a:avLst/>
+          </a:prstGeom>
+          <a:noFill/>
+        </p:spPr>
+        <p:txBody>
+          <a:bodyPr wrap="square" lIns="0" tIns="0" rIns="0" bIns="0" anchor="t">
+            <a:noAutofit/>
+          </a:bodyPr>
+          <a:lstStyle/>
+          <a:p>
+            <a:pPr algn="l">
+              <a:lnSpc>
+                <a:spcPct val="112000"/>
+              </a:lnSpc>
+              <a:spcAft>
+                <a:spcPts val="400"/>
+              </a:spcAft>
+            </a:pPr>
+            <a:r>
+              <a:rPr lang="ja-JP" altLang="en-US" b="0" dirty="0">
+                <a:solidFill>
+                  <a:srgbClr val="000000"/>
+                </a:solidFill>
+                <a:latin typeface="Meiryo"/>
+                <a:ea typeface="Meiryo"/>
+              </a:rPr>
+              <a:t>・0確認マクロが何かを、現場でも説明できる形に整理。</a:t>
+            </a:r>
+            <a:endParaRPr lang="en-US" altLang="ja-JP" b="0" dirty="0">
+              <a:solidFill>
+                <a:srgbClr val="000000"/>
+              </a:solidFill>
+              <a:latin typeface="Meiryo"/>
+              <a:ea typeface="Meiryo"/>
+            </a:endParaRPr>
+          </a:p>
+          <a:p>
+            <a:pPr algn="l">
+              <a:lnSpc>
+                <a:spcPct val="112000"/>
+              </a:lnSpc>
+              <a:spcAft>
+                <a:spcPts val="400"/>
+              </a:spcAft>
+            </a:pPr>
+            <a:r>
+              <a:rPr lang="ja-JP" altLang="en-US" b="0" dirty="0">
+                <a:solidFill>
+                  <a:srgbClr val="000000"/>
+                </a:solidFill>
+                <a:latin typeface="Meiryo"/>
+                <a:ea typeface="Meiryo"/>
+              </a:rPr>
+              <a:t>・「実行ログ」シートへ件数・内訳を自動記録。取り込みはボタンからだれでも実行可能(既定9)。</a:t>
+            </a:r>
+            <a:endParaRPr lang="en-US" altLang="ja-JP" b="0" dirty="0">
+              <a:solidFill>
+                <a:srgbClr val="000000"/>
+              </a:solidFill>
+              <a:latin typeface="Meiryo"/>
+              <a:ea typeface="Meiryo"/>
+            </a:endParaRPr>
+          </a:p>
+        </p:txBody>
+      </p:sp>
+      <p:sp>
+        <p:nvSpPr>
+          <p:cNvPr id="9106" name="TB26">
+            <a:extLst>
+              <a:ext uri="{FF2B5EF4-FFF2-40B4-BE49-F238E27FC236}">
+                <a16:creationId xmlns:a16="http://schemas.microsoft.com/office/drawing/2014/main" id="{9EA7CA49-8438-F8C9-4C30-426972466047}"/>
+              </a:ext>
+            </a:extLst>
+          </p:cNvPr>
+          <p:cNvSpPr txBox="1"/>
+          <p:nvPr/>
+        </p:nvSpPr>
+        <p:spPr>
+          <a:xfrm>
+            <a:off x="540000" y="4325063"/>
+            <a:ext cx="5040000" cy="288000"/>
+          </a:xfrm>
+          <a:prstGeom prst="rect">
+            <a:avLst/>
+          </a:prstGeom>
+          <a:noFill/>
+        </p:spPr>
+        <p:txBody>
+          <a:bodyPr wrap="square" lIns="0" tIns="0" rIns="0" bIns="0" anchor="t">
+            <a:noAutofit/>
+          </a:bodyPr>
+          <a:lstStyle/>
+          <a:p>
+            <a:pPr algn="l">
+              <a:lnSpc>
+                <a:spcPct val="112000"/>
+              </a:lnSpc>
+              <a:spcAft>
+                <a:spcPts val="400"/>
+              </a:spcAft>
+            </a:pPr>
+            <a:r>
+              <a:rPr lang="ja-JP" altLang="en-US" b="1" dirty="0">
+                <a:solidFill>
+                  <a:srgbClr val="000000"/>
+                </a:solidFill>
+                <a:latin typeface="Meiryo"/>
+                <a:ea typeface="Meiryo"/>
+              </a:rPr>
+              <a:t>数字</a:t>
+            </a:r>
+          </a:p>
+        </p:txBody>
+      </p:sp>
+      <p:sp>
+        <p:nvSpPr>
+          <p:cNvPr id="9107" name="TB27">
+            <a:extLst>
+              <a:ext uri="{FF2B5EF4-FFF2-40B4-BE49-F238E27FC236}">
+                <a16:creationId xmlns:a16="http://schemas.microsoft.com/office/drawing/2014/main" id="{0E391B8E-AB01-AC75-D1D9-4BA5617A534F}"/>
+              </a:ext>
+            </a:extLst>
+          </p:cNvPr>
+          <p:cNvSpPr txBox="1"/>
+          <p:nvPr/>
+        </p:nvSpPr>
+        <p:spPr>
+          <a:xfrm>
+            <a:off x="756000" y="4722706"/>
+            <a:ext cx="10656000" cy="1495561"/>
+          </a:xfrm>
+          <a:prstGeom prst="rect">
+            <a:avLst/>
+          </a:prstGeom>
+          <a:noFill/>
+        </p:spPr>
+        <p:txBody>
+          <a:bodyPr wrap="square" lIns="0" tIns="0" rIns="0" bIns="0" anchor="t">
+            <a:noAutofit/>
+          </a:bodyPr>
+          <a:lstStyle/>
+          <a:p>
+            <a:pPr algn="l">
+              <a:lnSpc>
+                <a:spcPct val="112000"/>
+              </a:lnSpc>
+              <a:spcAft>
+                <a:spcPts val="400"/>
+              </a:spcAft>
+            </a:pPr>
+            <a:r>
+              <a:rPr lang="ja-JP" altLang="en-US" b="0" dirty="0">
+                <a:solidFill>
+                  <a:srgbClr val="000000"/>
+                </a:solidFill>
+                <a:latin typeface="Meiryo"/>
+                <a:ea typeface="Meiryo"/>
+              </a:rPr>
+              <a:t>・実装(10/22)：正本へ実装しコンパイル通過。</a:t>
+            </a:r>
+          </a:p>
+          <a:p>
+            <a:pPr algn="l">
+              <a:lnSpc>
+                <a:spcPct val="112000"/>
+              </a:lnSpc>
+              <a:spcAft>
+                <a:spcPts val="400"/>
+              </a:spcAft>
+            </a:pPr>
+            <a:r>
+              <a:rPr lang="ja-JP" altLang="en-US" b="0" dirty="0">
+                <a:solidFill>
+                  <a:srgbClr val="000000"/>
+                </a:solidFill>
+                <a:latin typeface="Meiryo"/>
+                <a:ea typeface="Meiryo"/>
+              </a:rPr>
+              <a:t>・試験：写しに10/1版CSV(29,265行)を取込→6,024件が事前計算と全項目一致。</a:t>
+            </a:r>
+          </a:p>
+          <a:p>
+            <a:pPr algn="l">
+              <a:lnSpc>
+                <a:spcPct val="112000"/>
+              </a:lnSpc>
+              <a:spcAft>
+                <a:spcPts val="400"/>
+              </a:spcAft>
+            </a:pPr>
+            <a:r>
+              <a:rPr lang="ja-JP" altLang="en-US" b="0" dirty="0">
+                <a:solidFill>
+                  <a:srgbClr val="000000"/>
+                </a:solidFill>
+                <a:latin typeface="Meiryo"/>
+                <a:ea typeface="Meiryo"/>
+              </a:rPr>
+              <a:t>・計算機：本日(10/22)に機能改修の提案→実装中。予定通り実行できる見込み。</a:t>
+            </a:r>
+          </a:p>
+          <a:p>
+            <a:pPr algn="l">
+              <a:lnSpc>
+                <a:spcPct val="112000"/>
+              </a:lnSpc>
+              <a:spcAft>
+                <a:spcPts val="400"/>
+              </a:spcAft>
+            </a:pPr>
+            <a:r>
+              <a:rPr lang="ja-JP" altLang="en-US" b="0" dirty="0">
+                <a:solidFill>
+                  <a:srgbClr val="000000"/>
+                </a:solidFill>
+                <a:latin typeface="Meiryo"/>
+                <a:ea typeface="Meiryo"/>
+              </a:rPr>
+              <a:t>→ 次の展開：全体の手順を整備し仕様書を完成。リール消費取消可否の現場確認が前提。本番10月末(合格判断の上)。</a:t>
+            </a:r>
           </a:p>
         </p:txBody>
       </p:sp>
@@ -8591,7 +6210,7 @@
                 <a:latin typeface="Meiryo"/>
                 <a:ea typeface="Meiryo"/>
               </a:rPr>
-              <a:t>テーマ3　固定テーブル棚卸しマクロver.2の改修</a:t>
+              <a:t>テーマ3　鹿島引き込みに伴うツール改修</a:t>
             </a:r>
             <a:endParaRPr lang="ja-JP" altLang="en-US" sz="3600" dirty="0">
               <a:solidFill>
@@ -8645,7 +6264,7 @@
                 <a:latin typeface="Meiryo"/>
                 <a:ea typeface="Meiryo"/>
               </a:rPr>
-              <a:t>背景</a:t>
+              <a:t>目標</a:t>
             </a:r>
           </a:p>
         </p:txBody>
@@ -8694,7 +6313,7 @@
                 <a:latin typeface="Meiryo"/>
                 <a:ea typeface="Meiryo"/>
               </a:rPr>
-              <a:t>・旧版は現場で動く実績がある一方、空欄の扱い・送信漏れなど直すべき点が判明していた。</a:t>
+              <a:t>・ジョブ作成時の容量・負荷率の計算ツールを改修し、鹿島品目の導入時も通常通りの運用を可能にする。</a:t>
             </a:r>
           </a:p>
           <a:p>
@@ -8714,7 +6333,7 @@
                 <a:latin typeface="Meiryo"/>
                 <a:ea typeface="Meiryo"/>
               </a:rPr>
-              <a:t>・実機での検証工程が無く、本番までに動作を確かめる方法が残されていなかった。</a:t>
+              <a:t>・このテーマの進捗報告は生産一課へ行う運用。</a:t>
             </a:r>
           </a:p>
         </p:txBody>
@@ -8812,15 +6431,8 @@
                 <a:latin typeface="Meiryo"/>
                 <a:ea typeface="Meiryo"/>
               </a:rPr>
-              <a:t>・改良点だけをver.2本体へ統合(設定読み込み1回化・空欄スキップ・送信漏れで中断)。</a:t>
-            </a:r>
-            <a:endParaRPr lang="ja-JP" altLang="en-US" sz="1600" b="0" dirty="0">
-              <a:solidFill>
-                <a:srgbClr val="000000"/>
-              </a:solidFill>
-              <a:latin typeface="Meiryo"/>
-              <a:ea typeface="Meiryo"/>
-            </a:endParaRPr>
+              <a:t>・先週〜今週、茂木さんのBOSS計画の負荷率計算を支援。品目合計数別の負荷率比較グラフを作成。</a:t>
+            </a:r>
           </a:p>
           <a:p>
             <a:pPr algn="l">
@@ -8839,15 +6451,8 @@
                 <a:latin typeface="Meiryo"/>
                 <a:ea typeface="Meiryo"/>
               </a:rPr>
-              <a:t>・旧版の実績を尊重し、勝手な書き換えはしない方針で改修。</a:t>
-            </a:r>
-            <a:endParaRPr lang="ja-JP" altLang="en-US" sz="1600" b="0" dirty="0">
-              <a:solidFill>
-                <a:srgbClr val="000000"/>
-              </a:solidFill>
-              <a:latin typeface="Meiryo"/>
-              <a:ea typeface="Meiryo"/>
-            </a:endParaRPr>
+              <a:t>・BOSSデータの品目別・月別の集計(ピボット)も実施。</a:t>
+            </a:r>
           </a:p>
           <a:p>
             <a:pPr algn="l">
@@ -8866,15 +6471,8 @@
                 <a:latin typeface="Meiryo"/>
                 <a:ea typeface="Meiryo"/>
               </a:rPr>
-              <a:t>・テストケース47件を作成し、コンパイル→試し実行10件→本番1件→10件の段階で検証する。</a:t>
-            </a:r>
-            <a:endParaRPr lang="ja-JP" altLang="en-US" sz="1600" b="0" dirty="0">
-              <a:solidFill>
-                <a:srgbClr val="000000"/>
-              </a:solidFill>
-              <a:latin typeface="Meiryo"/>
-              <a:ea typeface="Meiryo"/>
-            </a:endParaRPr>
+              <a:t>・不足部品計算リストのB列差異は9/24に1件対応済み。</a:t>
+            </a:r>
           </a:p>
         </p:txBody>
       </p:sp>
@@ -9132,7 +6730,7 @@
                           <a:latin typeface="Meiryo"/>
                           <a:ea typeface="Meiryo"/>
                         </a:rPr>
-                        <a:t>改修の統合</a:t>
+                        <a:t>負荷率計算の支援</a:t>
                       </a:r>
                     </a:p>
                   </a:txBody>
@@ -9176,7 +6774,7 @@
                           <a:latin typeface="Meiryo"/>
                           <a:ea typeface="Meiryo"/>
                         </a:rPr>
-                        <a:t>ver.2本体へ統合(3点)</a:t>
+                        <a:t>BOSS計画(鹿島4品目+NKV)を7版作成・比較</a:t>
                       </a:r>
                     </a:p>
                   </a:txBody>
@@ -9220,7 +6818,7 @@
                           <a:latin typeface="Meiryo"/>
                           <a:ea typeface="Meiryo"/>
                         </a:rPr>
-                        <a:t>完了(未検証)</a:t>
+                        <a:t>完了</a:t>
                       </a:r>
                     </a:p>
                   </a:txBody>
@@ -9271,7 +6869,7 @@
                           <a:latin typeface="Meiryo"/>
                           <a:ea typeface="Meiryo"/>
                         </a:rPr>
-                        <a:t>テストケース</a:t>
+                        <a:t>負荷率比較グラフ</a:t>
                       </a:r>
                     </a:p>
                   </a:txBody>
@@ -9315,7 +6913,7 @@
                           <a:latin typeface="Meiryo"/>
                           <a:ea typeface="Meiryo"/>
                         </a:rPr>
-                        <a:t>47件を作成</a:t>
+                        <a:t>品目合計数別で1点作成</a:t>
                       </a:r>
                     </a:p>
                   </a:txBody>
@@ -9410,7 +7008,7 @@
                           <a:latin typeface="Meiryo"/>
                           <a:ea typeface="Meiryo"/>
                         </a:rPr>
-                        <a:t>実機検証(4段階)</a:t>
+                        <a:t>BOSSデータの集計</a:t>
                       </a:r>
                     </a:p>
                   </a:txBody>
@@ -9454,7 +7052,7 @@
                           <a:latin typeface="Meiryo"/>
                           <a:ea typeface="Meiryo"/>
                         </a:rPr>
-                        <a:t>コンパイル→試し実行10件→本番1件→10件</a:t>
+                        <a:t>1,382行抽出→品目別227種・月別6か月のピボット</a:t>
                       </a:r>
                     </a:p>
                   </a:txBody>
@@ -9498,7 +7096,7 @@
                           <a:latin typeface="Meiryo"/>
                           <a:ea typeface="Meiryo"/>
                         </a:rPr>
-                        <a:t>0/4段階(未着手)</a:t>
+                        <a:t>完了(検証済み)</a:t>
                       </a:r>
                     </a:p>
                   </a:txBody>
@@ -9549,7 +7147,7 @@
                           <a:latin typeface="Meiryo"/>
                           <a:ea typeface="Meiryo"/>
                         </a:rPr>
-                        <a:t>処理時間の効果</a:t>
+                        <a:t>B列差異</a:t>
                       </a:r>
                     </a:p>
                   </a:txBody>
@@ -9593,7 +7191,7 @@
                           <a:latin typeface="Meiryo"/>
                           <a:ea typeface="Meiryo"/>
                         </a:rPr>
-                        <a:t>旧版との前後比較</a:t>
+                        <a:t>不足部品計算リストの修正</a:t>
                       </a:r>
                     </a:p>
                   </a:txBody>
@@ -9637,7 +7235,7 @@
                           <a:latin typeface="Meiryo"/>
                           <a:ea typeface="Meiryo"/>
                         </a:rPr>
-                        <a:t>未測定(実機検証時に測定)</a:t>
+                        <a:t>1件対応済み(9/24)</a:t>
                       </a:r>
                     </a:p>
                   </a:txBody>
@@ -9688,7 +7286,7 @@
                           <a:latin typeface="Meiryo"/>
                           <a:ea typeface="Meiryo"/>
                         </a:rPr>
-                        <a:t>本番</a:t>
+                        <a:t>残課題</a:t>
                       </a:r>
                     </a:p>
                   </a:txBody>
@@ -9732,7 +7330,7 @@
                           <a:latin typeface="Meiryo"/>
                           <a:ea typeface="Meiryo"/>
                         </a:rPr>
-                        <a:t>生産終了ラインから順に棚卸しを実施</a:t>
+                        <a:t>経緯資料化と品目選定システム改修の検討着手</a:t>
                       </a:r>
                     </a:p>
                   </a:txBody>
@@ -9776,7 +7374,7 @@
                           <a:latin typeface="Meiryo"/>
                           <a:ea typeface="Meiryo"/>
                         </a:rPr>
-                        <a:t>10月末(予定)</a:t>
+                        <a:t>導入時までに</a:t>
                       </a:r>
                     </a:p>
                   </a:txBody>
@@ -9860,7 +7458,7 @@
                 <a:latin typeface="Meiryo"/>
                 <a:ea typeface="Meiryo"/>
               </a:rPr>
-              <a:t>→ 次の展開：10月末の本番前に実機検証(4段階)を完了させる</a:t>
+              <a:t>→ 次の展開：経緯資料化と品目選定システム改修の検討着手</a:t>
             </a:r>
           </a:p>
         </p:txBody>
@@ -9918,7 +7516,7 @@
         <p:spPr>
           <a:xfrm>
             <a:off x="35999" y="928195"/>
-            <a:ext cx="2461667" cy="288000"/>
+            <a:ext cx="2873456" cy="288000"/>
           </a:xfrm>
           <a:prstGeom prst="rect">
             <a:avLst/>
@@ -9947,15 +7545,8 @@
                 <a:latin typeface="Meiryo"/>
                 <a:ea typeface="Meiryo"/>
               </a:rPr>
-              <a:t>実施時期：9〜10月(本番10月末)</a:t>
-            </a:r>
-            <a:endParaRPr lang="ja-JP" altLang="en-US" sz="1400" b="0" dirty="0">
-              <a:solidFill>
-                <a:srgbClr val="666666"/>
-              </a:solidFill>
-              <a:latin typeface="Meiryo"/>
-              <a:ea typeface="Meiryo"/>
-            </a:endParaRPr>
+              <a:t>実施時期：10〜3月</a:t>
+            </a:r>
           </a:p>
         </p:txBody>
       </p:sp>
@@ -10092,14 +7683,14 @@
           <p:nvPr>
             <p:extLst>
               <p:ext uri="{D42A27DB-BD31-4B8C-83A1-F6EECF244321}">
-                <p14:modId xmlns:p14="http://schemas.microsoft.com/office/powerpoint/2010/main" val="3853445471"/>
+                <p14:modId xmlns:p14="http://schemas.microsoft.com/office/powerpoint/2010/main" val="460388436"/>
               </p:ext>
             </p:extLst>
           </p:nvPr>
         </p:nvGraphicFramePr>
         <p:xfrm>
           <a:off x="272980" y="2128477"/>
-          <a:ext cx="11646040" cy="3600000"/>
+          <a:ext cx="11646040" cy="3954271"/>
         </p:xfrm>
         <a:graphic>
           <a:graphicData uri="http://schemas.openxmlformats.org/drawingml/2006/table">
@@ -10282,7 +7873,7 @@
                           <a:latin typeface="Meiryo"/>
                           <a:ea typeface="Meiryo"/>
                         </a:rPr>
-                        <a:t>成果✓</a:t>
+                        <a:t>成果</a:t>
                       </a:r>
                     </a:p>
                   </a:txBody>
@@ -10326,7 +7917,7 @@
                           <a:latin typeface="Meiryo"/>
                           <a:ea typeface="Meiryo"/>
                         </a:rPr>
-                        <a:t>0確認マクロver.2を運用確定(質問票35問を運用手順書へ反映)</a:t>
+                        <a:t>管理手順書案2冊を作成しレビュー段階まで(107頁/99頁・未承認)</a:t>
                       </a:r>
                       <a:endParaRPr lang="en-US" altLang="ja-JP" sz="1600" b="0" dirty="0">
                         <a:solidFill>
@@ -10428,7 +8019,7 @@
                           <a:latin typeface="Meiryo"/>
                           <a:ea typeface="Meiryo"/>
                         </a:rPr>
-                        <a:t>成果✓</a:t>
+                        <a:t>成果</a:t>
                       </a:r>
                     </a:p>
                   </a:txBody>
@@ -10472,7 +8063,7 @@
                           <a:latin typeface="Meiryo"/>
                           <a:ea typeface="Meiryo"/>
                         </a:rPr>
-                        <a:t>管理手順書案2冊を作成(107頁/99頁・未承認)</a:t>
+                        <a:t>0確認マクロの改修と正本への実装(実行ログ自動記録・だれでも実行可能)</a:t>
                       </a:r>
                     </a:p>
                   </a:txBody>
@@ -10567,7 +8158,7 @@
                           <a:latin typeface="Meiryo"/>
                           <a:ea typeface="Meiryo"/>
                         </a:rPr>
-                        <a:t>成果✓</a:t>
+                        <a:t>成果</a:t>
                       </a:r>
                     </a:p>
                   </a:txBody>
@@ -10611,7 +8202,7 @@
                           <a:latin typeface="Meiryo"/>
                           <a:ea typeface="Meiryo"/>
                         </a:rPr>
-                        <a:t>棚卸しマクロver.2の改修完了(テストケース47件)</a:t>
+                        <a:t>鹿島引き込みの計算支援(負荷率計算・集計)とB列差異の対応</a:t>
                       </a:r>
                     </a:p>
                   </a:txBody>
@@ -10655,7 +8246,7 @@
                           <a:latin typeface="Meiryo"/>
                           <a:ea typeface="Meiryo"/>
                         </a:rPr>
-                        <a:t>完了(未検証)</a:t>
+                        <a:t>完了</a:t>
                       </a:r>
                     </a:p>
                   </a:txBody>
@@ -10691,7 +8282,7 @@
                   </a:ext>
                 </a:extLst>
               </a:tr>
-              <a:tr h="400000">
+              <a:tr h="754271">
                 <a:tc>
                   <a:txBody>
                     <a:bodyPr/>
@@ -10708,6 +8299,13 @@
                         </a:rPr>
                         <a:t>01</a:t>
                       </a:r>
+                      <a:endParaRPr lang="en-US" altLang="ja-JP" sz="1600" b="0" dirty="0">
+                        <a:solidFill>
+                          <a:srgbClr val="000000"/>
+                        </a:solidFill>
+                        <a:latin typeface="Meiryo"/>
+                        <a:ea typeface="Meiryo"/>
+                      </a:endParaRPr>
                     </a:p>
                   </a:txBody>
                   <a:tcPr marL="72000" marR="72000" marT="36000" marB="36000" anchor="ctr">
@@ -10750,7 +8348,7 @@
                           <a:latin typeface="Meiryo"/>
                           <a:ea typeface="Meiryo"/>
                         </a:rPr>
-                        <a:t>実機確認の日程と停止判断者を会議で確定</a:t>
+                        <a:t>実機確認の日程と停止判断者の確定、管理手順書の承認</a:t>
                       </a:r>
                     </a:p>
                   </a:txBody>
@@ -10889,7 +8487,7 @@
                           <a:latin typeface="Meiryo"/>
                           <a:ea typeface="Meiryo"/>
                         </a:rPr>
-                        <a:t>管理手順書の承認・相関図と画像の追加・一括バックアップの報告</a:t>
+                        <a:t>相関図と画像の追加</a:t>
                       </a:r>
                     </a:p>
                   </a:txBody>
@@ -10965,7 +8563,7 @@
                 </a:tc>
                 <a:extLst>
                   <a:ext uri="{0D108BD9-81ED-4DB2-BD59-A6C34878D82A}">
-                    <a16:rowId xmlns:a16="http://schemas.microsoft.com/office/drawing/2014/main" val="10004"/>
+                    <a16:rowId xmlns:a16="http://schemas.microsoft.com/office/drawing/2014/main" val="1252980010"/>
                   </a:ext>
                 </a:extLst>
               </a:tr>
@@ -11028,7 +8626,7 @@
                           <a:latin typeface="Meiryo"/>
                           <a:ea typeface="Meiryo"/>
                         </a:rPr>
-                        <a:t>棚卸しマクロver.2の実機検証(4段階)→固定テーブル棚卸しの本番</a:t>
+                        <a:t>セットアップレポート計算機の改修→棚卸しの本番と工数測定</a:t>
                       </a:r>
                     </a:p>
                   </a:txBody>
@@ -11104,7 +8702,7 @@
                 </a:tc>
                 <a:extLst>
                   <a:ext uri="{0D108BD9-81ED-4DB2-BD59-A6C34878D82A}">
-                    <a16:rowId xmlns:a16="http://schemas.microsoft.com/office/drawing/2014/main" val="10004"/>
+                    <a16:rowId xmlns:a16="http://schemas.microsoft.com/office/drawing/2014/main" val="276409638"/>
                   </a:ext>
                 </a:extLst>
               </a:tr>
@@ -11167,7 +8765,7 @@
                           <a:latin typeface="Meiryo"/>
                           <a:ea typeface="Meiryo"/>
                         </a:rPr>
-                        <a:t>0確認マクロの本番実行と確認工数の測定</a:t>
+                        <a:t>管理手順書の初版登録・LNB点検項目の登録</a:t>
                       </a:r>
                     </a:p>
                   </a:txBody>
@@ -11211,7 +8809,7 @@
                           <a:latin typeface="Meiryo"/>
                           <a:ea typeface="Meiryo"/>
                         </a:rPr>
-                        <a:t>10月末</a:t>
+                        <a:t>12月末</a:t>
                       </a:r>
                     </a:p>
                   </a:txBody>
@@ -11243,7 +8841,7 @@
                 </a:tc>
                 <a:extLst>
                   <a:ext uri="{0D108BD9-81ED-4DB2-BD59-A6C34878D82A}">
-                    <a16:rowId xmlns:a16="http://schemas.microsoft.com/office/drawing/2014/main" val="10004"/>
+                    <a16:rowId xmlns:a16="http://schemas.microsoft.com/office/drawing/2014/main" val="2368261508"/>
                   </a:ext>
                 </a:extLst>
               </a:tr>
@@ -11306,7 +8904,7 @@
                           <a:latin typeface="Meiryo"/>
                           <a:ea typeface="Meiryo"/>
                         </a:rPr>
-                        <a:t>LNB点検項目の聞き取りと登録</a:t>
+                        <a:t>鹿島：B列修正の経緯資料化と品目選定システム改修の検討着手</a:t>
                       </a:r>
                     </a:p>
                   </a:txBody>
@@ -11350,7 +8948,7 @@
                           <a:latin typeface="Meiryo"/>
                           <a:ea typeface="Meiryo"/>
                         </a:rPr>
-                        <a:t>12/28まで</a:t>
+                        <a:t>導入時まで</a:t>
                       </a:r>
                     </a:p>
                   </a:txBody>
@@ -11382,7 +8980,7 @@
                 </a:tc>
                 <a:extLst>
                   <a:ext uri="{0D108BD9-81ED-4DB2-BD59-A6C34878D82A}">
-                    <a16:rowId xmlns:a16="http://schemas.microsoft.com/office/drawing/2014/main" val="10004"/>
+                    <a16:rowId xmlns:a16="http://schemas.microsoft.com/office/drawing/2014/main" val="1687008710"/>
                   </a:ext>
                 </a:extLst>
               </a:tr>
@@ -11434,7 +9032,7 @@
                 <a:latin typeface="Meiryo"/>
                 <a:ea typeface="Meiryo"/>
               </a:rPr>
-              <a:t>前回(9/18)の進め方に沿い進捗。在庫確認の条件は手順書へ反映済み(10/15)。</a:t>
+              <a:t>前回(9/18)の進め方に沿い進捗。0確認マクロの正本実装は完了(10/22)。</a:t>
             </a:r>
             <a:endParaRPr lang="en-US" altLang="ja-JP" b="0" dirty="0">
               <a:solidFill>
@@ -11461,34 +9059,7 @@
                 <a:latin typeface="Meiryo"/>
                 <a:ea typeface="Meiryo"/>
               </a:rPr>
-              <a:t>検証と棚卸し本番は10月末(予定どおり)。手順書・仕様書は9月末に更新済み。</a:t>
-            </a:r>
-            <a:endParaRPr lang="en-US" altLang="ja-JP" b="0" dirty="0">
-              <a:solidFill>
-                <a:srgbClr val="000000"/>
-              </a:solidFill>
-              <a:latin typeface="Meiryo"/>
-              <a:ea typeface="Meiryo"/>
-            </a:endParaRPr>
-          </a:p>
-          <a:p>
-            <a:pPr algn="l">
-              <a:lnSpc>
-                <a:spcPct val="112000"/>
-              </a:lnSpc>
-              <a:spcAft>
-                <a:spcPts val="400"/>
-              </a:spcAft>
-            </a:pPr>
-            <a:r>
-              <a:rPr lang="ja-JP" altLang="en-US" b="0" dirty="0">
-                <a:solidFill>
-                  <a:srgbClr val="000000"/>
-                </a:solidFill>
-                <a:latin typeface="Meiryo"/>
-                <a:ea typeface="Meiryo"/>
-              </a:rPr>
-              <a:t>管理手順書の整備は会議方針による追加対応。</a:t>
+              <a:t>棚卸し本番は10月末(予定どおり)。管理手順書の承認を10/28の会議でお願いする。</a:t>
             </a:r>
             <a:endParaRPr lang="en-US" altLang="ja-JP" b="0" dirty="0">
               <a:solidFill>

</xml_diff>

<commit_message>
sync(workvault): 2026-10-23 13:37 差分 4 件
</commit_message>
<xml_diff>
--- a/workvault-sync/10_業務全般/業務報告/9月業務報告(篠原).pptx
+++ b/workvault-sync/10_業務全般/業務報告/9月業務報告(篠原).pptx
@@ -117,75 +117,75 @@
 </p:presentation>
 </file>
 
+<file path=ppt/revisionInfo.xml><?xml version="1.0" encoding="utf-8"?>
+<p1510:revInfo xmlns:a="http://schemas.openxmlformats.org/drawingml/2006/main" xmlns:r="http://schemas.openxmlformats.org/officeDocument/2006/relationships" xmlns:p1510="http://schemas.microsoft.com/office/powerpoint/2015/10/main">
+  <p1510:revLst>
+    <p1510:client id="{3CE6C09F-996B-4A97-8B67-0325D5F79331}" v="7" dt="2026-10-23T02:05:53.291"/>
+  </p1510:revLst>
+</p1510:revInfo>
+</file>
+
 <file path=ppt/changesInfos/changesInfo1.xml><?xml version="1.0" encoding="utf-8"?>
 <pc:chgInfo xmlns:a="http://schemas.openxmlformats.org/drawingml/2006/main" xmlns:r="http://schemas.openxmlformats.org/officeDocument/2006/relationships" xmlns:ac="http://schemas.microsoft.com/office/drawing/2013/main/command" xmlns:pc="http://schemas.microsoft.com/office/powerpoint/2013/main/command">
   <pc:docChgLst>
     <pc:chgData name="SHINOHARA Soshi (篠原 想詩)" userId="309c0b21-8b61-4cd5-9d32-07652c56306e" providerId="ADAL" clId="{60D42A6B-AE32-4A06-B461-AA9486421C3B}"/>
-    <pc:docChg chg="undo custSel addSld delSld modSld sldOrd delMainMaster">
-      <pc:chgData name="SHINOHARA Soshi (篠原 想詩)" userId="309c0b21-8b61-4cd5-9d32-07652c56306e" providerId="ADAL" clId="{60D42A6B-AE32-4A06-B461-AA9486421C3B}" dt="2026-10-22T09:43:08.253" v="2636" actId="1076"/>
+    <pc:docChg chg="mod modSld">
+      <pc:chgData name="SHINOHARA Soshi (篠原 想詩)" userId="309c0b21-8b61-4cd5-9d32-07652c56306e" providerId="ADAL" clId="{60D42A6B-AE32-4A06-B461-AA9486421C3B}" dt="2026-10-23T02:50:58.124" v="70" actId="20577"/>
       <pc:docMkLst>
         <pc:docMk/>
       </pc:docMkLst>
       <pc:sldChg chg="modSp mod">
-        <pc:chgData name="SHINOHARA Soshi (篠原 想詩)" userId="309c0b21-8b61-4cd5-9d32-07652c56306e" providerId="ADAL" clId="{60D42A6B-AE32-4A06-B461-AA9486421C3B}" dt="2026-10-22T09:43:08.253" v="2636" actId="1076"/>
+        <pc:chgData name="SHINOHARA Soshi (篠原 想詩)" userId="309c0b21-8b61-4cd5-9d32-07652c56306e" providerId="ADAL" clId="{60D42A6B-AE32-4A06-B461-AA9486421C3B}" dt="2026-10-23T02:49:54.402" v="28" actId="20577"/>
         <pc:sldMkLst>
           <pc:docMk/>
           <pc:sldMk cId="0" sldId="260"/>
         </pc:sldMkLst>
         <pc:spChg chg="mod">
-          <ac:chgData name="SHINOHARA Soshi (篠原 想詩)" userId="309c0b21-8b61-4cd5-9d32-07652c56306e" providerId="ADAL" clId="{60D42A6B-AE32-4A06-B461-AA9486421C3B}" dt="2026-10-22T09:42:48.204" v="2635" actId="20577"/>
+          <ac:chgData name="SHINOHARA Soshi (篠原 想詩)" userId="309c0b21-8b61-4cd5-9d32-07652c56306e" providerId="ADAL" clId="{60D42A6B-AE32-4A06-B461-AA9486421C3B}" dt="2026-10-23T02:49:54.402" v="28" actId="20577"/>
+          <ac:spMkLst>
+            <pc:docMk/>
+            <pc:sldMk cId="0" sldId="260"/>
+            <ac:spMk id="9" creationId="{286AF094-EB23-DE59-C364-CE66702F5820}"/>
+          </ac:spMkLst>
+        </pc:spChg>
+        <pc:spChg chg="mod">
+          <ac:chgData name="SHINOHARA Soshi (篠原 想詩)" userId="309c0b21-8b61-4cd5-9d32-07652c56306e" providerId="ADAL" clId="{60D42A6B-AE32-4A06-B461-AA9486421C3B}" dt="2026-10-23T02:49:45.328" v="17" actId="6549"/>
           <ac:spMkLst>
             <pc:docMk/>
             <pc:sldMk cId="0" sldId="260"/>
             <ac:spMk id="11" creationId="{9062C9EA-A562-CB3D-30B1-0D2FE45C706F}"/>
           </ac:spMkLst>
         </pc:spChg>
-        <pc:graphicFrameChg chg="mod">
-          <ac:chgData name="SHINOHARA Soshi (篠原 想詩)" userId="309c0b21-8b61-4cd5-9d32-07652c56306e" providerId="ADAL" clId="{60D42A6B-AE32-4A06-B461-AA9486421C3B}" dt="2026-10-22T09:43:08.253" v="2636" actId="1076"/>
-          <ac:graphicFrameMkLst>
-            <pc:docMk/>
-            <pc:sldMk cId="0" sldId="260"/>
-            <ac:graphicFrameMk id="23" creationId="{A1CE0432-81FE-9A98-8528-48DD5FFDE362}"/>
-          </ac:graphicFrameMkLst>
-        </pc:graphicFrameChg>
       </pc:sldChg>
-      <pc:sldChg chg="addSp delSp modSp add mod ord">
-        <pc:chgData name="SHINOHARA Soshi (篠原 想詩)" userId="309c0b21-8b61-4cd5-9d32-07652c56306e" providerId="ADAL" clId="{60D42A6B-AE32-4A06-B461-AA9486421C3B}" dt="2026-10-22T09:39:10.204" v="2589" actId="20577"/>
+      <pc:sldChg chg="modSp mod">
+        <pc:chgData name="SHINOHARA Soshi (篠原 想詩)" userId="309c0b21-8b61-4cd5-9d32-07652c56306e" providerId="ADAL" clId="{60D42A6B-AE32-4A06-B461-AA9486421C3B}" dt="2026-10-23T02:50:58.124" v="70" actId="20577"/>
         <pc:sldMkLst>
           <pc:docMk/>
-          <pc:sldMk cId="147431364" sldId="264"/>
+          <pc:sldMk cId="2460916238" sldId="261"/>
         </pc:sldMkLst>
-        <pc:spChg chg="add mod">
-          <ac:chgData name="SHINOHARA Soshi (篠原 想詩)" userId="309c0b21-8b61-4cd5-9d32-07652c56306e" providerId="ADAL" clId="{60D42A6B-AE32-4A06-B461-AA9486421C3B}" dt="2026-10-22T09:39:01.380" v="2584" actId="14100"/>
+        <pc:spChg chg="mod">
+          <ac:chgData name="SHINOHARA Soshi (篠原 想詩)" userId="309c0b21-8b61-4cd5-9d32-07652c56306e" providerId="ADAL" clId="{60D42A6B-AE32-4A06-B461-AA9486421C3B}" dt="2026-10-23T02:50:58.124" v="70" actId="20577"/>
           <ac:spMkLst>
             <pc:docMk/>
-            <pc:sldMk cId="147431364" sldId="264"/>
-            <ac:spMk id="29" creationId="{0E469F14-DE54-B50C-65FD-4EF61E57F230}"/>
-          </ac:spMkLst>
-        </pc:spChg>
-        <pc:spChg chg="mod">
-          <ac:chgData name="SHINOHARA Soshi (篠原 想詩)" userId="309c0b21-8b61-4cd5-9d32-07652c56306e" providerId="ADAL" clId="{60D42A6B-AE32-4A06-B461-AA9486421C3B}" dt="2026-10-22T09:39:10.204" v="2589" actId="20577"/>
-          <ac:spMkLst>
-            <pc:docMk/>
-            <pc:sldMk cId="147431364" sldId="264"/>
-            <ac:spMk id="21506" creationId="{64226943-6F0D-9B1F-EB98-B1CB9F46A659}"/>
+            <pc:sldMk cId="2460916238" sldId="261"/>
+            <ac:spMk id="9107" creationId="{0E391B8E-AB01-AC75-D1D9-4BA5617A534F}"/>
           </ac:spMkLst>
         </pc:spChg>
       </pc:sldChg>
       <pc:sldChg chg="modSp mod">
-        <pc:chgData name="SHINOHARA Soshi (篠原 想詩)" userId="309c0b21-8b61-4cd5-9d32-07652c56306e" providerId="ADAL" clId="{60D42A6B-AE32-4A06-B461-AA9486421C3B}" dt="2026-10-22T09:42:21.533" v="2631" actId="20577"/>
+        <pc:chgData name="SHINOHARA Soshi (篠原 想詩)" userId="309c0b21-8b61-4cd5-9d32-07652c56306e" providerId="ADAL" clId="{60D42A6B-AE32-4A06-B461-AA9486421C3B}" dt="2026-10-23T02:50:35.276" v="54" actId="20577"/>
         <pc:sldMkLst>
           <pc:docMk/>
-          <pc:sldMk cId="3249971736" sldId="265"/>
+          <pc:sldMk cId="2416652295" sldId="263"/>
         </pc:sldMkLst>
-        <pc:graphicFrameChg chg="modGraphic">
-          <ac:chgData name="SHINOHARA Soshi (篠原 想詩)" userId="309c0b21-8b61-4cd5-9d32-07652c56306e" providerId="ADAL" clId="{60D42A6B-AE32-4A06-B461-AA9486421C3B}" dt="2026-10-22T09:42:21.533" v="2631" actId="20577"/>
-          <ac:graphicFrameMkLst>
+        <pc:spChg chg="mod">
+          <ac:chgData name="SHINOHARA Soshi (篠原 想詩)" userId="309c0b21-8b61-4cd5-9d32-07652c56306e" providerId="ADAL" clId="{60D42A6B-AE32-4A06-B461-AA9486421C3B}" dt="2026-10-23T02:50:35.276" v="54" actId="20577"/>
+          <ac:spMkLst>
             <pc:docMk/>
-            <pc:sldMk cId="3249971736" sldId="265"/>
-            <ac:graphicFrameMk id="8" creationId="{58D35AA5-77A7-64BC-8911-FEFE11A99615}"/>
-          </ac:graphicFrameMkLst>
-        </pc:graphicFrameChg>
+            <pc:sldMk cId="2416652295" sldId="263"/>
+            <ac:spMk id="15" creationId="{CBB4D034-4453-9918-E427-6F3BF26F1E67}"/>
+          </ac:spMkLst>
+        </pc:spChg>
       </pc:sldChg>
     </pc:docChg>
   </pc:docChgLst>
@@ -4605,7 +4605,7 @@
                 <a:latin typeface="Meiryo"/>
                 <a:ea typeface="Meiryo"/>
               </a:rPr>
-              <a:t>結論</a:t>
+              <a:t>報告</a:t>
             </a:r>
           </a:p>
         </p:txBody>
@@ -4681,7 +4681,7 @@
                 <a:latin typeface="Meiryo"/>
                 <a:ea typeface="Meiryo"/>
               </a:rPr>
-              <a:t>棚卸(EGPro-MES差異確認)は上期からの継続テーマ。以降、管理表のテーマ順に報告する。</a:t>
+              <a:t>棚卸(EGPro-MES差異確認)は上期からの継続テーマ。</a:t>
             </a:r>
             <a:endParaRPr lang="en-US" altLang="ja-JP" b="0" dirty="0">
               <a:solidFill>
@@ -4768,7 +4768,7 @@
               </a:spcAft>
             </a:pPr>
             <a:r>
-              <a:rPr lang="ja-JP" altLang="en-US" b="0" dirty="0" sz="1200">
+              <a:rPr lang="ja-JP" altLang="en-US" sz="1200" b="0" dirty="0">
                 <a:solidFill>
                   <a:srgbClr val="000000"/>
                 </a:solidFill>
@@ -4795,14 +4795,14 @@
               </a:spcAft>
             </a:pPr>
             <a:r>
-              <a:rPr lang="ja-JP" altLang="en-US" b="0" dirty="0" sz="1200">
+              <a:rPr lang="ja-JP" altLang="en-US" sz="1200" b="0" dirty="0">
                 <a:solidFill>
                   <a:srgbClr val="000000"/>
                 </a:solidFill>
                 <a:latin typeface="Meiryo"/>
                 <a:ea typeface="Meiryo"/>
               </a:rPr>
-              <a:t>・テーマ2 棚卸のツール改善：10月末に本番</a:t>
+              <a:t>・テーマ2 棚卸のツール改善：来週に本番</a:t>
             </a:r>
             <a:endParaRPr lang="en-US" altLang="ja-JP" b="0" dirty="0">
               <a:solidFill>
@@ -4822,7 +4822,7 @@
               </a:spcAft>
             </a:pPr>
             <a:r>
-              <a:rPr lang="ja-JP" altLang="en-US" b="0" dirty="0" sz="1200">
+              <a:rPr lang="ja-JP" altLang="en-US" sz="1200" b="0" dirty="0">
                 <a:solidFill>
                   <a:srgbClr val="000000"/>
                 </a:solidFill>
@@ -4892,22 +4892,27 @@
       </p:sp>
       <p:pic>
         <p:nvPicPr>
-          <p:cNvPr id="21507" name="IMG_geki" descr="下期キャプチャ.png"/>
+          <p:cNvPr id="21507" name="IMG_geki"/>
           <p:cNvPicPr>
             <a:picLocks noChangeAspect="1"/>
           </p:cNvPicPr>
           <p:nvPr/>
         </p:nvPicPr>
         <p:blipFill>
-          <a:blip r:embed="rId2"/>
-          <a:stretch>
-            <a:fillRect/>
-          </a:stretch>
+          <a:blip r:embed="rId2">
+            <a:extLst>
+              <a:ext uri="{28A0092B-C50C-407E-A947-70E740481C1C}">
+                <a14:useLocalDpi xmlns:a14="http://schemas.microsoft.com/office/drawing/2010/main" val="0"/>
+              </a:ext>
+            </a:extLst>
+          </a:blip>
+          <a:srcRect/>
+          <a:stretch/>
         </p:blipFill>
         <p:spPr>
           <a:xfrm>
-            <a:off x="4160520" y="2907792"/>
-            <a:ext cx="7406640" cy="3695808"/>
+            <a:off x="4177416" y="2914219"/>
+            <a:ext cx="7273456" cy="3624416"/>
           </a:xfrm>
           <a:prstGeom prst="rect">
             <a:avLst/>
@@ -4981,6 +4986,35 @@
           <a:xfrm>
             <a:off x="457200" y="4526280"/>
             <a:ext cx="3474720" cy="1936776"/>
+          </a:xfrm>
+          <a:prstGeom prst="rect">
+            <a:avLst/>
+          </a:prstGeom>
+        </p:spPr>
+      </p:pic>
+      <p:pic>
+        <p:nvPicPr>
+          <p:cNvPr id="5" name="IMG_joki"/>
+          <p:cNvPicPr>
+            <a:picLocks noChangeAspect="1"/>
+          </p:cNvPicPr>
+          <p:nvPr/>
+        </p:nvPicPr>
+        <p:blipFill>
+          <a:blip r:embed="rId4">
+            <a:extLst>
+              <a:ext uri="{28A0092B-C50C-407E-A947-70E740481C1C}">
+                <a14:useLocalDpi xmlns:a14="http://schemas.microsoft.com/office/drawing/2010/main" val="0"/>
+              </a:ext>
+            </a:extLst>
+          </a:blip>
+          <a:srcRect/>
+          <a:stretch/>
+        </p:blipFill>
+        <p:spPr>
+          <a:xfrm>
+            <a:off x="474096" y="4526280"/>
+            <a:ext cx="3474719" cy="1936776"/>
           </a:xfrm>
           <a:prstGeom prst="rect">
             <a:avLst/>
@@ -5269,7 +5303,47 @@
                 <a:latin typeface="Meiryo"/>
                 <a:ea typeface="Meiryo"/>
               </a:rPr>
-              <a:t>・実績：管理手順書案2冊(107頁/99頁)を実物様式どおり作成。文書に載せる図7点も作成済み。</a:t>
+              <a:t>・実績：管理手順書案2冊の作成。文書に載せる図解も作成</a:t>
+            </a:r>
+            <a:r>
+              <a:rPr lang="en-US" altLang="ja-JP" b="0" dirty="0">
+                <a:solidFill>
+                  <a:srgbClr val="000000"/>
+                </a:solidFill>
+                <a:latin typeface="Meiryo"/>
+                <a:ea typeface="Meiryo"/>
+              </a:rPr>
+              <a:t>(</a:t>
+            </a:r>
+            <a:r>
+              <a:rPr lang="ja-JP" altLang="en-US" b="0" dirty="0">
+                <a:solidFill>
+                  <a:srgbClr val="000000"/>
+                </a:solidFill>
+                <a:latin typeface="Meiryo"/>
+                <a:ea typeface="Meiryo"/>
+              </a:rPr>
+              <a:t>進行中</a:t>
+            </a:r>
+            <a:r>
+              <a:rPr lang="en-US" altLang="ja-JP" b="0" dirty="0">
+                <a:solidFill>
+                  <a:srgbClr val="000000"/>
+                </a:solidFill>
+                <a:latin typeface="Meiryo"/>
+                <a:ea typeface="Meiryo"/>
+              </a:rPr>
+              <a:t>)</a:t>
+            </a:r>
+            <a:r>
+              <a:rPr lang="ja-JP" altLang="en-US" b="0" dirty="0">
+                <a:solidFill>
+                  <a:srgbClr val="000000"/>
+                </a:solidFill>
+                <a:latin typeface="Meiryo"/>
+                <a:ea typeface="Meiryo"/>
+              </a:rPr>
+              <a:t>。</a:t>
             </a:r>
             <a:endParaRPr lang="en-US" altLang="ja-JP" b="0" dirty="0">
               <a:solidFill>
@@ -5374,7 +5448,27 @@
                 <a:latin typeface="Meiryo"/>
                 <a:ea typeface="Meiryo"/>
               </a:rPr>
-              <a:t>・10/19の三者レビューと10/21の作成チーム確認に向け、レビュー用の準備を進めた。</a:t>
+              <a:t>・</a:t>
+            </a:r>
+            <a:r>
+              <a:rPr lang="ja-JP" altLang="en-US" dirty="0">
+                <a:solidFill>
+                  <a:srgbClr val="000000"/>
+                </a:solidFill>
+                <a:latin typeface="Meiryo"/>
+                <a:ea typeface="Meiryo"/>
+              </a:rPr>
+              <a:t>隔週行う</a:t>
+            </a:r>
+            <a:r>
+              <a:rPr lang="ja-JP" altLang="en-US" b="0" dirty="0">
+                <a:solidFill>
+                  <a:srgbClr val="000000"/>
+                </a:solidFill>
+                <a:latin typeface="Meiryo"/>
+                <a:ea typeface="Meiryo"/>
+              </a:rPr>
+              <a:t>チーム確認に向け、レビュー用の準備を進めた。</a:t>
             </a:r>
             <a:endParaRPr lang="en-US" altLang="ja-JP" b="0" dirty="0">
               <a:solidFill>
@@ -5401,9 +5495,9 @@
                 <a:latin typeface="Meiryo"/>
                 <a:ea typeface="Meiryo"/>
               </a:rPr>
-              <a:t>・残タスクは図の登録・再起動手順の原文突合・印刷範囲の再設定に絞った。</a:t>
-            </a:r>
-            <a:endParaRPr lang="en-US" altLang="ja-JP" b="0" dirty="0">
+              <a:t>・残タスクは図の登録、システム間の関係性や実際の操作手順、点検項目の確認など。</a:t>
+            </a:r>
+            <a:endParaRPr lang="en-US" altLang="ja-JP" dirty="0">
               <a:solidFill>
                 <a:srgbClr val="000000"/>
               </a:solidFill>
@@ -5457,7 +5551,7 @@
                 <a:latin typeface="Meiryo"/>
                 <a:ea typeface="Meiryo"/>
               </a:rPr>
-              <a:t>数字</a:t>
+              <a:t>内容</a:t>
             </a:r>
           </a:p>
         </p:txBody>
@@ -5506,7 +5600,7 @@
                 <a:latin typeface="Meiryo"/>
                 <a:ea typeface="Meiryo"/>
               </a:rPr>
-              <a:t>・案2冊：107頁/99頁(未承認)。図は相関図・データフロー図など7点。</a:t>
+              <a:t>・案2冊： 図は相関図・データフロー図など。</a:t>
             </a:r>
           </a:p>
           <a:p>
@@ -5526,7 +5620,7 @@
                 <a:latin typeface="Meiryo"/>
                 <a:ea typeface="Meiryo"/>
               </a:rPr>
-              <a:t>・レビュー：10/19(三者)・10/21(作成チーム)。期限：初版登録12月末、LNB点検項目の登録12/28。</a:t>
+              <a:t>・レビュー期限： 初版登録12月末、LNB点検項目の登録12/28。</a:t>
             </a:r>
           </a:p>
           <a:p>
@@ -5713,7 +5807,7 @@
                 <a:latin typeface="Meiryo"/>
                 <a:ea typeface="Meiryo"/>
               </a:rPr>
-              <a:t>実施時期：9〜10月(本番10月末)</a:t>
+              <a:t>実施時期：9〜10月(本番は来週)</a:t>
             </a:r>
           </a:p>
         </p:txBody>
@@ -5732,8 +5826,8 @@
         </p:nvSpPr>
         <p:spPr>
           <a:xfrm>
-            <a:off x="540000" y="1512800"/>
-            <a:ext cx="5040000" cy="288000"/>
+            <a:off x="540000" y="1433594"/>
+            <a:ext cx="6619336" cy="271491"/>
           </a:xfrm>
           <a:prstGeom prst="rect">
             <a:avLst/>
@@ -5762,7 +5856,7 @@
                 <a:latin typeface="Meiryo"/>
                 <a:ea typeface="Meiryo"/>
               </a:rPr>
-              <a:t>前提と0確認マクロとは</a:t>
+              <a:t>前提と0確認マクロ・セットアップレポート計算機について</a:t>
             </a:r>
           </a:p>
         </p:txBody>
@@ -5781,8 +5875,8 @@
         </p:nvSpPr>
         <p:spPr>
           <a:xfrm>
-            <a:off x="756000" y="1813174"/>
-            <a:ext cx="10656000" cy="1119581"/>
+            <a:off x="756000" y="1813175"/>
+            <a:ext cx="10656000" cy="798148"/>
           </a:xfrm>
           <a:prstGeom prst="rect">
             <a:avLst/>
@@ -5811,7 +5905,7 @@
                 <a:latin typeface="Meiryo"/>
                 <a:ea typeface="Meiryo"/>
               </a:rPr>
-              <a:t>・棚卸の手順は既に確立しており、実装要件も充足。</a:t>
+              <a:t>・棚卸の手順で必要になる工程で。</a:t>
             </a:r>
             <a:endParaRPr lang="en-US" altLang="ja-JP" b="0" dirty="0">
               <a:solidFill>
@@ -5838,7 +5932,54 @@
                 <a:latin typeface="Meiryo"/>
                 <a:ea typeface="Meiryo"/>
               </a:rPr>
-              <a:t>・0確認マクロ＝EG-Pro倉庫在庫CSVから、「0確認」で始まり在庫数上限以下の品目を抽出しA列へ書き出すツール。抽出分が在庫ゼロ確認(消し込み)の対象。</a:t>
+              <a:t>・0確認マクロ＝在庫の調整で必要になる確認対象を、倉庫在庫CSVから取り込んで一覧に整えるツール。</a:t>
+            </a:r>
+            <a:endParaRPr lang="en-US" altLang="ja-JP" b="0" dirty="0">
+              <a:solidFill>
+                <a:srgbClr val="000000"/>
+              </a:solidFill>
+              <a:latin typeface="Meiryo"/>
+              <a:ea typeface="Meiryo"/>
+            </a:endParaRPr>
+          </a:p>
+          <a:p>
+            <a:pPr algn="l">
+              <a:lnSpc>
+                <a:spcPct val="112000"/>
+              </a:lnSpc>
+              <a:spcAft>
+                <a:spcPts val="400"/>
+              </a:spcAft>
+            </a:pPr>
+            <a:r>
+              <a:rPr lang="ja-JP" altLang="en-US" dirty="0">
+                <a:solidFill>
+                  <a:srgbClr val="000000"/>
+                </a:solidFill>
+                <a:latin typeface="Meiryo"/>
+                <a:ea typeface="Meiryo"/>
+              </a:rPr>
+              <a:t>・セットアップレポート計算機</a:t>
+            </a:r>
+            <a:r>
+              <a:rPr lang="en-US" altLang="ja-JP" dirty="0">
+                <a:solidFill>
+                  <a:srgbClr val="000000"/>
+                </a:solidFill>
+                <a:latin typeface="Meiryo"/>
+                <a:ea typeface="Meiryo"/>
+              </a:rPr>
+              <a:t>=</a:t>
+            </a:r>
+            <a:r>
+              <a:rPr lang="ja-JP" altLang="en-US" dirty="0">
+                <a:solidFill>
+                  <a:srgbClr val="000000"/>
+                </a:solidFill>
+                <a:latin typeface="Meiryo"/>
+                <a:ea typeface="Meiryo"/>
+              </a:rPr>
+              <a:t>棚卸しで最も重要なツール。</a:t>
             </a:r>
             <a:endParaRPr lang="en-US" altLang="ja-JP" b="0" dirty="0">
               <a:solidFill>
@@ -5943,7 +6084,7 @@
                 <a:latin typeface="Meiryo"/>
                 <a:ea typeface="Meiryo"/>
               </a:rPr>
-              <a:t>・0確認マクロが何かを、現場でも説明できる形に整理。</a:t>
+              <a:t>・0確認マクロの使用方法の確立。</a:t>
             </a:r>
             <a:endParaRPr lang="en-US" altLang="ja-JP" b="0" dirty="0">
               <a:solidFill>
@@ -5970,7 +6111,17 @@
                 <a:latin typeface="Meiryo"/>
                 <a:ea typeface="Meiryo"/>
               </a:rPr>
-              <a:t>・「実行ログ」シートへ件数・内訳を自動記録。取り込みはボタンからだれでも実行可能(既定9)。</a:t>
+              <a:t>・「実行ログ」シートへ件数・内訳を自動記録。取り込みはボタンからだれでも実行可能</a:t>
+            </a:r>
+            <a:r>
+              <a:rPr lang="ja-JP" altLang="en-US" dirty="0">
+                <a:solidFill>
+                  <a:srgbClr val="000000"/>
+                </a:solidFill>
+                <a:latin typeface="Meiryo"/>
+                <a:ea typeface="Meiryo"/>
+              </a:rPr>
+              <a:t>に。</a:t>
             </a:r>
             <a:endParaRPr lang="en-US" altLang="ja-JP" b="0" dirty="0">
               <a:solidFill>
@@ -6010,7 +6161,7 @@
           </a:bodyPr>
           <a:lstStyle/>
           <a:p>
-            <a:pPr algn="l">
+            <a:pPr>
               <a:lnSpc>
                 <a:spcPct val="112000"/>
               </a:lnSpc>
@@ -6026,7 +6177,7 @@
                 <a:latin typeface="Meiryo"/>
                 <a:ea typeface="Meiryo"/>
               </a:rPr>
-              <a:t>数字</a:t>
+              <a:t>内容</a:t>
             </a:r>
           </a:p>
         </p:txBody>
@@ -6135,8 +6286,25 @@
                 <a:latin typeface="Meiryo"/>
                 <a:ea typeface="Meiryo"/>
               </a:rPr>
-              <a:t>→ 次の展開：全体の手順を整備し仕様書を完成。リール消費取消可否の現場確認が前提。本番10月末(合格判断の上)。</a:t>
-            </a:r>
+              <a:t>→ 次の展開：全体の手順を整備し仕様書を完成。リール消費取消可否の現場確認</a:t>
+            </a:r>
+            <a:r>
+              <a:rPr lang="ja-JP" altLang="en-US" b="0">
+                <a:solidFill>
+                  <a:srgbClr val="000000"/>
+                </a:solidFill>
+                <a:latin typeface="Meiryo"/>
+                <a:ea typeface="Meiryo"/>
+              </a:rPr>
+              <a:t>が前提。</a:t>
+            </a:r>
+            <a:endParaRPr lang="ja-JP" altLang="en-US" b="0" dirty="0">
+              <a:solidFill>
+                <a:srgbClr val="000000"/>
+              </a:solidFill>
+              <a:latin typeface="Meiryo"/>
+              <a:ea typeface="Meiryo"/>
+            </a:endParaRPr>
           </a:p>
         </p:txBody>
       </p:sp>
@@ -6504,7 +6672,7 @@
           </a:bodyPr>
           <a:lstStyle/>
           <a:p>
-            <a:pPr algn="l">
+            <a:pPr>
               <a:lnSpc>
                 <a:spcPct val="112000"/>
               </a:lnSpc>
@@ -6520,7 +6688,7 @@
                 <a:latin typeface="Meiryo"/>
                 <a:ea typeface="Meiryo"/>
               </a:rPr>
-              <a:t>数字</a:t>
+              <a:t>内容</a:t>
             </a:r>
           </a:p>
         </p:txBody>
@@ -7429,7 +7597,7 @@
         <p:spPr>
           <a:xfrm>
             <a:off x="756000" y="6231929"/>
-            <a:ext cx="6500000" cy="324000"/>
+            <a:ext cx="10872000" cy="288000"/>
           </a:xfrm>
           <a:prstGeom prst="rect">
             <a:avLst/>
@@ -7458,7 +7626,7 @@
                 <a:latin typeface="Meiryo"/>
                 <a:ea typeface="Meiryo"/>
               </a:rPr>
-              <a:t>→ 次の展開：経緯資料化と品目選定システム改修の検討着手</a:t>
+              <a:t>→ 次の展開：経緯資料化と品目選定システム改修の検討を進め、導入時までにツール面を整える</a:t>
             </a:r>
           </a:p>
         </p:txBody>
@@ -7620,7 +7788,7 @@
                 <a:latin typeface="Meiryo"/>
                 <a:ea typeface="Meiryo"/>
               </a:rPr>
-              <a:t>成果と翌月のアクション</a:t>
+              <a:t>進捗と翌月のアクション</a:t>
             </a:r>
             <a:endParaRPr lang="ja-JP" altLang="en-US" sz="3600" dirty="0">
               <a:solidFill>
@@ -7683,14 +7851,14 @@
           <p:nvPr>
             <p:extLst>
               <p:ext uri="{D42A27DB-BD31-4B8C-83A1-F6EECF244321}">
-                <p14:modId xmlns:p14="http://schemas.microsoft.com/office/powerpoint/2010/main" val="460388436"/>
+                <p14:modId xmlns:p14="http://schemas.microsoft.com/office/powerpoint/2010/main" val="2232919764"/>
               </p:ext>
             </p:extLst>
           </p:nvPr>
         </p:nvGraphicFramePr>
         <p:xfrm>
           <a:off x="272980" y="2128477"/>
-          <a:ext cx="11646040" cy="3954271"/>
+          <a:ext cx="11646040" cy="4113951"/>
         </p:xfrm>
         <a:graphic>
           <a:graphicData uri="http://schemas.openxmlformats.org/drawingml/2006/table">
@@ -7873,7 +8041,7 @@
                           <a:latin typeface="Meiryo"/>
                           <a:ea typeface="Meiryo"/>
                         </a:rPr>
-                        <a:t>成果</a:t>
+                        <a:t>進捗</a:t>
                       </a:r>
                     </a:p>
                   </a:txBody>
@@ -7917,7 +8085,7 @@
                           <a:latin typeface="Meiryo"/>
                           <a:ea typeface="Meiryo"/>
                         </a:rPr>
-                        <a:t>管理手順書案2冊を作成しレビュー段階まで(107頁/99頁・未承認)</a:t>
+                        <a:t>管理手順書案2冊を草案として作成。</a:t>
                       </a:r>
                       <a:endParaRPr lang="en-US" altLang="ja-JP" sz="1600" b="0" dirty="0">
                         <a:solidFill>
@@ -8011,16 +8179,13 @@
                     <a:lstStyle/>
                     <a:p>
                       <a:pPr algn="l"/>
-                      <a:r>
-                        <a:rPr lang="ja-JP" altLang="en-US" sz="1600" b="0" dirty="0">
-                          <a:solidFill>
-                            <a:srgbClr val="000000"/>
-                          </a:solidFill>
-                          <a:latin typeface="Meiryo"/>
-                          <a:ea typeface="Meiryo"/>
-                        </a:rPr>
-                        <a:t>成果</a:t>
-                      </a:r>
+                      <a:endParaRPr lang="ja-JP" altLang="en-US" sz="1600" b="0" dirty="0">
+                        <a:solidFill>
+                          <a:srgbClr val="000000"/>
+                        </a:solidFill>
+                        <a:latin typeface="Meiryo"/>
+                        <a:ea typeface="Meiryo"/>
+                      </a:endParaRPr>
                     </a:p>
                   </a:txBody>
                   <a:tcPr marL="72000" marR="72000" marT="36000" marB="36000" anchor="ctr">
@@ -8063,7 +8228,27 @@
                           <a:latin typeface="Meiryo"/>
                           <a:ea typeface="Meiryo"/>
                         </a:rPr>
-                        <a:t>0確認マクロの改修と正本への実装(実行ログ自動記録・だれでも実行可能)</a:t>
+                        <a:t>0確認マクロの改修と正本への実装</a:t>
+                      </a:r>
+                      <a:endParaRPr lang="en-US" altLang="ja-JP" sz="1600" b="0" dirty="0">
+                        <a:solidFill>
+                          <a:srgbClr val="000000"/>
+                        </a:solidFill>
+                        <a:latin typeface="Meiryo"/>
+                        <a:ea typeface="Meiryo"/>
+                      </a:endParaRPr>
+                    </a:p>
+                    <a:p>
+                      <a:pPr algn="l"/>
+                      <a:r>
+                        <a:rPr lang="ja-JP" altLang="en-US" sz="1600" b="0" dirty="0">
+                          <a:solidFill>
+                            <a:srgbClr val="000000"/>
+                          </a:solidFill>
+                          <a:latin typeface="Meiryo"/>
+                          <a:ea typeface="Meiryo"/>
+                        </a:rPr>
+                        <a:t>(実行ログ自動記録・だれでも実行可能に)</a:t>
                       </a:r>
                     </a:p>
                   </a:txBody>
@@ -8150,16 +8335,13 @@
                     <a:lstStyle/>
                     <a:p>
                       <a:pPr algn="l"/>
-                      <a:r>
-                        <a:rPr lang="ja-JP" altLang="en-US" sz="1600" b="0" dirty="0">
-                          <a:solidFill>
-                            <a:srgbClr val="000000"/>
-                          </a:solidFill>
-                          <a:latin typeface="Meiryo"/>
-                          <a:ea typeface="Meiryo"/>
-                        </a:rPr>
-                        <a:t>成果</a:t>
-                      </a:r>
+                      <a:endParaRPr lang="ja-JP" altLang="en-US" sz="1600" b="0" dirty="0">
+                        <a:solidFill>
+                          <a:srgbClr val="000000"/>
+                        </a:solidFill>
+                        <a:latin typeface="Meiryo"/>
+                        <a:ea typeface="Meiryo"/>
+                      </a:endParaRPr>
                     </a:p>
                   </a:txBody>
                   <a:tcPr marL="72000" marR="72000" marT="36000" marB="36000" anchor="ctr">
@@ -8202,8 +8384,15 @@
                           <a:latin typeface="Meiryo"/>
                           <a:ea typeface="Meiryo"/>
                         </a:rPr>
-                        <a:t>鹿島引き込みの計算支援(負荷率計算・集計)とB列差異の対応</a:t>
+                        <a:t>鹿島引き込み：容量計算ツールの解析と臨時の負荷率計算</a:t>
                       </a:r>
+                      <a:endParaRPr lang="en-US" altLang="ja-JP" sz="1600" b="0" dirty="0">
+                        <a:solidFill>
+                          <a:srgbClr val="000000"/>
+                        </a:solidFill>
+                        <a:latin typeface="Meiryo"/>
+                        <a:ea typeface="Meiryo"/>
+                      </a:endParaRPr>
                     </a:p>
                   </a:txBody>
                   <a:tcPr marL="72000" marR="72000" marT="36000" marB="36000" anchor="ctr">
@@ -8222,10 +8411,14 @@
                         <a:srgbClr val="9B9B9B"/>
                       </a:solidFill>
                     </a:lnT>
-                    <a:lnB w="9525" cap="flat">
-                      <a:solidFill>
-                        <a:srgbClr val="9B9B9B"/>
-                      </a:solidFill>
+                    <a:lnB w="9525" cap="flat" cmpd="sng" algn="ctr">
+                      <a:solidFill>
+                        <a:srgbClr val="9B9B9B"/>
+                      </a:solidFill>
+                      <a:prstDash val="solid"/>
+                      <a:round/>
+                      <a:headEnd type="none" w="med" len="med"/>
+                      <a:tailEnd type="none" w="med" len="med"/>
                     </a:lnB>
                     <a:solidFill>
                       <a:srgbClr val="FFFFFF"/>
@@ -8266,10 +8459,14 @@
                         <a:srgbClr val="9B9B9B"/>
                       </a:solidFill>
                     </a:lnT>
-                    <a:lnB w="9525" cap="flat">
-                      <a:solidFill>
-                        <a:srgbClr val="9B9B9B"/>
-                      </a:solidFill>
+                    <a:lnB w="9525" cap="flat" cmpd="sng" algn="ctr">
+                      <a:solidFill>
+                        <a:srgbClr val="9B9B9B"/>
+                      </a:solidFill>
+                      <a:prstDash val="solid"/>
+                      <a:round/>
+                      <a:headEnd type="none" w="med" len="med"/>
+                      <a:tailEnd type="none" w="med" len="med"/>
                     </a:lnB>
                     <a:solidFill>
                       <a:srgbClr val="FFFFFF"/>
@@ -8289,16 +8486,6 @@
                     <a:lstStyle/>
                     <a:p>
                       <a:pPr algn="l"/>
-                      <a:r>
-                        <a:rPr lang="ja-JP" altLang="en-US" sz="1600" b="0" dirty="0">
-                          <a:solidFill>
-                            <a:srgbClr val="000000"/>
-                          </a:solidFill>
-                          <a:latin typeface="Meiryo"/>
-                          <a:ea typeface="Meiryo"/>
-                        </a:rPr>
-                        <a:t>01</a:t>
-                      </a:r>
                       <a:endParaRPr lang="en-US" altLang="ja-JP" sz="1600" b="0" dirty="0">
                         <a:solidFill>
                           <a:srgbClr val="000000"/>
@@ -8314,149 +8501,14 @@
                         <a:srgbClr val="9B9B9B"/>
                       </a:solidFill>
                     </a:lnL>
-                    <a:lnR w="9525" cap="flat">
-                      <a:solidFill>
-                        <a:srgbClr val="9B9B9B"/>
-                      </a:solidFill>
-                    </a:lnR>
-                    <a:lnT w="9525" cap="flat">
-                      <a:solidFill>
-                        <a:srgbClr val="9B9B9B"/>
-                      </a:solidFill>
-                    </a:lnT>
-                    <a:lnB w="9525" cap="flat">
-                      <a:solidFill>
-                        <a:srgbClr val="9B9B9B"/>
-                      </a:solidFill>
-                    </a:lnB>
-                    <a:solidFill>
-                      <a:srgbClr val="FFFFFF"/>
-                    </a:solidFill>
-                  </a:tcPr>
-                </a:tc>
-                <a:tc>
-                  <a:txBody>
-                    <a:bodyPr/>
-                    <a:lstStyle/>
-                    <a:p>
-                      <a:pPr algn="l"/>
-                      <a:r>
-                        <a:rPr lang="ja-JP" altLang="en-US" sz="1600" b="0" dirty="0">
-                          <a:solidFill>
-                            <a:srgbClr val="000000"/>
-                          </a:solidFill>
-                          <a:latin typeface="Meiryo"/>
-                          <a:ea typeface="Meiryo"/>
-                        </a:rPr>
-                        <a:t>実機確認の日程と停止判断者の確定、管理手順書の承認</a:t>
-                      </a:r>
-                    </a:p>
-                  </a:txBody>
-                  <a:tcPr marL="72000" marR="72000" marT="36000" marB="36000" anchor="ctr">
-                    <a:lnL w="9525" cap="flat">
-                      <a:solidFill>
-                        <a:srgbClr val="9B9B9B"/>
-                      </a:solidFill>
-                    </a:lnL>
-                    <a:lnR w="9525" cap="flat">
-                      <a:solidFill>
-                        <a:srgbClr val="9B9B9B"/>
-                      </a:solidFill>
-                    </a:lnR>
-                    <a:lnT w="9525" cap="flat">
-                      <a:solidFill>
-                        <a:srgbClr val="9B9B9B"/>
-                      </a:solidFill>
-                    </a:lnT>
-                    <a:lnB w="9525" cap="flat">
-                      <a:solidFill>
-                        <a:srgbClr val="9B9B9B"/>
-                      </a:solidFill>
-                    </a:lnB>
-                    <a:solidFill>
-                      <a:srgbClr val="FFFFFF"/>
-                    </a:solidFill>
-                  </a:tcPr>
-                </a:tc>
-                <a:tc>
-                  <a:txBody>
-                    <a:bodyPr/>
-                    <a:lstStyle/>
-                    <a:p>
-                      <a:pPr algn="l"/>
-                      <a:r>
-                        <a:rPr lang="ja-JP" altLang="en-US" sz="1600" b="0" dirty="0">
-                          <a:solidFill>
-                            <a:srgbClr val="000000"/>
-                          </a:solidFill>
-                          <a:latin typeface="Meiryo"/>
-                          <a:ea typeface="Meiryo"/>
-                        </a:rPr>
-                        <a:t>10/28(最優先)</a:t>
-                      </a:r>
-                    </a:p>
-                  </a:txBody>
-                  <a:tcPr marL="72000" marR="72000" marT="36000" marB="36000" anchor="ctr">
-                    <a:lnL w="9525" cap="flat">
-                      <a:solidFill>
-                        <a:srgbClr val="9B9B9B"/>
-                      </a:solidFill>
-                    </a:lnL>
-                    <a:lnR w="9525" cap="flat">
-                      <a:solidFill>
-                        <a:srgbClr val="9B9B9B"/>
-                      </a:solidFill>
-                    </a:lnR>
-                    <a:lnT w="9525" cap="flat">
-                      <a:solidFill>
-                        <a:srgbClr val="9B9B9B"/>
-                      </a:solidFill>
-                    </a:lnT>
-                    <a:lnB w="9525" cap="flat">
-                      <a:solidFill>
-                        <a:srgbClr val="9B9B9B"/>
-                      </a:solidFill>
-                    </a:lnB>
-                    <a:solidFill>
-                      <a:srgbClr val="FFFFFF"/>
-                    </a:solidFill>
-                  </a:tcPr>
-                </a:tc>
-                <a:extLst>
-                  <a:ext uri="{0D108BD9-81ED-4DB2-BD59-A6C34878D82A}">
-                    <a16:rowId xmlns:a16="http://schemas.microsoft.com/office/drawing/2014/main" val="10004"/>
-                  </a:ext>
-                </a:extLst>
-              </a:tr>
-              <a:tr h="400000">
-                <a:tc>
-                  <a:txBody>
-                    <a:bodyPr/>
-                    <a:lstStyle/>
-                    <a:p>
-                      <a:pPr algn="l"/>
-                      <a:r>
-                        <a:rPr lang="ja-JP" altLang="en-US" sz="1600" b="0" dirty="0">
-                          <a:solidFill>
-                            <a:srgbClr val="000000"/>
-                          </a:solidFill>
-                          <a:latin typeface="Meiryo"/>
-                          <a:ea typeface="Meiryo"/>
-                        </a:rPr>
-                        <a:t>02</a:t>
-                      </a:r>
-                    </a:p>
-                  </a:txBody>
-                  <a:tcPr marL="72000" marR="72000" marT="36000" marB="36000" anchor="ctr">
-                    <a:lnL w="9525" cap="flat">
-                      <a:solidFill>
-                        <a:srgbClr val="9B9B9B"/>
-                      </a:solidFill>
-                    </a:lnL>
-                    <a:lnR w="9525" cap="flat">
-                      <a:solidFill>
-                        <a:srgbClr val="9B9B9B"/>
-                      </a:solidFill>
+                    <a:lnR w="9525" cap="flat" cmpd="sng" algn="ctr">
+                      <a:solidFill>
+                        <a:srgbClr val="9B9B9B"/>
+                      </a:solidFill>
+                      <a:prstDash val="solid"/>
+                      <a:round/>
+                      <a:headEnd type="none" w="med" len="med"/>
+                      <a:tailEnd type="none" w="med" len="med"/>
                     </a:lnR>
                     <a:lnT w="9525" cap="flat">
                       <a:solidFill>
@@ -8507,10 +8559,14 @@
                         <a:srgbClr val="9B9B9B"/>
                       </a:solidFill>
                     </a:lnT>
-                    <a:lnB w="9525" cap="flat">
-                      <a:solidFill>
-                        <a:srgbClr val="9B9B9B"/>
-                      </a:solidFill>
+                    <a:lnB w="9525" cap="flat" cmpd="sng" algn="ctr">
+                      <a:solidFill>
+                        <a:srgbClr val="9B9B9B"/>
+                      </a:solidFill>
+                      <a:prstDash val="solid"/>
+                      <a:round/>
+                      <a:headEnd type="none" w="med" len="med"/>
+                      <a:tailEnd type="none" w="med" len="med"/>
                     </a:lnB>
                     <a:solidFill>
                       <a:srgbClr val="FFFFFF"/>
@@ -8551,10 +8607,14 @@
                         <a:srgbClr val="9B9B9B"/>
                       </a:solidFill>
                     </a:lnT>
-                    <a:lnB w="9525" cap="flat">
-                      <a:solidFill>
-                        <a:srgbClr val="9B9B9B"/>
-                      </a:solidFill>
+                    <a:lnB w="9525" cap="flat" cmpd="sng" algn="ctr">
+                      <a:solidFill>
+                        <a:srgbClr val="9B9B9B"/>
+                      </a:solidFill>
+                      <a:prstDash val="solid"/>
+                      <a:round/>
+                      <a:headEnd type="none" w="med" len="med"/>
+                      <a:tailEnd type="none" w="med" len="med"/>
                     </a:lnB>
                     <a:solidFill>
                       <a:srgbClr val="FFFFFF"/>
@@ -8563,7 +8623,7 @@
                 </a:tc>
                 <a:extLst>
                   <a:ext uri="{0D108BD9-81ED-4DB2-BD59-A6C34878D82A}">
-                    <a16:rowId xmlns:a16="http://schemas.microsoft.com/office/drawing/2014/main" val="1252980010"/>
+                    <a16:rowId xmlns:a16="http://schemas.microsoft.com/office/drawing/2014/main" val="10004"/>
                   </a:ext>
                 </a:extLst>
               </a:tr>
@@ -8574,16 +8634,13 @@
                     <a:lstStyle/>
                     <a:p>
                       <a:pPr algn="l"/>
-                      <a:r>
-                        <a:rPr lang="ja-JP" altLang="en-US" sz="1600" b="0" dirty="0">
-                          <a:solidFill>
-                            <a:srgbClr val="000000"/>
-                          </a:solidFill>
-                          <a:latin typeface="Meiryo"/>
-                          <a:ea typeface="Meiryo"/>
-                        </a:rPr>
-                        <a:t>03</a:t>
-                      </a:r>
+                      <a:endParaRPr lang="ja-JP" altLang="en-US" sz="1600" b="0" dirty="0">
+                        <a:solidFill>
+                          <a:srgbClr val="000000"/>
+                        </a:solidFill>
+                        <a:latin typeface="Meiryo"/>
+                        <a:ea typeface="Meiryo"/>
+                      </a:endParaRPr>
                     </a:p>
                   </a:txBody>
                   <a:tcPr marL="72000" marR="72000" marT="36000" marB="36000" anchor="ctr">
@@ -8592,10 +8649,14 @@
                         <a:srgbClr val="9B9B9B"/>
                       </a:solidFill>
                     </a:lnL>
-                    <a:lnR w="9525" cap="flat">
-                      <a:solidFill>
-                        <a:srgbClr val="9B9B9B"/>
-                      </a:solidFill>
+                    <a:lnR w="9525" cap="flat" cmpd="sng" algn="ctr">
+                      <a:solidFill>
+                        <a:srgbClr val="9B9B9B"/>
+                      </a:solidFill>
+                      <a:prstDash val="solid"/>
+                      <a:round/>
+                      <a:headEnd type="none" w="med" len="med"/>
+                      <a:tailEnd type="none" w="med" len="med"/>
                     </a:lnR>
                     <a:lnT w="9525" cap="flat">
                       <a:solidFill>
@@ -8641,10 +8702,14 @@
                         <a:srgbClr val="9B9B9B"/>
                       </a:solidFill>
                     </a:lnR>
-                    <a:lnT w="9525" cap="flat">
-                      <a:solidFill>
-                        <a:srgbClr val="9B9B9B"/>
-                      </a:solidFill>
+                    <a:lnT w="9525" cap="flat" cmpd="sng" algn="ctr">
+                      <a:solidFill>
+                        <a:srgbClr val="9B9B9B"/>
+                      </a:solidFill>
+                      <a:prstDash val="solid"/>
+                      <a:round/>
+                      <a:headEnd type="none" w="med" len="med"/>
+                      <a:tailEnd type="none" w="med" len="med"/>
                     </a:lnT>
                     <a:lnB w="9525" cap="flat">
                       <a:solidFill>
@@ -8670,7 +8735,7 @@
                           <a:latin typeface="Meiryo"/>
                           <a:ea typeface="Meiryo"/>
                         </a:rPr>
-                        <a:t>10月末</a:t>
+                        <a:t>来週</a:t>
                       </a:r>
                     </a:p>
                   </a:txBody>
@@ -8685,10 +8750,14 @@
                         <a:srgbClr val="9B9B9B"/>
                       </a:solidFill>
                     </a:lnR>
-                    <a:lnT w="9525" cap="flat">
-                      <a:solidFill>
-                        <a:srgbClr val="9B9B9B"/>
-                      </a:solidFill>
+                    <a:lnT w="9525" cap="flat" cmpd="sng" algn="ctr">
+                      <a:solidFill>
+                        <a:srgbClr val="9B9B9B"/>
+                      </a:solidFill>
+                      <a:prstDash val="solid"/>
+                      <a:round/>
+                      <a:headEnd type="none" w="med" len="med"/>
+                      <a:tailEnd type="none" w="med" len="med"/>
                     </a:lnT>
                     <a:lnB w="9525" cap="flat">
                       <a:solidFill>
@@ -8702,7 +8771,7 @@
                 </a:tc>
                 <a:extLst>
                   <a:ext uri="{0D108BD9-81ED-4DB2-BD59-A6C34878D82A}">
-                    <a16:rowId xmlns:a16="http://schemas.microsoft.com/office/drawing/2014/main" val="276409638"/>
+                    <a16:rowId xmlns:a16="http://schemas.microsoft.com/office/drawing/2014/main" val="1252980010"/>
                   </a:ext>
                 </a:extLst>
               </a:tr>
@@ -8713,16 +8782,13 @@
                     <a:lstStyle/>
                     <a:p>
                       <a:pPr algn="l"/>
-                      <a:r>
-                        <a:rPr lang="ja-JP" altLang="en-US" sz="1600" b="0" dirty="0">
-                          <a:solidFill>
-                            <a:srgbClr val="000000"/>
-                          </a:solidFill>
-                          <a:latin typeface="Meiryo"/>
-                          <a:ea typeface="Meiryo"/>
-                        </a:rPr>
-                        <a:t>04</a:t>
-                      </a:r>
+                      <a:endParaRPr lang="ja-JP" altLang="en-US" sz="1600" b="0" dirty="0">
+                        <a:solidFill>
+                          <a:srgbClr val="000000"/>
+                        </a:solidFill>
+                        <a:latin typeface="Meiryo"/>
+                        <a:ea typeface="Meiryo"/>
+                      </a:endParaRPr>
                     </a:p>
                   </a:txBody>
                   <a:tcPr marL="72000" marR="72000" marT="36000" marB="36000" anchor="ctr">
@@ -8731,10 +8797,14 @@
                         <a:srgbClr val="9B9B9B"/>
                       </a:solidFill>
                     </a:lnL>
-                    <a:lnR w="9525" cap="flat">
-                      <a:solidFill>
-                        <a:srgbClr val="9B9B9B"/>
-                      </a:solidFill>
+                    <a:lnR w="9525" cap="flat" cmpd="sng" algn="ctr">
+                      <a:solidFill>
+                        <a:srgbClr val="9B9B9B"/>
+                      </a:solidFill>
+                      <a:prstDash val="solid"/>
+                      <a:round/>
+                      <a:headEnd type="none" w="med" len="med"/>
+                      <a:tailEnd type="none" w="med" len="med"/>
                     </a:lnR>
                     <a:lnT w="9525" cap="flat">
                       <a:solidFill>
@@ -8841,7 +8911,7 @@
                 </a:tc>
                 <a:extLst>
                   <a:ext uri="{0D108BD9-81ED-4DB2-BD59-A6C34878D82A}">
-                    <a16:rowId xmlns:a16="http://schemas.microsoft.com/office/drawing/2014/main" val="2368261508"/>
+                    <a16:rowId xmlns:a16="http://schemas.microsoft.com/office/drawing/2014/main" val="276409638"/>
                   </a:ext>
                 </a:extLst>
               </a:tr>
@@ -8852,16 +8922,13 @@
                     <a:lstStyle/>
                     <a:p>
                       <a:pPr algn="l"/>
-                      <a:r>
-                        <a:rPr lang="ja-JP" altLang="en-US" sz="1600" b="0" dirty="0">
-                          <a:solidFill>
-                            <a:srgbClr val="000000"/>
-                          </a:solidFill>
-                          <a:latin typeface="Meiryo"/>
-                          <a:ea typeface="Meiryo"/>
-                        </a:rPr>
-                        <a:t>05</a:t>
-                      </a:r>
+                      <a:endParaRPr lang="ja-JP" altLang="en-US" sz="1600" b="0" dirty="0">
+                        <a:solidFill>
+                          <a:srgbClr val="000000"/>
+                        </a:solidFill>
+                        <a:latin typeface="Meiryo"/>
+                        <a:ea typeface="Meiryo"/>
+                      </a:endParaRPr>
                     </a:p>
                   </a:txBody>
                   <a:tcPr marL="72000" marR="72000" marT="36000" marB="36000" anchor="ctr">
@@ -8870,10 +8937,14 @@
                         <a:srgbClr val="9B9B9B"/>
                       </a:solidFill>
                     </a:lnL>
-                    <a:lnR w="9525" cap="flat">
-                      <a:solidFill>
-                        <a:srgbClr val="9B9B9B"/>
-                      </a:solidFill>
+                    <a:lnR w="9525" cap="flat" cmpd="sng" algn="ctr">
+                      <a:solidFill>
+                        <a:srgbClr val="9B9B9B"/>
+                      </a:solidFill>
+                      <a:prstDash val="solid"/>
+                      <a:round/>
+                      <a:headEnd type="none" w="med" len="med"/>
+                      <a:tailEnd type="none" w="med" len="med"/>
                     </a:lnR>
                     <a:lnT w="9525" cap="flat">
                       <a:solidFill>
@@ -8967,6 +9038,144 @@
                       <a:solidFill>
                         <a:srgbClr val="9B9B9B"/>
                       </a:solidFill>
+                    </a:lnT>
+                    <a:lnB w="9525" cap="flat">
+                      <a:solidFill>
+                        <a:srgbClr val="9B9B9B"/>
+                      </a:solidFill>
+                    </a:lnB>
+                    <a:solidFill>
+                      <a:srgbClr val="FFFFFF"/>
+                    </a:solidFill>
+                  </a:tcPr>
+                </a:tc>
+                <a:extLst>
+                  <a:ext uri="{0D108BD9-81ED-4DB2-BD59-A6C34878D82A}">
+                    <a16:rowId xmlns:a16="http://schemas.microsoft.com/office/drawing/2014/main" val="2368261508"/>
+                  </a:ext>
+                </a:extLst>
+              </a:tr>
+              <a:tr h="400000">
+                <a:tc>
+                  <a:txBody>
+                    <a:bodyPr/>
+                    <a:lstStyle/>
+                    <a:p>
+                      <a:pPr algn="l"/>
+                      <a:endParaRPr lang="ja-JP" altLang="en-US" sz="1600" b="0" dirty="0">
+                        <a:solidFill>
+                          <a:srgbClr val="000000"/>
+                        </a:solidFill>
+                        <a:latin typeface="Meiryo"/>
+                        <a:ea typeface="Meiryo"/>
+                      </a:endParaRPr>
+                    </a:p>
+                  </a:txBody>
+                  <a:tcPr marL="72000" marR="72000" marT="36000" marB="36000" anchor="ctr">
+                    <a:lnL w="9525" cap="flat">
+                      <a:solidFill>
+                        <a:srgbClr val="9B9B9B"/>
+                      </a:solidFill>
+                    </a:lnL>
+                    <a:lnR w="9525" cap="flat">
+                      <a:solidFill>
+                        <a:srgbClr val="9B9B9B"/>
+                      </a:solidFill>
+                    </a:lnR>
+                    <a:lnT w="9525" cap="flat">
+                      <a:solidFill>
+                        <a:srgbClr val="9B9B9B"/>
+                      </a:solidFill>
+                    </a:lnT>
+                    <a:lnB w="9525" cap="flat">
+                      <a:solidFill>
+                        <a:srgbClr val="9B9B9B"/>
+                      </a:solidFill>
+                    </a:lnB>
+                    <a:solidFill>
+                      <a:srgbClr val="FFFFFF"/>
+                    </a:solidFill>
+                  </a:tcPr>
+                </a:tc>
+                <a:tc>
+                  <a:txBody>
+                    <a:bodyPr/>
+                    <a:lstStyle/>
+                    <a:p>
+                      <a:pPr algn="l"/>
+                      <a:endParaRPr lang="ja-JP" altLang="en-US" sz="1600" b="0" dirty="0">
+                        <a:solidFill>
+                          <a:srgbClr val="000000"/>
+                        </a:solidFill>
+                        <a:latin typeface="Meiryo"/>
+                        <a:ea typeface="Meiryo"/>
+                      </a:endParaRPr>
+                    </a:p>
+                  </a:txBody>
+                  <a:tcPr marL="72000" marR="72000" marT="36000" marB="36000" anchor="ctr">
+                    <a:lnL w="9525" cap="flat">
+                      <a:solidFill>
+                        <a:srgbClr val="9B9B9B"/>
+                      </a:solidFill>
+                    </a:lnL>
+                    <a:lnR w="9525" cap="flat">
+                      <a:solidFill>
+                        <a:srgbClr val="9B9B9B"/>
+                      </a:solidFill>
+                    </a:lnR>
+                    <a:lnT w="9525" cap="flat" cmpd="sng" algn="ctr">
+                      <a:solidFill>
+                        <a:srgbClr val="9B9B9B"/>
+                      </a:solidFill>
+                      <a:prstDash val="solid"/>
+                      <a:round/>
+                      <a:headEnd type="none" w="med" len="med"/>
+                      <a:tailEnd type="none" w="med" len="med"/>
+                    </a:lnT>
+                    <a:lnB w="9525" cap="flat">
+                      <a:solidFill>
+                        <a:srgbClr val="9B9B9B"/>
+                      </a:solidFill>
+                    </a:lnB>
+                    <a:solidFill>
+                      <a:srgbClr val="FFFFFF"/>
+                    </a:solidFill>
+                  </a:tcPr>
+                </a:tc>
+                <a:tc>
+                  <a:txBody>
+                    <a:bodyPr/>
+                    <a:lstStyle/>
+                    <a:p>
+                      <a:pPr algn="l"/>
+                      <a:endParaRPr lang="ja-JP" altLang="en-US" sz="1600" b="0" dirty="0">
+                        <a:solidFill>
+                          <a:srgbClr val="000000"/>
+                        </a:solidFill>
+                        <a:latin typeface="Meiryo"/>
+                        <a:ea typeface="Meiryo"/>
+                      </a:endParaRPr>
+                    </a:p>
+                  </a:txBody>
+                  <a:tcPr marL="72000" marR="72000" marT="36000" marB="36000" anchor="ctr">
+                    <a:lnL w="9525" cap="flat">
+                      <a:solidFill>
+                        <a:srgbClr val="9B9B9B"/>
+                      </a:solidFill>
+                    </a:lnL>
+                    <a:lnR w="9525" cap="flat">
+                      <a:solidFill>
+                        <a:srgbClr val="9B9B9B"/>
+                      </a:solidFill>
+                    </a:lnR>
+                    <a:lnT w="9525" cap="flat" cmpd="sng" algn="ctr">
+                      <a:solidFill>
+                        <a:srgbClr val="9B9B9B"/>
+                      </a:solidFill>
+                      <a:prstDash val="solid"/>
+                      <a:round/>
+                      <a:headEnd type="none" w="med" len="med"/>
+                      <a:tailEnd type="none" w="med" len="med"/>
                     </a:lnT>
                     <a:lnB w="9525" cap="flat">
                       <a:solidFill>
@@ -9032,7 +9241,7 @@
                 <a:latin typeface="Meiryo"/>
                 <a:ea typeface="Meiryo"/>
               </a:rPr>
-              <a:t>前回(9/18)の進め方に沿い進捗。0確認マクロの正本実装は完了(10/22)。</a:t>
+              <a:t>前回(9/18)の進め方に沿い進捗。</a:t>
             </a:r>
             <a:endParaRPr lang="en-US" altLang="ja-JP" b="0" dirty="0">
               <a:solidFill>
@@ -9059,7 +9268,7 @@
                 <a:latin typeface="Meiryo"/>
                 <a:ea typeface="Meiryo"/>
               </a:rPr>
-              <a:t>棚卸し本番は10月末(予定どおり)。管理手順書の承認を10/28の会議でお願いする。</a:t>
+              <a:t>棚卸し本番は来週(予定どおり)。</a:t>
             </a:r>
             <a:endParaRPr lang="en-US" altLang="ja-JP" b="0" dirty="0">
               <a:solidFill>

</xml_diff>